<commit_message>
Dzhigan v2: replace icons with photos and memes
Photos from Wikimedia Commons (CC BY-SA 4.0), credited on slides.

Co-Authored-By: Claude Opus 5.5 <noreply@anthropic.com>
Claude-Session: https://claude.ai/code/session_01ESKVy2aSLgHDCNezBhnSbq
</commit_message>
<xml_diff>
--- a/Dzhigan_v2.pptx
+++ b/Dzhigan_v2.pptx
@@ -1685,7 +1685,7 @@
         <p:spPr>
           <a:xfrm>
             <a:off x="548640" y="411480"/>
-            <a:ext cx="5486400" cy="274320"/>
+            <a:ext cx="4572000" cy="274320"/>
           </a:xfrm>
           <a:prstGeom prst="rect">
             <a:avLst/>
@@ -1715,55 +1715,101 @@
           </a:p>
         </p:txBody>
       </p:sp>
-      <p:sp>
-        <p:nvSpPr>
-          <p:cNvPr id="3" name="Text 1"/>
-          <p:cNvSpPr txBox="1"/>
-          <p:nvPr/>
-        </p:nvSpPr>
-        <p:spPr>
-          <a:xfrm>
-            <a:off x="3840480" y="1828800"/>
-            <a:ext cx="5120640" cy="2926080"/>
-          </a:xfrm>
-          <a:prstGeom prst="rect">
-            <a:avLst/>
-          </a:prstGeom>
-          <a:noFill/>
-          <a:ln/>
-        </p:spPr>
-        <p:txBody>
-          <a:bodyPr wrap="square" lIns="0" tIns="0" rIns="0" bIns="0" rtlCol="0" anchor="b"/>
+      <p:pic>
+        <p:nvPicPr>
+          <p:cNvPr id="3" name="Image 0" descr="Джиган на VK Fest 2025">    </p:cNvPr>
+          <p:cNvPicPr>
+            <a:picLocks noChangeAspect="1"/>
+          </p:cNvPicPr>
+          <p:nvPr/>
+        </p:nvPicPr>
+        <p:blipFill>
+          <a:blip r:embed="rId1"/>
+          <a:stretch>
+            <a:fillRect/>
+          </a:stretch>
+        </p:blipFill>
+        <p:spPr>
+          <a:xfrm>
+            <a:off x="5486400" y="0"/>
+            <a:ext cx="3657600" cy="5143500"/>
+          </a:xfrm>
+          <a:prstGeom prst="rect">
+            <a:avLst/>
+          </a:prstGeom>
+        </p:spPr>
+      </p:pic>
+      <p:sp>
+        <p:nvSpPr>
+          <p:cNvPr id="4" name="Shape 1"/>
+          <p:cNvSpPr/>
+          <p:nvPr/>
+        </p:nvSpPr>
+        <p:spPr>
+          <a:xfrm>
+            <a:off x="5486400" y="4869180"/>
+            <a:ext cx="3657600" cy="274320"/>
+          </a:xfrm>
+          <a:prstGeom prst="rect">
+            <a:avLst/>
+          </a:prstGeom>
+          <a:solidFill>
+            <a:srgbClr val="000000">
+              <a:alpha val="55000"/>
+            </a:srgbClr>
+          </a:solidFill>
+          <a:ln/>
+        </p:spPr>
+      </p:sp>
+      <p:sp>
+        <p:nvSpPr>
+          <p:cNvPr id="5" name="Text 2"/>
+          <p:cNvSpPr txBox="1"/>
+          <p:nvPr/>
+        </p:nvSpPr>
+        <p:spPr>
+          <a:xfrm>
+            <a:off x="5623560" y="4869180"/>
+            <a:ext cx="3383280" cy="274320"/>
+          </a:xfrm>
+          <a:prstGeom prst="rect">
+            <a:avLst/>
+          </a:prstGeom>
+          <a:noFill/>
+          <a:ln/>
+        </p:spPr>
+        <p:txBody>
+          <a:bodyPr wrap="square" lIns="0" tIns="0" rIns="0" bIns="0" rtlCol="0" anchor="ctr"/>
           <a:lstStyle/>
           <a:p>
             <a:pPr algn="r" indent="0" marL="0">
               <a:buNone/>
             </a:pPr>
             <a:r>
-              <a:rPr lang="en-US" sz="15000" b="1" dirty="0">
-                <a:solidFill>
-                  <a:srgbClr val="17171F"/>
-                </a:solidFill>
-                <a:latin typeface="Arial" pitchFamily="34" charset="0"/>
-                <a:ea typeface="Arial" pitchFamily="34" charset="-122"/>
-                <a:cs typeface="Arial" pitchFamily="34" charset="-120"/>
-              </a:rPr>
-              <a:t>20</a:t>
-            </a:r>
-            <a:endParaRPr lang="en-US" sz="15000" dirty="0"/>
-          </a:p>
-        </p:txBody>
-      </p:sp>
-      <p:sp>
-        <p:nvSpPr>
-          <p:cNvPr id="4" name="Text 2"/>
+              <a:rPr lang="en-US" sz="700" dirty="0">
+                <a:solidFill>
+                  <a:srgbClr val="E6E6EC"/>
+                </a:solidFill>
+                <a:latin typeface="Arial" pitchFamily="34" charset="0"/>
+                <a:ea typeface="Arial" pitchFamily="34" charset="-122"/>
+                <a:cs typeface="Arial" pitchFamily="34" charset="-120"/>
+              </a:rPr>
+              <a:t>Фото: Okras, CC BY-SA 4.0</a:t>
+            </a:r>
+            <a:endParaRPr lang="en-US" sz="700" dirty="0"/>
+          </a:p>
+        </p:txBody>
+      </p:sp>
+      <p:sp>
+        <p:nvSpPr>
+          <p:cNvPr id="6" name="Text 3"/>
           <p:cNvSpPr txBox="1"/>
           <p:nvPr/>
         </p:nvSpPr>
         <p:spPr>
           <a:xfrm>
             <a:off x="548640" y="1417320"/>
-            <a:ext cx="7315200" cy="1097280"/>
+            <a:ext cx="4754880" cy="1097280"/>
           </a:xfrm>
           <a:prstGeom prst="rect">
             <a:avLst/>
@@ -1795,14 +1841,14 @@
       </p:sp>
       <p:sp>
         <p:nvSpPr>
-          <p:cNvPr id="5" name="Text 3"/>
+          <p:cNvPr id="7" name="Text 4"/>
           <p:cNvSpPr txBox="1"/>
           <p:nvPr/>
         </p:nvSpPr>
         <p:spPr>
           <a:xfrm>
             <a:off x="548640" y="2560320"/>
-            <a:ext cx="5486400" cy="822960"/>
+            <a:ext cx="4754880" cy="822960"/>
           </a:xfrm>
           <a:prstGeom prst="rect">
             <a:avLst/>
@@ -1851,7 +1897,7 @@
       </p:sp>
       <p:sp>
         <p:nvSpPr>
-          <p:cNvPr id="6" name="Shape 4"/>
+          <p:cNvPr id="8" name="Shape 5"/>
           <p:cNvSpPr/>
           <p:nvPr/>
         </p:nvSpPr>
@@ -1878,7 +1924,7 @@
       </p:sp>
       <p:sp>
         <p:nvSpPr>
-          <p:cNvPr id="7" name="Text 5"/>
+          <p:cNvPr id="9" name="Text 6"/>
           <p:cNvSpPr txBox="1"/>
           <p:nvPr/>
         </p:nvSpPr>
@@ -1917,7 +1963,7 @@
       </p:sp>
       <p:sp>
         <p:nvSpPr>
-          <p:cNvPr id="8" name="Shape 6"/>
+          <p:cNvPr id="10" name="Shape 7"/>
           <p:cNvSpPr/>
           <p:nvPr/>
         </p:nvSpPr>
@@ -1944,7 +1990,7 @@
       </p:sp>
       <p:sp>
         <p:nvSpPr>
-          <p:cNvPr id="9" name="Text 7"/>
+          <p:cNvPr id="11" name="Text 8"/>
           <p:cNvSpPr txBox="1"/>
           <p:nvPr/>
         </p:nvSpPr>
@@ -2022,7 +2068,7 @@
         <p:spPr>
           <a:xfrm>
             <a:off x="548640" y="411480"/>
-            <a:ext cx="5486400" cy="274320"/>
+            <a:ext cx="4572000" cy="274320"/>
           </a:xfrm>
           <a:prstGeom prst="rect">
             <a:avLst/>
@@ -2055,45 +2101,6 @@
       <p:sp>
         <p:nvSpPr>
           <p:cNvPr id="3" name="Text 1"/>
-          <p:cNvSpPr txBox="1"/>
-          <p:nvPr/>
-        </p:nvSpPr>
-        <p:spPr>
-          <a:xfrm>
-            <a:off x="7680960" y="4663440"/>
-            <a:ext cx="914400" cy="228600"/>
-          </a:xfrm>
-          <a:prstGeom prst="rect">
-            <a:avLst/>
-          </a:prstGeom>
-          <a:noFill/>
-          <a:ln/>
-        </p:spPr>
-        <p:txBody>
-          <a:bodyPr wrap="square" lIns="0" tIns="0" rIns="0" bIns="0" rtlCol="0" anchor="ctr"/>
-          <a:lstStyle/>
-          <a:p>
-            <a:pPr algn="r" indent="0" marL="0">
-              <a:buNone/>
-            </a:pPr>
-            <a:r>
-              <a:rPr lang="en-US" sz="900" dirty="0">
-                <a:solidFill>
-                  <a:srgbClr val="8E8E9C"/>
-                </a:solidFill>
-                <a:latin typeface="Arial" pitchFamily="34" charset="0"/>
-                <a:ea typeface="Arial" pitchFamily="34" charset="-122"/>
-                <a:cs typeface="Arial" pitchFamily="34" charset="-120"/>
-              </a:rPr>
-              <a:t>10 / 10</a:t>
-            </a:r>
-            <a:endParaRPr lang="en-US" sz="900" dirty="0"/>
-          </a:p>
-        </p:txBody>
-      </p:sp>
-      <p:sp>
-        <p:nvSpPr>
-          <p:cNvPr id="4" name="Text 2"/>
           <p:cNvSpPr txBox="1"/>
           <p:nvPr/>
         </p:nvSpPr>
@@ -2132,7 +2139,7 @@
       </p:sp>
       <p:sp>
         <p:nvSpPr>
-          <p:cNvPr id="5" name="Shape 3"/>
+          <p:cNvPr id="4" name="Shape 2"/>
           <p:cNvSpPr/>
           <p:nvPr/>
         </p:nvSpPr>
@@ -2155,7 +2162,7 @@
       </p:sp>
       <p:sp>
         <p:nvSpPr>
-          <p:cNvPr id="6" name="Shape 4"/>
+          <p:cNvPr id="5" name="Shape 3"/>
           <p:cNvSpPr/>
           <p:nvPr/>
         </p:nvSpPr>
@@ -2180,7 +2187,7 @@
       </p:sp>
       <p:sp>
         <p:nvSpPr>
-          <p:cNvPr id="7" name="Text 5"/>
+          <p:cNvPr id="6" name="Text 4"/>
           <p:cNvSpPr txBox="1"/>
           <p:nvPr/>
         </p:nvSpPr>
@@ -2219,7 +2226,7 @@
       </p:sp>
       <p:sp>
         <p:nvSpPr>
-          <p:cNvPr id="8" name="Text 6"/>
+          <p:cNvPr id="7" name="Text 5"/>
           <p:cNvSpPr txBox="1"/>
           <p:nvPr/>
         </p:nvSpPr>
@@ -2258,7 +2265,7 @@
       </p:sp>
       <p:sp>
         <p:nvSpPr>
-          <p:cNvPr id="9" name="Shape 7"/>
+          <p:cNvPr id="8" name="Shape 6"/>
           <p:cNvSpPr/>
           <p:nvPr/>
         </p:nvSpPr>
@@ -2283,7 +2290,7 @@
       </p:sp>
       <p:sp>
         <p:nvSpPr>
-          <p:cNvPr id="10" name="Text 8"/>
+          <p:cNvPr id="9" name="Text 7"/>
           <p:cNvSpPr txBox="1"/>
           <p:nvPr/>
         </p:nvSpPr>
@@ -2322,7 +2329,7 @@
       </p:sp>
       <p:sp>
         <p:nvSpPr>
-          <p:cNvPr id="11" name="Text 9"/>
+          <p:cNvPr id="10" name="Text 8"/>
           <p:cNvSpPr txBox="1"/>
           <p:nvPr/>
         </p:nvSpPr>
@@ -2361,7 +2368,7 @@
       </p:sp>
       <p:sp>
         <p:nvSpPr>
-          <p:cNvPr id="12" name="Shape 10"/>
+          <p:cNvPr id="11" name="Shape 9"/>
           <p:cNvSpPr/>
           <p:nvPr/>
         </p:nvSpPr>
@@ -2386,7 +2393,7 @@
       </p:sp>
       <p:sp>
         <p:nvSpPr>
-          <p:cNvPr id="13" name="Text 11"/>
+          <p:cNvPr id="12" name="Text 10"/>
           <p:cNvSpPr txBox="1"/>
           <p:nvPr/>
         </p:nvSpPr>
@@ -2425,7 +2432,7 @@
       </p:sp>
       <p:sp>
         <p:nvSpPr>
-          <p:cNvPr id="14" name="Text 12"/>
+          <p:cNvPr id="13" name="Text 11"/>
           <p:cNvSpPr txBox="1"/>
           <p:nvPr/>
         </p:nvSpPr>
@@ -2464,7 +2471,7 @@
       </p:sp>
       <p:sp>
         <p:nvSpPr>
-          <p:cNvPr id="15" name="Shape 13"/>
+          <p:cNvPr id="14" name="Shape 12"/>
           <p:cNvSpPr/>
           <p:nvPr/>
         </p:nvSpPr>
@@ -2489,7 +2496,7 @@
       </p:sp>
       <p:sp>
         <p:nvSpPr>
-          <p:cNvPr id="16" name="Text 14"/>
+          <p:cNvPr id="15" name="Text 13"/>
           <p:cNvSpPr txBox="1"/>
           <p:nvPr/>
         </p:nvSpPr>
@@ -2528,7 +2535,7 @@
       </p:sp>
       <p:sp>
         <p:nvSpPr>
-          <p:cNvPr id="17" name="Text 15"/>
+          <p:cNvPr id="16" name="Text 14"/>
           <p:cNvSpPr txBox="1"/>
           <p:nvPr/>
         </p:nvSpPr>
@@ -2567,7 +2574,7 @@
       </p:sp>
       <p:sp>
         <p:nvSpPr>
-          <p:cNvPr id="18" name="Shape 16"/>
+          <p:cNvPr id="17" name="Shape 15"/>
           <p:cNvSpPr/>
           <p:nvPr/>
         </p:nvSpPr>
@@ -2592,7 +2599,7 @@
       </p:sp>
       <p:sp>
         <p:nvSpPr>
-          <p:cNvPr id="19" name="Text 17"/>
+          <p:cNvPr id="18" name="Text 16"/>
           <p:cNvSpPr txBox="1"/>
           <p:nvPr/>
         </p:nvSpPr>
@@ -2631,7 +2638,7 @@
       </p:sp>
       <p:sp>
         <p:nvSpPr>
-          <p:cNvPr id="20" name="Text 18"/>
+          <p:cNvPr id="19" name="Text 17"/>
           <p:cNvSpPr txBox="1"/>
           <p:nvPr/>
         </p:nvSpPr>
@@ -2670,7 +2677,7 @@
       </p:sp>
       <p:sp>
         <p:nvSpPr>
-          <p:cNvPr id="21" name="Text 19"/>
+          <p:cNvPr id="20" name="Text 18"/>
           <p:cNvSpPr txBox="1"/>
           <p:nvPr/>
         </p:nvSpPr>
@@ -2704,6 +2711,45 @@
               <a:t>Спасибо за внимание!</a:t>
             </a:r>
             <a:endParaRPr lang="en-US" sz="2800" dirty="0"/>
+          </a:p>
+        </p:txBody>
+      </p:sp>
+      <p:sp>
+        <p:nvSpPr>
+          <p:cNvPr id="21" name="Text 19"/>
+          <p:cNvSpPr txBox="1"/>
+          <p:nvPr/>
+        </p:nvSpPr>
+        <p:spPr>
+          <a:xfrm>
+            <a:off x="7680960" y="4663440"/>
+            <a:ext cx="914400" cy="228600"/>
+          </a:xfrm>
+          <a:prstGeom prst="rect">
+            <a:avLst/>
+          </a:prstGeom>
+          <a:noFill/>
+          <a:ln/>
+        </p:spPr>
+        <p:txBody>
+          <a:bodyPr wrap="square" lIns="0" tIns="0" rIns="0" bIns="0" rtlCol="0" anchor="ctr"/>
+          <a:lstStyle/>
+          <a:p>
+            <a:pPr algn="r" indent="0" marL="0">
+              <a:buNone/>
+            </a:pPr>
+            <a:r>
+              <a:rPr lang="en-US" sz="900" dirty="0">
+                <a:solidFill>
+                  <a:srgbClr val="8E8E9C"/>
+                </a:solidFill>
+                <a:latin typeface="Arial" pitchFamily="34" charset="0"/>
+                <a:ea typeface="Arial" pitchFamily="34" charset="-122"/>
+                <a:cs typeface="Arial" pitchFamily="34" charset="-120"/>
+              </a:rPr>
+              <a:t>10 / 10</a:t>
+            </a:r>
+            <a:endParaRPr lang="en-US" sz="900" dirty="0"/>
           </a:p>
         </p:txBody>
       </p:sp>
@@ -2747,8 +2793,8 @@
         </p:nvSpPr>
         <p:spPr>
           <a:xfrm>
-            <a:off x="548640" y="411480"/>
-            <a:ext cx="5486400" cy="274320"/>
+            <a:off x="3749040" y="411480"/>
+            <a:ext cx="4572000" cy="274320"/>
           </a:xfrm>
           <a:prstGeom prst="rect">
             <a:avLst/>
@@ -2777,169 +2823,10 @@
             <a:endParaRPr lang="en-US" sz="1000" dirty="0"/>
           </a:p>
         </p:txBody>
-      </p:sp>
-      <p:sp>
-        <p:nvSpPr>
-          <p:cNvPr id="3" name="Text 1"/>
-          <p:cNvSpPr txBox="1"/>
-          <p:nvPr/>
-        </p:nvSpPr>
-        <p:spPr>
-          <a:xfrm>
-            <a:off x="7680960" y="4663440"/>
-            <a:ext cx="914400" cy="228600"/>
-          </a:xfrm>
-          <a:prstGeom prst="rect">
-            <a:avLst/>
-          </a:prstGeom>
-          <a:noFill/>
-          <a:ln/>
-        </p:spPr>
-        <p:txBody>
-          <a:bodyPr wrap="square" lIns="0" tIns="0" rIns="0" bIns="0" rtlCol="0" anchor="ctr"/>
-          <a:lstStyle/>
-          <a:p>
-            <a:pPr algn="r" indent="0" marL="0">
-              <a:buNone/>
-            </a:pPr>
-            <a:r>
-              <a:rPr lang="en-US" sz="900" dirty="0">
-                <a:solidFill>
-                  <a:srgbClr val="8E8E9C"/>
-                </a:solidFill>
-                <a:latin typeface="Arial" pitchFamily="34" charset="0"/>
-                <a:ea typeface="Arial" pitchFamily="34" charset="-122"/>
-                <a:cs typeface="Arial" pitchFamily="34" charset="-120"/>
-              </a:rPr>
-              <a:t>02 / 10</a:t>
-            </a:r>
-            <a:endParaRPr lang="en-US" sz="900" dirty="0"/>
-          </a:p>
-        </p:txBody>
-      </p:sp>
-      <p:sp>
-        <p:nvSpPr>
-          <p:cNvPr id="4" name="Text 2"/>
-          <p:cNvSpPr txBox="1"/>
-          <p:nvPr/>
-        </p:nvSpPr>
-        <p:spPr>
-          <a:xfrm>
-            <a:off x="548640" y="731520"/>
-            <a:ext cx="8046720" cy="822960"/>
-          </a:xfrm>
-          <a:prstGeom prst="rect">
-            <a:avLst/>
-          </a:prstGeom>
-          <a:noFill/>
-          <a:ln/>
-        </p:spPr>
-        <p:txBody>
-          <a:bodyPr wrap="square" lIns="0" tIns="0" rIns="0" bIns="0" rtlCol="0" anchor="t"/>
-          <a:lstStyle/>
-          <a:p>
-            <a:pPr indent="0" marL="0">
-              <a:buNone/>
-            </a:pPr>
-            <a:r>
-              <a:rPr lang="en-US" sz="3400" b="1" dirty="0">
-                <a:solidFill>
-                  <a:srgbClr val="F4F4F6"/>
-                </a:solidFill>
-                <a:latin typeface="Arial" pitchFamily="34" charset="0"/>
-                <a:ea typeface="Arial" pitchFamily="34" charset="-122"/>
-                <a:cs typeface="Arial" pitchFamily="34" charset="-120"/>
-              </a:rPr>
-              <a:t>Денис Устименко-Вайнштейн</a:t>
-            </a:r>
-            <a:endParaRPr lang="en-US" sz="3400" dirty="0"/>
-          </a:p>
-        </p:txBody>
-      </p:sp>
-      <p:sp>
-        <p:nvSpPr>
-          <p:cNvPr id="5" name="Text 3"/>
-          <p:cNvSpPr txBox="1"/>
-          <p:nvPr/>
-        </p:nvSpPr>
-        <p:spPr>
-          <a:xfrm>
-            <a:off x="548640" y="1737360"/>
-            <a:ext cx="2926080" cy="1554480"/>
-          </a:xfrm>
-          <a:prstGeom prst="rect">
-            <a:avLst/>
-          </a:prstGeom>
-          <a:noFill/>
-          <a:ln/>
-        </p:spPr>
-        <p:txBody>
-          <a:bodyPr wrap="square" lIns="0" tIns="0" rIns="0" bIns="0" rtlCol="0" anchor="t"/>
-          <a:lstStyle/>
-          <a:p>
-            <a:pPr indent="0" marL="0">
-              <a:buNone/>
-            </a:pPr>
-            <a:r>
-              <a:rPr lang="en-US" sz="6000" b="1" dirty="0">
-                <a:solidFill>
-                  <a:srgbClr val="8B7CF6"/>
-                </a:solidFill>
-                <a:latin typeface="Arial" pitchFamily="34" charset="0"/>
-                <a:ea typeface="Arial" pitchFamily="34" charset="-122"/>
-                <a:cs typeface="Arial" pitchFamily="34" charset="-120"/>
-              </a:rPr>
-              <a:t>1985</a:t>
-            </a:r>
-            <a:endParaRPr lang="en-US" sz="6000" dirty="0"/>
-          </a:p>
-          <a:p>
-            <a:pPr indent="0" marL="0">
-              <a:buNone/>
-            </a:pPr>
-            <a:r>
-              <a:rPr lang="en-US" sz="1800" dirty="0">
-                <a:solidFill>
-                  <a:srgbClr val="8E8E9C"/>
-                </a:solidFill>
-                <a:latin typeface="Arial" pitchFamily="34" charset="0"/>
-                <a:ea typeface="Arial" pitchFamily="34" charset="-122"/>
-                <a:cs typeface="Arial" pitchFamily="34" charset="-120"/>
-              </a:rPr>
-              <a:t>Одесса</a:t>
-            </a:r>
-            <a:endParaRPr lang="en-US" sz="6000" dirty="0"/>
-          </a:p>
-        </p:txBody>
-      </p:sp>
-      <p:sp>
-        <p:nvSpPr>
-          <p:cNvPr id="6" name="Shape 4"/>
-          <p:cNvSpPr/>
-          <p:nvPr/>
-        </p:nvSpPr>
-        <p:spPr>
-          <a:xfrm>
-            <a:off x="3931920" y="1737360"/>
-            <a:ext cx="502920" cy="502920"/>
-          </a:xfrm>
-          <a:prstGeom prst="ellipse">
-            <a:avLst/>
-          </a:prstGeom>
-          <a:solidFill>
-            <a:srgbClr val="231F3D"/>
-          </a:solidFill>
-          <a:ln w="12700">
-            <a:solidFill>
-              <a:srgbClr val="231F3D"/>
-            </a:solidFill>
-            <a:prstDash val="solid"/>
-          </a:ln>
-        </p:spPr>
       </p:sp>
       <p:pic>
         <p:nvPicPr>
-          <p:cNvPr id="7" name="Image 0" descr="preencoded.png">    </p:cNvPr>
+          <p:cNvPr id="3" name="Image 0" descr="Портрет Джигана">    </p:cNvPr>
           <p:cNvPicPr>
             <a:picLocks noChangeAspect="1"/>
           </p:cNvPicPr>
@@ -2953,8 +2840,8 @@
         </p:blipFill>
         <p:spPr>
           <a:xfrm>
-            <a:off x="4057650" y="1863090"/>
-            <a:ext cx="251460" cy="251460"/>
+            <a:off x="0" y="0"/>
+            <a:ext cx="3291840" cy="5143500"/>
           </a:xfrm>
           <a:prstGeom prst="rect">
             <a:avLst/>
@@ -2963,14 +2850,223 @@
       </p:pic>
       <p:sp>
         <p:nvSpPr>
+          <p:cNvPr id="4" name="Shape 1"/>
+          <p:cNvSpPr/>
+          <p:nvPr/>
+        </p:nvSpPr>
+        <p:spPr>
+          <a:xfrm>
+            <a:off x="0" y="4869180"/>
+            <a:ext cx="3291840" cy="274320"/>
+          </a:xfrm>
+          <a:prstGeom prst="rect">
+            <a:avLst/>
+          </a:prstGeom>
+          <a:solidFill>
+            <a:srgbClr val="000000">
+              <a:alpha val="55000"/>
+            </a:srgbClr>
+          </a:solidFill>
+          <a:ln/>
+        </p:spPr>
+      </p:sp>
+      <p:sp>
+        <p:nvSpPr>
+          <p:cNvPr id="5" name="Text 2"/>
+          <p:cNvSpPr txBox="1"/>
+          <p:nvPr/>
+        </p:nvSpPr>
+        <p:spPr>
+          <a:xfrm>
+            <a:off x="137160" y="4869180"/>
+            <a:ext cx="3017520" cy="274320"/>
+          </a:xfrm>
+          <a:prstGeom prst="rect">
+            <a:avLst/>
+          </a:prstGeom>
+          <a:noFill/>
+          <a:ln/>
+        </p:spPr>
+        <p:txBody>
+          <a:bodyPr wrap="square" lIns="0" tIns="0" rIns="0" bIns="0" rtlCol="0" anchor="ctr"/>
+          <a:lstStyle/>
+          <a:p>
+            <a:pPr algn="r" indent="0" marL="0">
+              <a:buNone/>
+            </a:pPr>
+            <a:r>
+              <a:rPr lang="en-US" sz="700" dirty="0">
+                <a:solidFill>
+                  <a:srgbClr val="E6E6EC"/>
+                </a:solidFill>
+                <a:latin typeface="Arial" pitchFamily="34" charset="0"/>
+                <a:ea typeface="Arial" pitchFamily="34" charset="-122"/>
+                <a:cs typeface="Arial" pitchFamily="34" charset="-120"/>
+              </a:rPr>
+              <a:t>Фото: Алексей Гоманков, CC BY-SA 4.0</a:t>
+            </a:r>
+            <a:endParaRPr lang="en-US" sz="700" dirty="0"/>
+          </a:p>
+        </p:txBody>
+      </p:sp>
+      <p:sp>
+        <p:nvSpPr>
+          <p:cNvPr id="6" name="Text 3"/>
+          <p:cNvSpPr txBox="1"/>
+          <p:nvPr/>
+        </p:nvSpPr>
+        <p:spPr>
+          <a:xfrm>
+            <a:off x="3749040" y="731520"/>
+            <a:ext cx="4937760" cy="1097280"/>
+          </a:xfrm>
+          <a:prstGeom prst="rect">
+            <a:avLst/>
+          </a:prstGeom>
+          <a:noFill/>
+          <a:ln/>
+        </p:spPr>
+        <p:txBody>
+          <a:bodyPr wrap="square" lIns="0" tIns="0" rIns="0" bIns="0" rtlCol="0" anchor="t"/>
+          <a:lstStyle/>
+          <a:p>
+            <a:pPr indent="0" marL="0">
+              <a:buNone/>
+            </a:pPr>
+            <a:r>
+              <a:rPr lang="en-US" sz="2800" b="1" dirty="0">
+                <a:solidFill>
+                  <a:srgbClr val="F4F4F6"/>
+                </a:solidFill>
+                <a:latin typeface="Arial" pitchFamily="34" charset="0"/>
+                <a:ea typeface="Arial" pitchFamily="34" charset="-122"/>
+                <a:cs typeface="Arial" pitchFamily="34" charset="-120"/>
+              </a:rPr>
+              <a:t>Денис</a:t>
+            </a:r>
+            <a:endParaRPr lang="en-US" sz="2800" dirty="0"/>
+          </a:p>
+          <a:p>
+            <a:pPr indent="0" marL="0">
+              <a:buNone/>
+            </a:pPr>
+            <a:r>
+              <a:rPr lang="en-US" sz="2800" b="1" dirty="0">
+                <a:solidFill>
+                  <a:srgbClr val="F4F4F6"/>
+                </a:solidFill>
+                <a:latin typeface="Arial" pitchFamily="34" charset="0"/>
+                <a:ea typeface="Arial" pitchFamily="34" charset="-122"/>
+                <a:cs typeface="Arial" pitchFamily="34" charset="-120"/>
+              </a:rPr>
+              <a:t>Устименко-Вайнштейн</a:t>
+            </a:r>
+            <a:endParaRPr lang="en-US" sz="2800" dirty="0"/>
+          </a:p>
+        </p:txBody>
+      </p:sp>
+      <p:sp>
+        <p:nvSpPr>
+          <p:cNvPr id="7" name="Text 4"/>
+          <p:cNvSpPr txBox="1"/>
+          <p:nvPr/>
+        </p:nvSpPr>
+        <p:spPr>
+          <a:xfrm>
+            <a:off x="3749040" y="1874520"/>
+            <a:ext cx="4846320" cy="548640"/>
+          </a:xfrm>
+          <a:prstGeom prst="rect">
+            <a:avLst/>
+          </a:prstGeom>
+          <a:noFill/>
+          <a:ln/>
+        </p:spPr>
+        <p:txBody>
+          <a:bodyPr wrap="square" lIns="0" tIns="0" rIns="0" bIns="0" rtlCol="0" anchor="ctr"/>
+          <a:lstStyle/>
+          <a:p>
+            <a:pPr indent="0" marL="0">
+              <a:buNone/>
+            </a:pPr>
+            <a:r>
+              <a:rPr lang="en-US" sz="3200" b="1" dirty="0">
+                <a:solidFill>
+                  <a:srgbClr val="8B7CF6"/>
+                </a:solidFill>
+                <a:latin typeface="Arial" pitchFamily="34" charset="0"/>
+                <a:ea typeface="Arial" pitchFamily="34" charset="-122"/>
+                <a:cs typeface="Arial" pitchFamily="34" charset="-120"/>
+              </a:rPr>
+              <a:t>1985</a:t>
+            </a:r>
+            <a:pPr indent="0" marL="0">
+              <a:buNone/>
+            </a:pPr>
+            <a:r>
+              <a:rPr lang="en-US" sz="1800" dirty="0">
+                <a:solidFill>
+                  <a:srgbClr val="8E8E9C"/>
+                </a:solidFill>
+                <a:latin typeface="Arial" pitchFamily="34" charset="0"/>
+                <a:ea typeface="Arial" pitchFamily="34" charset="-122"/>
+                <a:cs typeface="Arial" pitchFamily="34" charset="-120"/>
+              </a:rPr>
+              <a:t>  ·  Одесса</a:t>
+            </a:r>
+            <a:endParaRPr lang="en-US" sz="3200" dirty="0"/>
+          </a:p>
+        </p:txBody>
+      </p:sp>
+      <p:sp>
+        <p:nvSpPr>
           <p:cNvPr id="8" name="Text 5"/>
           <p:cNvSpPr txBox="1"/>
           <p:nvPr/>
         </p:nvSpPr>
         <p:spPr>
           <a:xfrm>
-            <a:off x="4617720" y="1719072"/>
-            <a:ext cx="3931920" cy="292608"/>
+            <a:off x="3749040" y="2679192"/>
+            <a:ext cx="502920" cy="292608"/>
+          </a:xfrm>
+          <a:prstGeom prst="rect">
+            <a:avLst/>
+          </a:prstGeom>
+          <a:noFill/>
+          <a:ln/>
+        </p:spPr>
+        <p:txBody>
+          <a:bodyPr wrap="square" lIns="0" tIns="0" rIns="0" bIns="0" rtlCol="0" anchor="ctr"/>
+          <a:lstStyle/>
+          <a:p>
+            <a:pPr indent="0" marL="0">
+              <a:buNone/>
+            </a:pPr>
+            <a:r>
+              <a:rPr lang="en-US" sz="1400" b="1" dirty="0">
+                <a:solidFill>
+                  <a:srgbClr val="8B7CF6"/>
+                </a:solidFill>
+                <a:latin typeface="Arial" pitchFamily="34" charset="0"/>
+                <a:ea typeface="Arial" pitchFamily="34" charset="-122"/>
+                <a:cs typeface="Arial" pitchFamily="34" charset="-120"/>
+              </a:rPr>
+              <a:t>01</a:t>
+            </a:r>
+            <a:endParaRPr lang="en-US" sz="1400" dirty="0"/>
+          </a:p>
+        </p:txBody>
+      </p:sp>
+      <p:sp>
+        <p:nvSpPr>
+          <p:cNvPr id="9" name="Text 6"/>
+          <p:cNvSpPr txBox="1"/>
+          <p:nvPr/>
+        </p:nvSpPr>
+        <p:spPr>
+          <a:xfrm>
+            <a:off x="4297680" y="2679192"/>
+            <a:ext cx="4297680" cy="292608"/>
           </a:xfrm>
           <a:prstGeom prst="rect">
             <a:avLst/>
@@ -3002,14 +3098,14 @@
       </p:sp>
       <p:sp>
         <p:nvSpPr>
-          <p:cNvPr id="9" name="Text 6"/>
-          <p:cNvSpPr txBox="1"/>
-          <p:nvPr/>
-        </p:nvSpPr>
-        <p:spPr>
-          <a:xfrm>
-            <a:off x="4617720" y="2011680"/>
-            <a:ext cx="3931920" cy="274320"/>
+          <p:cNvPr id="10" name="Text 7"/>
+          <p:cNvSpPr txBox="1"/>
+          <p:nvPr/>
+        </p:nvSpPr>
+        <p:spPr>
+          <a:xfrm>
+            <a:off x="4297680" y="2971800"/>
+            <a:ext cx="4297680" cy="274320"/>
           </a:xfrm>
           <a:prstGeom prst="rect">
             <a:avLst/>
@@ -3041,63 +3137,53 @@
       </p:sp>
       <p:sp>
         <p:nvSpPr>
-          <p:cNvPr id="10" name="Shape 7"/>
-          <p:cNvSpPr/>
-          <p:nvPr/>
-        </p:nvSpPr>
-        <p:spPr>
-          <a:xfrm>
-            <a:off x="3931920" y="2606040"/>
-            <a:ext cx="502920" cy="502920"/>
-          </a:xfrm>
-          <a:prstGeom prst="ellipse">
-            <a:avLst/>
-          </a:prstGeom>
-          <a:solidFill>
-            <a:srgbClr val="231F3D"/>
-          </a:solidFill>
-          <a:ln w="12700">
-            <a:solidFill>
-              <a:srgbClr val="231F3D"/>
-            </a:solidFill>
-            <a:prstDash val="solid"/>
-          </a:ln>
-        </p:spPr>
-      </p:sp>
-      <p:pic>
-        <p:nvPicPr>
-          <p:cNvPr id="11" name="Image 1" descr="preencoded.png">    </p:cNvPr>
-          <p:cNvPicPr>
-            <a:picLocks noChangeAspect="1"/>
-          </p:cNvPicPr>
-          <p:nvPr/>
-        </p:nvPicPr>
-        <p:blipFill>
-          <a:blip r:embed="rId2"/>
-          <a:stretch>
-            <a:fillRect/>
-          </a:stretch>
-        </p:blipFill>
-        <p:spPr>
-          <a:xfrm>
-            <a:off x="4057650" y="2731770"/>
-            <a:ext cx="251460" cy="251460"/>
-          </a:xfrm>
-          <a:prstGeom prst="rect">
-            <a:avLst/>
-          </a:prstGeom>
-        </p:spPr>
-      </p:pic>
-      <p:sp>
-        <p:nvSpPr>
-          <p:cNvPr id="12" name="Text 8"/>
-          <p:cNvSpPr txBox="1"/>
-          <p:nvPr/>
-        </p:nvSpPr>
-        <p:spPr>
-          <a:xfrm>
-            <a:off x="4617720" y="2587752"/>
-            <a:ext cx="3931920" cy="292608"/>
+          <p:cNvPr id="11" name="Text 8"/>
+          <p:cNvSpPr txBox="1"/>
+          <p:nvPr/>
+        </p:nvSpPr>
+        <p:spPr>
+          <a:xfrm>
+            <a:off x="3749040" y="3337560"/>
+            <a:ext cx="502920" cy="292608"/>
+          </a:xfrm>
+          <a:prstGeom prst="rect">
+            <a:avLst/>
+          </a:prstGeom>
+          <a:noFill/>
+          <a:ln/>
+        </p:spPr>
+        <p:txBody>
+          <a:bodyPr wrap="square" lIns="0" tIns="0" rIns="0" bIns="0" rtlCol="0" anchor="ctr"/>
+          <a:lstStyle/>
+          <a:p>
+            <a:pPr indent="0" marL="0">
+              <a:buNone/>
+            </a:pPr>
+            <a:r>
+              <a:rPr lang="en-US" sz="1400" b="1" dirty="0">
+                <a:solidFill>
+                  <a:srgbClr val="8B7CF6"/>
+                </a:solidFill>
+                <a:latin typeface="Arial" pitchFamily="34" charset="0"/>
+                <a:ea typeface="Arial" pitchFamily="34" charset="-122"/>
+                <a:cs typeface="Arial" pitchFamily="34" charset="-120"/>
+              </a:rPr>
+              <a:t>02</a:t>
+            </a:r>
+            <a:endParaRPr lang="en-US" sz="1400" dirty="0"/>
+          </a:p>
+        </p:txBody>
+      </p:sp>
+      <p:sp>
+        <p:nvSpPr>
+          <p:cNvPr id="12" name="Text 9"/>
+          <p:cNvSpPr txBox="1"/>
+          <p:nvPr/>
+        </p:nvSpPr>
+        <p:spPr>
+          <a:xfrm>
+            <a:off x="4297680" y="3337560"/>
+            <a:ext cx="4297680" cy="292608"/>
           </a:xfrm>
           <a:prstGeom prst="rect">
             <a:avLst/>
@@ -3129,14 +3215,14 @@
       </p:sp>
       <p:sp>
         <p:nvSpPr>
-          <p:cNvPr id="13" name="Text 9"/>
-          <p:cNvSpPr txBox="1"/>
-          <p:nvPr/>
-        </p:nvSpPr>
-        <p:spPr>
-          <a:xfrm>
-            <a:off x="4617720" y="2880360"/>
-            <a:ext cx="3931920" cy="274320"/>
+          <p:cNvPr id="13" name="Text 10"/>
+          <p:cNvSpPr txBox="1"/>
+          <p:nvPr/>
+        </p:nvSpPr>
+        <p:spPr>
+          <a:xfrm>
+            <a:off x="4297680" y="3630168"/>
+            <a:ext cx="4297680" cy="274320"/>
           </a:xfrm>
           <a:prstGeom prst="rect">
             <a:avLst/>
@@ -3168,63 +3254,53 @@
       </p:sp>
       <p:sp>
         <p:nvSpPr>
-          <p:cNvPr id="14" name="Shape 10"/>
-          <p:cNvSpPr/>
-          <p:nvPr/>
-        </p:nvSpPr>
-        <p:spPr>
-          <a:xfrm>
-            <a:off x="3931920" y="3474720"/>
-            <a:ext cx="502920" cy="502920"/>
-          </a:xfrm>
-          <a:prstGeom prst="ellipse">
-            <a:avLst/>
-          </a:prstGeom>
-          <a:solidFill>
-            <a:srgbClr val="231F3D"/>
-          </a:solidFill>
-          <a:ln w="12700">
-            <a:solidFill>
-              <a:srgbClr val="231F3D"/>
-            </a:solidFill>
-            <a:prstDash val="solid"/>
-          </a:ln>
-        </p:spPr>
-      </p:sp>
-      <p:pic>
-        <p:nvPicPr>
-          <p:cNvPr id="15" name="Image 2" descr="preencoded.png">    </p:cNvPr>
-          <p:cNvPicPr>
-            <a:picLocks noChangeAspect="1"/>
-          </p:cNvPicPr>
-          <p:nvPr/>
-        </p:nvPicPr>
-        <p:blipFill>
-          <a:blip r:embed="rId3"/>
-          <a:stretch>
-            <a:fillRect/>
-          </a:stretch>
-        </p:blipFill>
-        <p:spPr>
-          <a:xfrm>
-            <a:off x="4057650" y="3600450"/>
-            <a:ext cx="251460" cy="251460"/>
-          </a:xfrm>
-          <a:prstGeom prst="rect">
-            <a:avLst/>
-          </a:prstGeom>
-        </p:spPr>
-      </p:pic>
-      <p:sp>
-        <p:nvSpPr>
-          <p:cNvPr id="16" name="Text 11"/>
-          <p:cNvSpPr txBox="1"/>
-          <p:nvPr/>
-        </p:nvSpPr>
-        <p:spPr>
-          <a:xfrm>
-            <a:off x="4617720" y="3456432"/>
-            <a:ext cx="3931920" cy="292608"/>
+          <p:cNvPr id="14" name="Text 11"/>
+          <p:cNvSpPr txBox="1"/>
+          <p:nvPr/>
+        </p:nvSpPr>
+        <p:spPr>
+          <a:xfrm>
+            <a:off x="3749040" y="3995928"/>
+            <a:ext cx="502920" cy="292608"/>
+          </a:xfrm>
+          <a:prstGeom prst="rect">
+            <a:avLst/>
+          </a:prstGeom>
+          <a:noFill/>
+          <a:ln/>
+        </p:spPr>
+        <p:txBody>
+          <a:bodyPr wrap="square" lIns="0" tIns="0" rIns="0" bIns="0" rtlCol="0" anchor="ctr"/>
+          <a:lstStyle/>
+          <a:p>
+            <a:pPr indent="0" marL="0">
+              <a:buNone/>
+            </a:pPr>
+            <a:r>
+              <a:rPr lang="en-US" sz="1400" b="1" dirty="0">
+                <a:solidFill>
+                  <a:srgbClr val="8B7CF6"/>
+                </a:solidFill>
+                <a:latin typeface="Arial" pitchFamily="34" charset="0"/>
+                <a:ea typeface="Arial" pitchFamily="34" charset="-122"/>
+                <a:cs typeface="Arial" pitchFamily="34" charset="-120"/>
+              </a:rPr>
+              <a:t>03</a:t>
+            </a:r>
+            <a:endParaRPr lang="en-US" sz="1400" dirty="0"/>
+          </a:p>
+        </p:txBody>
+      </p:sp>
+      <p:sp>
+        <p:nvSpPr>
+          <p:cNvPr id="15" name="Text 12"/>
+          <p:cNvSpPr txBox="1"/>
+          <p:nvPr/>
+        </p:nvSpPr>
+        <p:spPr>
+          <a:xfrm>
+            <a:off x="4297680" y="3995928"/>
+            <a:ext cx="4297680" cy="292608"/>
           </a:xfrm>
           <a:prstGeom prst="rect">
             <a:avLst/>
@@ -3256,14 +3332,14 @@
       </p:sp>
       <p:sp>
         <p:nvSpPr>
-          <p:cNvPr id="17" name="Text 12"/>
-          <p:cNvSpPr txBox="1"/>
-          <p:nvPr/>
-        </p:nvSpPr>
-        <p:spPr>
-          <a:xfrm>
-            <a:off x="4617720" y="3749040"/>
-            <a:ext cx="3931920" cy="274320"/>
+          <p:cNvPr id="16" name="Text 13"/>
+          <p:cNvSpPr txBox="1"/>
+          <p:nvPr/>
+        </p:nvSpPr>
+        <p:spPr>
+          <a:xfrm>
+            <a:off x="4297680" y="4288536"/>
+            <a:ext cx="4297680" cy="274320"/>
           </a:xfrm>
           <a:prstGeom prst="rect">
             <a:avLst/>
@@ -3290,6 +3366,45 @@
               <a:t>Танцевальный поп-рэп с первых треков</a:t>
             </a:r>
             <a:endParaRPr lang="en-US" sz="1200" dirty="0"/>
+          </a:p>
+        </p:txBody>
+      </p:sp>
+      <p:sp>
+        <p:nvSpPr>
+          <p:cNvPr id="17" name="Text 14"/>
+          <p:cNvSpPr txBox="1"/>
+          <p:nvPr/>
+        </p:nvSpPr>
+        <p:spPr>
+          <a:xfrm>
+            <a:off x="7680960" y="4663440"/>
+            <a:ext cx="914400" cy="228600"/>
+          </a:xfrm>
+          <a:prstGeom prst="rect">
+            <a:avLst/>
+          </a:prstGeom>
+          <a:noFill/>
+          <a:ln/>
+        </p:spPr>
+        <p:txBody>
+          <a:bodyPr wrap="square" lIns="0" tIns="0" rIns="0" bIns="0" rtlCol="0" anchor="ctr"/>
+          <a:lstStyle/>
+          <a:p>
+            <a:pPr algn="r" indent="0" marL="0">
+              <a:buNone/>
+            </a:pPr>
+            <a:r>
+              <a:rPr lang="en-US" sz="900" dirty="0">
+                <a:solidFill>
+                  <a:srgbClr val="8E8E9C"/>
+                </a:solidFill>
+                <a:latin typeface="Arial" pitchFamily="34" charset="0"/>
+                <a:ea typeface="Arial" pitchFamily="34" charset="-122"/>
+                <a:cs typeface="Arial" pitchFamily="34" charset="-120"/>
+              </a:rPr>
+              <a:t>02 / 10</a:t>
+            </a:r>
+            <a:endParaRPr lang="en-US" sz="900" dirty="0"/>
           </a:p>
         </p:txBody>
       </p:sp>
@@ -3334,7 +3449,7 @@
         <p:spPr>
           <a:xfrm>
             <a:off x="548640" y="411480"/>
-            <a:ext cx="5486400" cy="274320"/>
+            <a:ext cx="4572000" cy="274320"/>
           </a:xfrm>
           <a:prstGeom prst="rect">
             <a:avLst/>
@@ -3367,45 +3482,6 @@
       <p:sp>
         <p:nvSpPr>
           <p:cNvPr id="3" name="Text 1"/>
-          <p:cNvSpPr txBox="1"/>
-          <p:nvPr/>
-        </p:nvSpPr>
-        <p:spPr>
-          <a:xfrm>
-            <a:off x="7680960" y="4663440"/>
-            <a:ext cx="914400" cy="228600"/>
-          </a:xfrm>
-          <a:prstGeom prst="rect">
-            <a:avLst/>
-          </a:prstGeom>
-          <a:noFill/>
-          <a:ln/>
-        </p:spPr>
-        <p:txBody>
-          <a:bodyPr wrap="square" lIns="0" tIns="0" rIns="0" bIns="0" rtlCol="0" anchor="ctr"/>
-          <a:lstStyle/>
-          <a:p>
-            <a:pPr algn="r" indent="0" marL="0">
-              <a:buNone/>
-            </a:pPr>
-            <a:r>
-              <a:rPr lang="en-US" sz="900" dirty="0">
-                <a:solidFill>
-                  <a:srgbClr val="8E8E9C"/>
-                </a:solidFill>
-                <a:latin typeface="Arial" pitchFamily="34" charset="0"/>
-                <a:ea typeface="Arial" pitchFamily="34" charset="-122"/>
-                <a:cs typeface="Arial" pitchFamily="34" charset="-120"/>
-              </a:rPr>
-              <a:t>03 / 10</a:t>
-            </a:r>
-            <a:endParaRPr lang="en-US" sz="900" dirty="0"/>
-          </a:p>
-        </p:txBody>
-      </p:sp>
-      <p:sp>
-        <p:nvSpPr>
-          <p:cNvPr id="4" name="Text 2"/>
           <p:cNvSpPr txBox="1"/>
           <p:nvPr/>
         </p:nvSpPr>
@@ -3444,7 +3520,7 @@
       </p:sp>
       <p:sp>
         <p:nvSpPr>
-          <p:cNvPr id="5" name="Shape 3"/>
+          <p:cNvPr id="4" name="Shape 2"/>
           <p:cNvSpPr/>
           <p:nvPr/>
         </p:nvSpPr>
@@ -3471,7 +3547,7 @@
       </p:sp>
       <p:sp>
         <p:nvSpPr>
-          <p:cNvPr id="6" name="Text 4"/>
+          <p:cNvPr id="5" name="Text 3"/>
           <p:cNvSpPr txBox="1"/>
           <p:nvPr/>
         </p:nvSpPr>
@@ -3510,7 +3586,7 @@
       </p:sp>
       <p:sp>
         <p:nvSpPr>
-          <p:cNvPr id="7" name="Text 5"/>
+          <p:cNvPr id="6" name="Text 4"/>
           <p:cNvSpPr txBox="1"/>
           <p:nvPr/>
         </p:nvSpPr>
@@ -3549,7 +3625,7 @@
       </p:sp>
       <p:sp>
         <p:nvSpPr>
-          <p:cNvPr id="8" name="Text 6"/>
+          <p:cNvPr id="7" name="Text 5"/>
           <p:cNvSpPr txBox="1"/>
           <p:nvPr/>
         </p:nvSpPr>
@@ -3586,33 +3662,48 @@
           </a:p>
         </p:txBody>
       </p:sp>
-      <p:pic>
-        <p:nvPicPr>
-          <p:cNvPr id="9" name="Image 0" descr="preencoded.png">    </p:cNvPr>
-          <p:cNvPicPr>
-            <a:picLocks noChangeAspect="1"/>
-          </p:cNvPicPr>
-          <p:nvPr/>
-        </p:nvPicPr>
-        <p:blipFill>
-          <a:blip r:embed="rId1"/>
-          <a:stretch>
-            <a:fillRect/>
-          </a:stretch>
-        </p:blipFill>
-        <p:spPr>
-          <a:xfrm>
-            <a:off x="3008376" y="2743200"/>
-            <a:ext cx="274320" cy="274320"/>
-          </a:xfrm>
-          <a:prstGeom prst="rect">
-            <a:avLst/>
-          </a:prstGeom>
-        </p:spPr>
-      </p:pic>
-      <p:sp>
-        <p:nvSpPr>
-          <p:cNvPr id="10" name="Shape 7"/>
+      <p:sp>
+        <p:nvSpPr>
+          <p:cNvPr id="8" name="Text 6"/>
+          <p:cNvSpPr txBox="1"/>
+          <p:nvPr/>
+        </p:nvSpPr>
+        <p:spPr>
+          <a:xfrm>
+            <a:off x="2880360" y="2697480"/>
+            <a:ext cx="521208" cy="365760"/>
+          </a:xfrm>
+          <a:prstGeom prst="rect">
+            <a:avLst/>
+          </a:prstGeom>
+          <a:noFill/>
+          <a:ln/>
+        </p:spPr>
+        <p:txBody>
+          <a:bodyPr wrap="square" lIns="0" tIns="0" rIns="0" bIns="0" rtlCol="0" anchor="ctr"/>
+          <a:lstStyle/>
+          <a:p>
+            <a:pPr algn="ctr" indent="0" marL="0">
+              <a:buNone/>
+            </a:pPr>
+            <a:r>
+              <a:rPr lang="en-US" sz="1800" dirty="0">
+                <a:solidFill>
+                  <a:srgbClr val="8E8E9C"/>
+                </a:solidFill>
+                <a:latin typeface="Arial" pitchFamily="34" charset="0"/>
+                <a:ea typeface="Arial" pitchFamily="34" charset="-122"/>
+                <a:cs typeface="Arial" pitchFamily="34" charset="-120"/>
+              </a:rPr>
+              <a:t>→</a:t>
+            </a:r>
+            <a:endParaRPr lang="en-US" sz="1800" dirty="0"/>
+          </a:p>
+        </p:txBody>
+      </p:sp>
+      <p:sp>
+        <p:nvSpPr>
+          <p:cNvPr id="9" name="Shape 7"/>
           <p:cNvSpPr/>
           <p:nvPr/>
         </p:nvSpPr>
@@ -3639,7 +3730,7 @@
       </p:sp>
       <p:sp>
         <p:nvSpPr>
-          <p:cNvPr id="11" name="Text 8"/>
+          <p:cNvPr id="10" name="Text 8"/>
           <p:cNvSpPr txBox="1"/>
           <p:nvPr/>
         </p:nvSpPr>
@@ -3678,7 +3769,7 @@
       </p:sp>
       <p:sp>
         <p:nvSpPr>
-          <p:cNvPr id="12" name="Text 9"/>
+          <p:cNvPr id="11" name="Text 9"/>
           <p:cNvSpPr txBox="1"/>
           <p:nvPr/>
         </p:nvSpPr>
@@ -3717,7 +3808,7 @@
       </p:sp>
       <p:sp>
         <p:nvSpPr>
-          <p:cNvPr id="13" name="Text 10"/>
+          <p:cNvPr id="12" name="Text 10"/>
           <p:cNvSpPr txBox="1"/>
           <p:nvPr/>
         </p:nvSpPr>
@@ -3754,33 +3845,48 @@
           </a:p>
         </p:txBody>
       </p:sp>
-      <p:pic>
-        <p:nvPicPr>
-          <p:cNvPr id="14" name="Image 1" descr="preencoded.png">    </p:cNvPr>
-          <p:cNvPicPr>
-            <a:picLocks noChangeAspect="1"/>
-          </p:cNvPicPr>
-          <p:nvPr/>
-        </p:nvPicPr>
-        <p:blipFill>
-          <a:blip r:embed="rId2"/>
-          <a:stretch>
-            <a:fillRect/>
-          </a:stretch>
-        </p:blipFill>
-        <p:spPr>
-          <a:xfrm>
-            <a:off x="5861304" y="2743200"/>
-            <a:ext cx="274320" cy="274320"/>
-          </a:xfrm>
-          <a:prstGeom prst="rect">
-            <a:avLst/>
-          </a:prstGeom>
-        </p:spPr>
-      </p:pic>
-      <p:sp>
-        <p:nvSpPr>
-          <p:cNvPr id="15" name="Shape 11"/>
+      <p:sp>
+        <p:nvSpPr>
+          <p:cNvPr id="13" name="Text 11"/>
+          <p:cNvSpPr txBox="1"/>
+          <p:nvPr/>
+        </p:nvSpPr>
+        <p:spPr>
+          <a:xfrm>
+            <a:off x="5733288" y="2697480"/>
+            <a:ext cx="521208" cy="365760"/>
+          </a:xfrm>
+          <a:prstGeom prst="rect">
+            <a:avLst/>
+          </a:prstGeom>
+          <a:noFill/>
+          <a:ln/>
+        </p:spPr>
+        <p:txBody>
+          <a:bodyPr wrap="square" lIns="0" tIns="0" rIns="0" bIns="0" rtlCol="0" anchor="ctr"/>
+          <a:lstStyle/>
+          <a:p>
+            <a:pPr algn="ctr" indent="0" marL="0">
+              <a:buNone/>
+            </a:pPr>
+            <a:r>
+              <a:rPr lang="en-US" sz="1800" dirty="0">
+                <a:solidFill>
+                  <a:srgbClr val="8E8E9C"/>
+                </a:solidFill>
+                <a:latin typeface="Arial" pitchFamily="34" charset="0"/>
+                <a:ea typeface="Arial" pitchFamily="34" charset="-122"/>
+                <a:cs typeface="Arial" pitchFamily="34" charset="-120"/>
+              </a:rPr>
+              <a:t>→</a:t>
+            </a:r>
+            <a:endParaRPr lang="en-US" sz="1800" dirty="0"/>
+          </a:p>
+        </p:txBody>
+      </p:sp>
+      <p:sp>
+        <p:nvSpPr>
+          <p:cNvPr id="14" name="Shape 12"/>
           <p:cNvSpPr/>
           <p:nvPr/>
         </p:nvSpPr>
@@ -3807,7 +3913,7 @@
       </p:sp>
       <p:sp>
         <p:nvSpPr>
-          <p:cNvPr id="16" name="Text 12"/>
+          <p:cNvPr id="15" name="Text 13"/>
           <p:cNvSpPr txBox="1"/>
           <p:nvPr/>
         </p:nvSpPr>
@@ -3846,7 +3952,7 @@
       </p:sp>
       <p:sp>
         <p:nvSpPr>
-          <p:cNvPr id="17" name="Text 13"/>
+          <p:cNvPr id="16" name="Text 14"/>
           <p:cNvSpPr txBox="1"/>
           <p:nvPr/>
         </p:nvSpPr>
@@ -3885,7 +3991,7 @@
       </p:sp>
       <p:sp>
         <p:nvSpPr>
-          <p:cNvPr id="18" name="Text 14"/>
+          <p:cNvPr id="17" name="Text 15"/>
           <p:cNvSpPr txBox="1"/>
           <p:nvPr/>
         </p:nvSpPr>
@@ -3919,6 +4025,45 @@
               <a:t>Контракт с лейблом Тимати</a:t>
             </a:r>
             <a:endParaRPr lang="en-US" sz="1200" dirty="0"/>
+          </a:p>
+        </p:txBody>
+      </p:sp>
+      <p:sp>
+        <p:nvSpPr>
+          <p:cNvPr id="18" name="Text 16"/>
+          <p:cNvSpPr txBox="1"/>
+          <p:nvPr/>
+        </p:nvSpPr>
+        <p:spPr>
+          <a:xfrm>
+            <a:off x="7680960" y="4663440"/>
+            <a:ext cx="914400" cy="228600"/>
+          </a:xfrm>
+          <a:prstGeom prst="rect">
+            <a:avLst/>
+          </a:prstGeom>
+          <a:noFill/>
+          <a:ln/>
+        </p:spPr>
+        <p:txBody>
+          <a:bodyPr wrap="square" lIns="0" tIns="0" rIns="0" bIns="0" rtlCol="0" anchor="ctr"/>
+          <a:lstStyle/>
+          <a:p>
+            <a:pPr algn="r" indent="0" marL="0">
+              <a:buNone/>
+            </a:pPr>
+            <a:r>
+              <a:rPr lang="en-US" sz="900" dirty="0">
+                <a:solidFill>
+                  <a:srgbClr val="8E8E9C"/>
+                </a:solidFill>
+                <a:latin typeface="Arial" pitchFamily="34" charset="0"/>
+                <a:ea typeface="Arial" pitchFamily="34" charset="-122"/>
+                <a:cs typeface="Arial" pitchFamily="34" charset="-120"/>
+              </a:rPr>
+              <a:t>03 / 10</a:t>
+            </a:r>
+            <a:endParaRPr lang="en-US" sz="900" dirty="0"/>
           </a:p>
         </p:txBody>
       </p:sp>
@@ -3963,7 +4108,7 @@
         <p:spPr>
           <a:xfrm>
             <a:off x="548640" y="411480"/>
-            <a:ext cx="5486400" cy="274320"/>
+            <a:ext cx="4572000" cy="274320"/>
           </a:xfrm>
           <a:prstGeom prst="rect">
             <a:avLst/>
@@ -3996,45 +4141,6 @@
       <p:sp>
         <p:nvSpPr>
           <p:cNvPr id="3" name="Text 1"/>
-          <p:cNvSpPr txBox="1"/>
-          <p:nvPr/>
-        </p:nvSpPr>
-        <p:spPr>
-          <a:xfrm>
-            <a:off x="7680960" y="4663440"/>
-            <a:ext cx="914400" cy="228600"/>
-          </a:xfrm>
-          <a:prstGeom prst="rect">
-            <a:avLst/>
-          </a:prstGeom>
-          <a:noFill/>
-          <a:ln/>
-        </p:spPr>
-        <p:txBody>
-          <a:bodyPr wrap="square" lIns="0" tIns="0" rIns="0" bIns="0" rtlCol="0" anchor="ctr"/>
-          <a:lstStyle/>
-          <a:p>
-            <a:pPr algn="r" indent="0" marL="0">
-              <a:buNone/>
-            </a:pPr>
-            <a:r>
-              <a:rPr lang="en-US" sz="900" dirty="0">
-                <a:solidFill>
-                  <a:srgbClr val="8E8E9C"/>
-                </a:solidFill>
-                <a:latin typeface="Arial" pitchFamily="34" charset="0"/>
-                <a:ea typeface="Arial" pitchFamily="34" charset="-122"/>
-                <a:cs typeface="Arial" pitchFamily="34" charset="-120"/>
-              </a:rPr>
-              <a:t>04 / 10</a:t>
-            </a:r>
-            <a:endParaRPr lang="en-US" sz="900" dirty="0"/>
-          </a:p>
-        </p:txBody>
-      </p:sp>
-      <p:sp>
-        <p:nvSpPr>
-          <p:cNvPr id="4" name="Text 2"/>
           <p:cNvSpPr txBox="1"/>
           <p:nvPr/>
         </p:nvSpPr>
@@ -4073,7 +4179,7 @@
       </p:sp>
       <p:sp>
         <p:nvSpPr>
-          <p:cNvPr id="5" name="Shape 3"/>
+          <p:cNvPr id="4" name="Shape 2"/>
           <p:cNvSpPr/>
           <p:nvPr/>
         </p:nvSpPr>
@@ -4100,7 +4206,7 @@
       </p:sp>
       <p:sp>
         <p:nvSpPr>
-          <p:cNvPr id="6" name="Text 4"/>
+          <p:cNvPr id="5" name="Text 3"/>
           <p:cNvSpPr txBox="1"/>
           <p:nvPr/>
         </p:nvSpPr>
@@ -4139,7 +4245,7 @@
       </p:sp>
       <p:sp>
         <p:nvSpPr>
-          <p:cNvPr id="7" name="Text 5"/>
+          <p:cNvPr id="6" name="Text 4"/>
           <p:cNvSpPr txBox="1"/>
           <p:nvPr/>
         </p:nvSpPr>
@@ -4178,7 +4284,7 @@
       </p:sp>
       <p:sp>
         <p:nvSpPr>
-          <p:cNvPr id="8" name="Shape 6"/>
+          <p:cNvPr id="7" name="Shape 5"/>
           <p:cNvSpPr/>
           <p:nvPr/>
         </p:nvSpPr>
@@ -4205,7 +4311,7 @@
       </p:sp>
       <p:sp>
         <p:nvSpPr>
-          <p:cNvPr id="9" name="Text 7"/>
+          <p:cNvPr id="8" name="Text 6"/>
           <p:cNvSpPr txBox="1"/>
           <p:nvPr/>
         </p:nvSpPr>
@@ -4244,7 +4350,7 @@
       </p:sp>
       <p:sp>
         <p:nvSpPr>
-          <p:cNvPr id="10" name="Text 8"/>
+          <p:cNvPr id="9" name="Text 7"/>
           <p:cNvSpPr txBox="1"/>
           <p:nvPr/>
         </p:nvSpPr>
@@ -4283,7 +4389,7 @@
       </p:sp>
       <p:sp>
         <p:nvSpPr>
-          <p:cNvPr id="11" name="Shape 9"/>
+          <p:cNvPr id="10" name="Shape 8"/>
           <p:cNvSpPr/>
           <p:nvPr/>
         </p:nvSpPr>
@@ -4310,7 +4416,7 @@
       </p:sp>
       <p:sp>
         <p:nvSpPr>
-          <p:cNvPr id="12" name="Text 10"/>
+          <p:cNvPr id="11" name="Text 9"/>
           <p:cNvSpPr txBox="1"/>
           <p:nvPr/>
         </p:nvSpPr>
@@ -4349,7 +4455,7 @@
       </p:sp>
       <p:sp>
         <p:nvSpPr>
-          <p:cNvPr id="13" name="Text 11"/>
+          <p:cNvPr id="12" name="Text 10"/>
           <p:cNvSpPr txBox="1"/>
           <p:nvPr/>
         </p:nvSpPr>
@@ -4445,7 +4551,7 @@
       </p:sp>
       <p:sp>
         <p:nvSpPr>
-          <p:cNvPr id="14" name="Text 12"/>
+          <p:cNvPr id="13" name="Text 11"/>
           <p:cNvSpPr txBox="1"/>
           <p:nvPr/>
         </p:nvSpPr>
@@ -4484,7 +4590,7 @@
       </p:sp>
       <p:sp>
         <p:nvSpPr>
-          <p:cNvPr id="15" name="Text 13"/>
+          <p:cNvPr id="14" name="Text 12"/>
           <p:cNvSpPr txBox="1"/>
           <p:nvPr/>
         </p:nvSpPr>
@@ -4535,6 +4641,45 @@
               <a:t>артиста приносили лейблу основные деньги: Тимати и Джиган</a:t>
             </a:r>
             <a:endParaRPr lang="en-US" sz="6400" dirty="0"/>
+          </a:p>
+        </p:txBody>
+      </p:sp>
+      <p:sp>
+        <p:nvSpPr>
+          <p:cNvPr id="15" name="Text 13"/>
+          <p:cNvSpPr txBox="1"/>
+          <p:nvPr/>
+        </p:nvSpPr>
+        <p:spPr>
+          <a:xfrm>
+            <a:off x="7680960" y="4663440"/>
+            <a:ext cx="914400" cy="228600"/>
+          </a:xfrm>
+          <a:prstGeom prst="rect">
+            <a:avLst/>
+          </a:prstGeom>
+          <a:noFill/>
+          <a:ln/>
+        </p:spPr>
+        <p:txBody>
+          <a:bodyPr wrap="square" lIns="0" tIns="0" rIns="0" bIns="0" rtlCol="0" anchor="ctr"/>
+          <a:lstStyle/>
+          <a:p>
+            <a:pPr algn="r" indent="0" marL="0">
+              <a:buNone/>
+            </a:pPr>
+            <a:r>
+              <a:rPr lang="en-US" sz="900" dirty="0">
+                <a:solidFill>
+                  <a:srgbClr val="8E8E9C"/>
+                </a:solidFill>
+                <a:latin typeface="Arial" pitchFamily="34" charset="0"/>
+                <a:ea typeface="Arial" pitchFamily="34" charset="-122"/>
+                <a:cs typeface="Arial" pitchFamily="34" charset="-120"/>
+              </a:rPr>
+              <a:t>04 / 10</a:t>
+            </a:r>
+            <a:endParaRPr lang="en-US" sz="900" dirty="0"/>
           </a:p>
         </p:txBody>
       </p:sp>
@@ -4579,7 +4724,7 @@
         <p:spPr>
           <a:xfrm>
             <a:off x="548640" y="411480"/>
-            <a:ext cx="5486400" cy="274320"/>
+            <a:ext cx="4572000" cy="274320"/>
           </a:xfrm>
           <a:prstGeom prst="rect">
             <a:avLst/>
@@ -4609,16 +4754,62 @@
           </a:p>
         </p:txBody>
       </p:sp>
-      <p:sp>
-        <p:nvSpPr>
-          <p:cNvPr id="3" name="Text 1"/>
-          <p:cNvSpPr txBox="1"/>
-          <p:nvPr/>
-        </p:nvSpPr>
-        <p:spPr>
-          <a:xfrm>
-            <a:off x="7680960" y="4663440"/>
-            <a:ext cx="914400" cy="228600"/>
+      <p:pic>
+        <p:nvPicPr>
+          <p:cNvPr id="3" name="Image 0" descr="Джиган на сцене в Витебске, 2016">    </p:cNvPr>
+          <p:cNvPicPr>
+            <a:picLocks noChangeAspect="1"/>
+          </p:cNvPicPr>
+          <p:nvPr/>
+        </p:nvPicPr>
+        <p:blipFill>
+          <a:blip r:embed="rId1"/>
+          <a:stretch>
+            <a:fillRect/>
+          </a:stretch>
+        </p:blipFill>
+        <p:spPr>
+          <a:xfrm>
+            <a:off x="5303520" y="0"/>
+            <a:ext cx="3840480" cy="5143500"/>
+          </a:xfrm>
+          <a:prstGeom prst="rect">
+            <a:avLst/>
+          </a:prstGeom>
+        </p:spPr>
+      </p:pic>
+      <p:sp>
+        <p:nvSpPr>
+          <p:cNvPr id="4" name="Shape 1"/>
+          <p:cNvSpPr/>
+          <p:nvPr/>
+        </p:nvSpPr>
+        <p:spPr>
+          <a:xfrm>
+            <a:off x="5303520" y="4869180"/>
+            <a:ext cx="3840480" cy="274320"/>
+          </a:xfrm>
+          <a:prstGeom prst="rect">
+            <a:avLst/>
+          </a:prstGeom>
+          <a:solidFill>
+            <a:srgbClr val="000000">
+              <a:alpha val="55000"/>
+            </a:srgbClr>
+          </a:solidFill>
+          <a:ln/>
+        </p:spPr>
+      </p:sp>
+      <p:sp>
+        <p:nvSpPr>
+          <p:cNvPr id="5" name="Text 2"/>
+          <p:cNvSpPr txBox="1"/>
+          <p:nvPr/>
+        </p:nvSpPr>
+        <p:spPr>
+          <a:xfrm>
+            <a:off x="5440680" y="4869180"/>
+            <a:ext cx="3566160" cy="274320"/>
           </a:xfrm>
           <a:prstGeom prst="rect">
             <a:avLst/>
@@ -4634,69 +4825,30 @@
               <a:buNone/>
             </a:pPr>
             <a:r>
-              <a:rPr lang="en-US" sz="900" dirty="0">
-                <a:solidFill>
-                  <a:srgbClr val="8E8E9C"/>
-                </a:solidFill>
-                <a:latin typeface="Arial" pitchFamily="34" charset="0"/>
-                <a:ea typeface="Arial" pitchFamily="34" charset="-122"/>
-                <a:cs typeface="Arial" pitchFamily="34" charset="-120"/>
-              </a:rPr>
-              <a:t>05 / 10</a:t>
-            </a:r>
-            <a:endParaRPr lang="en-US" sz="900" dirty="0"/>
-          </a:p>
-        </p:txBody>
-      </p:sp>
-      <p:sp>
-        <p:nvSpPr>
-          <p:cNvPr id="4" name="Text 2"/>
-          <p:cNvSpPr txBox="1"/>
-          <p:nvPr/>
-        </p:nvSpPr>
-        <p:spPr>
-          <a:xfrm>
-            <a:off x="3291840" y="2103120"/>
-            <a:ext cx="5669280" cy="2926080"/>
-          </a:xfrm>
-          <a:prstGeom prst="rect">
-            <a:avLst/>
-          </a:prstGeom>
-          <a:noFill/>
-          <a:ln/>
-        </p:spPr>
-        <p:txBody>
-          <a:bodyPr wrap="square" lIns="0" tIns="0" rIns="0" bIns="0" rtlCol="0" anchor="b"/>
-          <a:lstStyle/>
-          <a:p>
-            <a:pPr algn="r" indent="0" marL="0">
-              <a:buNone/>
-            </a:pPr>
-            <a:r>
-              <a:rPr lang="en-US" sz="15000" b="1" dirty="0">
-                <a:solidFill>
-                  <a:srgbClr val="17171F"/>
-                </a:solidFill>
-                <a:latin typeface="Arial" pitchFamily="34" charset="0"/>
-                <a:ea typeface="Arial" pitchFamily="34" charset="-122"/>
-                <a:cs typeface="Arial" pitchFamily="34" charset="-120"/>
-              </a:rPr>
-              <a:t>2013</a:t>
-            </a:r>
-            <a:endParaRPr lang="en-US" sz="15000" dirty="0"/>
-          </a:p>
-        </p:txBody>
-      </p:sp>
-      <p:sp>
-        <p:nvSpPr>
-          <p:cNvPr id="5" name="Text 3"/>
+              <a:rPr lang="en-US" sz="700" dirty="0">
+                <a:solidFill>
+                  <a:srgbClr val="E6E6EC"/>
+                </a:solidFill>
+                <a:latin typeface="Arial" pitchFamily="34" charset="0"/>
+                <a:ea typeface="Arial" pitchFamily="34" charset="-122"/>
+                <a:cs typeface="Arial" pitchFamily="34" charset="-120"/>
+              </a:rPr>
+              <a:t>Витебск, 2016 · Фото: Okras, CC BY-SA 4.0</a:t>
+            </a:r>
+            <a:endParaRPr lang="en-US" sz="700" dirty="0"/>
+          </a:p>
+        </p:txBody>
+      </p:sp>
+      <p:sp>
+        <p:nvSpPr>
+          <p:cNvPr id="6" name="Text 3"/>
           <p:cNvSpPr txBox="1"/>
           <p:nvPr/>
         </p:nvSpPr>
         <p:spPr>
           <a:xfrm>
             <a:off x="548640" y="731520"/>
-            <a:ext cx="8046720" cy="1188720"/>
+            <a:ext cx="4480560" cy="1188720"/>
           </a:xfrm>
           <a:prstGeom prst="rect">
             <a:avLst/>
@@ -4745,13 +4897,13 @@
       </p:sp>
       <p:sp>
         <p:nvSpPr>
-          <p:cNvPr id="6" name="Shape 4"/>
+          <p:cNvPr id="7" name="Shape 4"/>
           <p:cNvSpPr/>
           <p:nvPr/>
         </p:nvSpPr>
         <p:spPr>
           <a:xfrm>
-            <a:off x="548640" y="2331720"/>
+            <a:off x="548640" y="2194560"/>
             <a:ext cx="128016" cy="128016"/>
           </a:xfrm>
           <a:prstGeom prst="ellipse">
@@ -4770,14 +4922,14 @@
       </p:sp>
       <p:sp>
         <p:nvSpPr>
-          <p:cNvPr id="7" name="Text 5"/>
-          <p:cNvSpPr txBox="1"/>
-          <p:nvPr/>
-        </p:nvSpPr>
-        <p:spPr>
-          <a:xfrm>
-            <a:off x="868680" y="2240280"/>
-            <a:ext cx="3840480" cy="310896"/>
+          <p:cNvPr id="8" name="Text 5"/>
+          <p:cNvSpPr txBox="1"/>
+          <p:nvPr/>
+        </p:nvSpPr>
+        <p:spPr>
+          <a:xfrm>
+            <a:off x="868680" y="2103120"/>
+            <a:ext cx="4114800" cy="310896"/>
           </a:xfrm>
           <a:prstGeom prst="rect">
             <a:avLst/>
@@ -4823,13 +4975,13 @@
       </p:sp>
       <p:sp>
         <p:nvSpPr>
-          <p:cNvPr id="8" name="Shape 6"/>
+          <p:cNvPr id="9" name="Shape 6"/>
           <p:cNvSpPr/>
           <p:nvPr/>
         </p:nvSpPr>
         <p:spPr>
           <a:xfrm>
-            <a:off x="548640" y="2807208"/>
+            <a:off x="548640" y="2615184"/>
             <a:ext cx="128016" cy="128016"/>
           </a:xfrm>
           <a:prstGeom prst="ellipse">
@@ -4848,14 +5000,14 @@
       </p:sp>
       <p:sp>
         <p:nvSpPr>
-          <p:cNvPr id="9" name="Text 7"/>
-          <p:cNvSpPr txBox="1"/>
-          <p:nvPr/>
-        </p:nvSpPr>
-        <p:spPr>
-          <a:xfrm>
-            <a:off x="868680" y="2715768"/>
-            <a:ext cx="3840480" cy="310896"/>
+          <p:cNvPr id="10" name="Text 7"/>
+          <p:cNvSpPr txBox="1"/>
+          <p:nvPr/>
+        </p:nvSpPr>
+        <p:spPr>
+          <a:xfrm>
+            <a:off x="868680" y="2523744"/>
+            <a:ext cx="4114800" cy="310896"/>
           </a:xfrm>
           <a:prstGeom prst="rect">
             <a:avLst/>
@@ -4901,13 +5053,13 @@
       </p:sp>
       <p:sp>
         <p:nvSpPr>
-          <p:cNvPr id="10" name="Shape 8"/>
+          <p:cNvPr id="11" name="Shape 8"/>
           <p:cNvSpPr/>
           <p:nvPr/>
         </p:nvSpPr>
         <p:spPr>
           <a:xfrm>
-            <a:off x="548640" y="3282696"/>
+            <a:off x="548640" y="3035808"/>
             <a:ext cx="128016" cy="128016"/>
           </a:xfrm>
           <a:prstGeom prst="ellipse">
@@ -4926,14 +5078,14 @@
       </p:sp>
       <p:sp>
         <p:nvSpPr>
-          <p:cNvPr id="11" name="Text 9"/>
-          <p:cNvSpPr txBox="1"/>
-          <p:nvPr/>
-        </p:nvSpPr>
-        <p:spPr>
-          <a:xfrm>
-            <a:off x="868680" y="3191256"/>
-            <a:ext cx="3840480" cy="310896"/>
+          <p:cNvPr id="12" name="Text 9"/>
+          <p:cNvSpPr txBox="1"/>
+          <p:nvPr/>
+        </p:nvSpPr>
+        <p:spPr>
+          <a:xfrm>
+            <a:off x="868680" y="2944368"/>
+            <a:ext cx="4114800" cy="310896"/>
           </a:xfrm>
           <a:prstGeom prst="rect">
             <a:avLst/>
@@ -4971,7 +5123,7 @@
                 <a:ea typeface="Arial" pitchFamily="34" charset="-122"/>
                 <a:cs typeface="Arial" pitchFamily="34" charset="-120"/>
               </a:rPr>
-              <a:t>   первый сольный</a:t>
+              <a:t>   после ухода</a:t>
             </a:r>
             <a:endParaRPr lang="en-US" sz="1500" dirty="0"/>
           </a:p>
@@ -4979,13 +5131,13 @@
       </p:sp>
       <p:sp>
         <p:nvSpPr>
-          <p:cNvPr id="12" name="Shape 10"/>
+          <p:cNvPr id="13" name="Shape 10"/>
           <p:cNvSpPr/>
           <p:nvPr/>
         </p:nvSpPr>
         <p:spPr>
           <a:xfrm>
-            <a:off x="548640" y="3758184"/>
+            <a:off x="548640" y="3456432"/>
             <a:ext cx="128016" cy="128016"/>
           </a:xfrm>
           <a:prstGeom prst="ellipse">
@@ -5004,14 +5156,14 @@
       </p:sp>
       <p:sp>
         <p:nvSpPr>
-          <p:cNvPr id="13" name="Text 11"/>
-          <p:cNvSpPr txBox="1"/>
-          <p:nvPr/>
-        </p:nvSpPr>
-        <p:spPr>
-          <a:xfrm>
-            <a:off x="868680" y="3666744"/>
-            <a:ext cx="3840480" cy="310896"/>
+          <p:cNvPr id="14" name="Text 11"/>
+          <p:cNvSpPr txBox="1"/>
+          <p:nvPr/>
+        </p:nvSpPr>
+        <p:spPr>
+          <a:xfrm>
+            <a:off x="868680" y="3364992"/>
+            <a:ext cx="4114800" cy="310896"/>
           </a:xfrm>
           <a:prstGeom prst="rect">
             <a:avLst/>
@@ -5057,18 +5209,18 @@
       </p:sp>
       <p:sp>
         <p:nvSpPr>
-          <p:cNvPr id="14" name="Shape 12"/>
+          <p:cNvPr id="15" name="Shape 12"/>
           <p:cNvSpPr/>
           <p:nvPr/>
         </p:nvSpPr>
         <p:spPr>
           <a:xfrm>
-            <a:off x="5120640" y="914400"/>
-            <a:ext cx="3474720" cy="685800"/>
+            <a:off x="548640" y="3931920"/>
+            <a:ext cx="4297680" cy="594360"/>
           </a:xfrm>
           <a:prstGeom prst="roundRect">
             <a:avLst>
-              <a:gd name="adj" fmla="val 10667"/>
+              <a:gd name="adj" fmla="val 12308"/>
             </a:avLst>
           </a:prstGeom>
           <a:solidFill>
@@ -5084,14 +5236,14 @@
       </p:sp>
       <p:sp>
         <p:nvSpPr>
-          <p:cNvPr id="15" name="Text 13"/>
-          <p:cNvSpPr txBox="1"/>
-          <p:nvPr/>
-        </p:nvSpPr>
-        <p:spPr>
-          <a:xfrm>
-            <a:off x="5303520" y="914400"/>
-            <a:ext cx="3200400" cy="685800"/>
+          <p:cNvPr id="16" name="Text 13"/>
+          <p:cNvSpPr txBox="1"/>
+          <p:nvPr/>
+        </p:nvSpPr>
+        <p:spPr>
+          <a:xfrm>
+            <a:off x="731520" y="3931920"/>
+            <a:ext cx="4023360" cy="594360"/>
           </a:xfrm>
           <a:prstGeom prst="rect">
             <a:avLst/>
@@ -5118,6 +5270,45 @@
               <a:t>Слушают имя, а не вывеску лейбла</a:t>
             </a:r>
             <a:endParaRPr lang="en-US" sz="1400" dirty="0"/>
+          </a:p>
+        </p:txBody>
+      </p:sp>
+      <p:sp>
+        <p:nvSpPr>
+          <p:cNvPr id="17" name="Text 14"/>
+          <p:cNvSpPr txBox="1"/>
+          <p:nvPr/>
+        </p:nvSpPr>
+        <p:spPr>
+          <a:xfrm>
+            <a:off x="4023360" y="4663440"/>
+            <a:ext cx="914400" cy="228600"/>
+          </a:xfrm>
+          <a:prstGeom prst="rect">
+            <a:avLst/>
+          </a:prstGeom>
+          <a:noFill/>
+          <a:ln/>
+        </p:spPr>
+        <p:txBody>
+          <a:bodyPr wrap="square" lIns="0" tIns="0" rIns="0" bIns="0" rtlCol="0" anchor="ctr"/>
+          <a:lstStyle/>
+          <a:p>
+            <a:pPr algn="r" indent="0" marL="0">
+              <a:buNone/>
+            </a:pPr>
+            <a:r>
+              <a:rPr lang="en-US" sz="900" dirty="0">
+                <a:solidFill>
+                  <a:srgbClr val="8E8E9C"/>
+                </a:solidFill>
+                <a:latin typeface="Arial" pitchFamily="34" charset="0"/>
+                <a:ea typeface="Arial" pitchFamily="34" charset="-122"/>
+                <a:cs typeface="Arial" pitchFamily="34" charset="-120"/>
+              </a:rPr>
+              <a:t>05 / 10</a:t>
+            </a:r>
+            <a:endParaRPr lang="en-US" sz="900" dirty="0"/>
           </a:p>
         </p:txBody>
       </p:sp>
@@ -5162,7 +5353,7 @@
         <p:spPr>
           <a:xfrm>
             <a:off x="548640" y="411480"/>
-            <a:ext cx="5486400" cy="274320"/>
+            <a:ext cx="4572000" cy="274320"/>
           </a:xfrm>
           <a:prstGeom prst="rect">
             <a:avLst/>
@@ -5195,45 +5386,6 @@
       <p:sp>
         <p:nvSpPr>
           <p:cNvPr id="3" name="Text 1"/>
-          <p:cNvSpPr txBox="1"/>
-          <p:nvPr/>
-        </p:nvSpPr>
-        <p:spPr>
-          <a:xfrm>
-            <a:off x="7680960" y="4663440"/>
-            <a:ext cx="914400" cy="228600"/>
-          </a:xfrm>
-          <a:prstGeom prst="rect">
-            <a:avLst/>
-          </a:prstGeom>
-          <a:noFill/>
-          <a:ln/>
-        </p:spPr>
-        <p:txBody>
-          <a:bodyPr wrap="square" lIns="0" tIns="0" rIns="0" bIns="0" rtlCol="0" anchor="ctr"/>
-          <a:lstStyle/>
-          <a:p>
-            <a:pPr algn="r" indent="0" marL="0">
-              <a:buNone/>
-            </a:pPr>
-            <a:r>
-              <a:rPr lang="en-US" sz="900" dirty="0">
-                <a:solidFill>
-                  <a:srgbClr val="8E8E9C"/>
-                </a:solidFill>
-                <a:latin typeface="Arial" pitchFamily="34" charset="0"/>
-                <a:ea typeface="Arial" pitchFamily="34" charset="-122"/>
-                <a:cs typeface="Arial" pitchFamily="34" charset="-120"/>
-              </a:rPr>
-              <a:t>06 / 10</a:t>
-            </a:r>
-            <a:endParaRPr lang="en-US" sz="900" dirty="0"/>
-          </a:p>
-        </p:txBody>
-      </p:sp>
-      <p:sp>
-        <p:nvSpPr>
-          <p:cNvPr id="4" name="Text 2"/>
           <p:cNvSpPr txBox="1"/>
           <p:nvPr/>
         </p:nvSpPr>
@@ -5272,7 +5424,7 @@
       </p:sp>
       <p:sp>
         <p:nvSpPr>
-          <p:cNvPr id="5" name="Text 3"/>
+          <p:cNvPr id="4" name="Text 2"/>
           <p:cNvSpPr txBox="1"/>
           <p:nvPr/>
         </p:nvSpPr>
@@ -5328,7 +5480,7 @@
       </p:sp>
       <p:sp>
         <p:nvSpPr>
-          <p:cNvPr id="6" name="Text 4"/>
+          <p:cNvPr id="5" name="Text 3"/>
           <p:cNvSpPr txBox="1"/>
           <p:nvPr/>
         </p:nvSpPr>
@@ -5367,7 +5519,7 @@
       </p:sp>
       <p:sp>
         <p:nvSpPr>
-          <p:cNvPr id="7" name="Shape 5"/>
+          <p:cNvPr id="6" name="Shape 4"/>
           <p:cNvSpPr/>
           <p:nvPr/>
         </p:nvSpPr>
@@ -5394,7 +5546,7 @@
       </p:sp>
       <p:sp>
         <p:nvSpPr>
-          <p:cNvPr id="8" name="Text 6"/>
+          <p:cNvPr id="7" name="Text 5"/>
           <p:cNvSpPr txBox="1"/>
           <p:nvPr/>
         </p:nvSpPr>
@@ -5456,7 +5608,7 @@
       </p:sp>
       <p:sp>
         <p:nvSpPr>
-          <p:cNvPr id="9" name="Shape 7"/>
+          <p:cNvPr id="8" name="Shape 6"/>
           <p:cNvSpPr/>
           <p:nvPr/>
         </p:nvSpPr>
@@ -5483,7 +5635,7 @@
       </p:sp>
       <p:sp>
         <p:nvSpPr>
-          <p:cNvPr id="10" name="Text 8"/>
+          <p:cNvPr id="9" name="Text 7"/>
           <p:cNvSpPr txBox="1"/>
           <p:nvPr/>
         </p:nvSpPr>
@@ -5540,6 +5692,45 @@
               <a:t>+ фит с Григорием Лепсом</a:t>
             </a:r>
             <a:endParaRPr lang="en-US" sz="1500" dirty="0"/>
+          </a:p>
+        </p:txBody>
+      </p:sp>
+      <p:sp>
+        <p:nvSpPr>
+          <p:cNvPr id="10" name="Text 8"/>
+          <p:cNvSpPr txBox="1"/>
+          <p:nvPr/>
+        </p:nvSpPr>
+        <p:spPr>
+          <a:xfrm>
+            <a:off x="7680960" y="4663440"/>
+            <a:ext cx="914400" cy="228600"/>
+          </a:xfrm>
+          <a:prstGeom prst="rect">
+            <a:avLst/>
+          </a:prstGeom>
+          <a:noFill/>
+          <a:ln/>
+        </p:spPr>
+        <p:txBody>
+          <a:bodyPr wrap="square" lIns="0" tIns="0" rIns="0" bIns="0" rtlCol="0" anchor="ctr"/>
+          <a:lstStyle/>
+          <a:p>
+            <a:pPr algn="r" indent="0" marL="0">
+              <a:buNone/>
+            </a:pPr>
+            <a:r>
+              <a:rPr lang="en-US" sz="900" dirty="0">
+                <a:solidFill>
+                  <a:srgbClr val="8E8E9C"/>
+                </a:solidFill>
+                <a:latin typeface="Arial" pitchFamily="34" charset="0"/>
+                <a:ea typeface="Arial" pitchFamily="34" charset="-122"/>
+                <a:cs typeface="Arial" pitchFamily="34" charset="-120"/>
+              </a:rPr>
+              <a:t>06 / 10</a:t>
+            </a:r>
+            <a:endParaRPr lang="en-US" sz="900" dirty="0"/>
           </a:p>
         </p:txBody>
       </p:sp>
@@ -5584,7 +5775,7 @@
         <p:spPr>
           <a:xfrm>
             <a:off x="548640" y="411480"/>
-            <a:ext cx="5486400" cy="274320"/>
+            <a:ext cx="4572000" cy="274320"/>
           </a:xfrm>
           <a:prstGeom prst="rect">
             <a:avLst/>
@@ -5622,24 +5813,158 @@
         </p:nvSpPr>
         <p:spPr>
           <a:xfrm>
-            <a:off x="7680960" y="4663440"/>
-            <a:ext cx="914400" cy="228600"/>
-          </a:xfrm>
-          <a:prstGeom prst="rect">
-            <a:avLst/>
-          </a:prstGeom>
-          <a:noFill/>
-          <a:ln/>
-        </p:spPr>
-        <p:txBody>
-          <a:bodyPr wrap="square" lIns="0" tIns="0" rIns="0" bIns="0" rtlCol="0" anchor="ctr"/>
-          <a:lstStyle/>
-          <a:p>
-            <a:pPr algn="r" indent="0" marL="0">
-              <a:buNone/>
-            </a:pPr>
-            <a:r>
-              <a:rPr lang="en-US" sz="900" dirty="0">
+            <a:off x="548640" y="731520"/>
+            <a:ext cx="3657600" cy="1188720"/>
+          </a:xfrm>
+          <a:prstGeom prst="rect">
+            <a:avLst/>
+          </a:prstGeom>
+          <a:noFill/>
+          <a:ln/>
+        </p:spPr>
+        <p:txBody>
+          <a:bodyPr wrap="square" lIns="0" tIns="0" rIns="0" bIns="0" rtlCol="0" anchor="t"/>
+          <a:lstStyle/>
+          <a:p>
+            <a:pPr indent="0" marL="0">
+              <a:buNone/>
+            </a:pPr>
+            <a:r>
+              <a:rPr lang="en-US" sz="3400" b="1" dirty="0">
+                <a:solidFill>
+                  <a:srgbClr val="F4F4F6"/>
+                </a:solidFill>
+                <a:latin typeface="Arial" pitchFamily="34" charset="0"/>
+                <a:ea typeface="Arial" pitchFamily="34" charset="-122"/>
+                <a:cs typeface="Arial" pitchFamily="34" charset="-120"/>
+              </a:rPr>
+              <a:t>Из радио —</a:t>
+            </a:r>
+            <a:endParaRPr lang="en-US" sz="3400" dirty="0"/>
+          </a:p>
+          <a:p>
+            <a:pPr indent="0" marL="0">
+              <a:buNone/>
+            </a:pPr>
+            <a:r>
+              <a:rPr lang="en-US" sz="3400" b="1" dirty="0">
+                <a:solidFill>
+                  <a:srgbClr val="F4F4F6"/>
+                </a:solidFill>
+                <a:latin typeface="Arial" pitchFamily="34" charset="0"/>
+                <a:ea typeface="Arial" pitchFamily="34" charset="-122"/>
+                <a:cs typeface="Arial" pitchFamily="34" charset="-120"/>
+              </a:rPr>
+              <a:t>в рилсы</a:t>
+            </a:r>
+            <a:endParaRPr lang="en-US" sz="3400" dirty="0"/>
+          </a:p>
+        </p:txBody>
+      </p:sp>
+      <p:sp>
+        <p:nvSpPr>
+          <p:cNvPr id="4" name="Text 2"/>
+          <p:cNvSpPr txBox="1"/>
+          <p:nvPr/>
+        </p:nvSpPr>
+        <p:spPr>
+          <a:xfrm>
+            <a:off x="548640" y="2176272"/>
+            <a:ext cx="502920" cy="292608"/>
+          </a:xfrm>
+          <a:prstGeom prst="rect">
+            <a:avLst/>
+          </a:prstGeom>
+          <a:noFill/>
+          <a:ln/>
+        </p:spPr>
+        <p:txBody>
+          <a:bodyPr wrap="square" lIns="0" tIns="0" rIns="0" bIns="0" rtlCol="0" anchor="ctr"/>
+          <a:lstStyle/>
+          <a:p>
+            <a:pPr indent="0" marL="0">
+              <a:buNone/>
+            </a:pPr>
+            <a:r>
+              <a:rPr lang="en-US" sz="1400" b="1" dirty="0">
+                <a:solidFill>
+                  <a:srgbClr val="8B7CF6"/>
+                </a:solidFill>
+                <a:latin typeface="Arial" pitchFamily="34" charset="0"/>
+                <a:ea typeface="Arial" pitchFamily="34" charset="-122"/>
+                <a:cs typeface="Arial" pitchFamily="34" charset="-120"/>
+              </a:rPr>
+              <a:t>01</a:t>
+            </a:r>
+            <a:endParaRPr lang="en-US" sz="1400" dirty="0"/>
+          </a:p>
+        </p:txBody>
+      </p:sp>
+      <p:sp>
+        <p:nvSpPr>
+          <p:cNvPr id="5" name="Text 3"/>
+          <p:cNvSpPr txBox="1"/>
+          <p:nvPr/>
+        </p:nvSpPr>
+        <p:spPr>
+          <a:xfrm>
+            <a:off x="1097280" y="2176272"/>
+            <a:ext cx="2926080" cy="292608"/>
+          </a:xfrm>
+          <a:prstGeom prst="rect">
+            <a:avLst/>
+          </a:prstGeom>
+          <a:noFill/>
+          <a:ln/>
+        </p:spPr>
+        <p:txBody>
+          <a:bodyPr wrap="square" lIns="0" tIns="0" rIns="0" bIns="0" rtlCol="0" anchor="ctr"/>
+          <a:lstStyle/>
+          <a:p>
+            <a:pPr indent="0" marL="0">
+              <a:buNone/>
+            </a:pPr>
+            <a:r>
+              <a:rPr lang="en-US" sz="1600" b="1" dirty="0">
+                <a:solidFill>
+                  <a:srgbClr val="F4F4F6"/>
+                </a:solidFill>
+                <a:latin typeface="Arial" pitchFamily="34" charset="0"/>
+                <a:ea typeface="Arial" pitchFamily="34" charset="-122"/>
+                <a:cs typeface="Arial" pitchFamily="34" charset="-120"/>
+              </a:rPr>
+              <a:t>«Хавчик»</a:t>
+            </a:r>
+            <a:endParaRPr lang="en-US" sz="1600" dirty="0"/>
+          </a:p>
+        </p:txBody>
+      </p:sp>
+      <p:sp>
+        <p:nvSpPr>
+          <p:cNvPr id="6" name="Text 4"/>
+          <p:cNvSpPr txBox="1"/>
+          <p:nvPr/>
+        </p:nvSpPr>
+        <p:spPr>
+          <a:xfrm>
+            <a:off x="1097280" y="2468880"/>
+            <a:ext cx="2926080" cy="274320"/>
+          </a:xfrm>
+          <a:prstGeom prst="rect">
+            <a:avLst/>
+          </a:prstGeom>
+          <a:noFill/>
+          <a:ln/>
+        </p:spPr>
+        <p:txBody>
+          <a:bodyPr wrap="square" lIns="0" tIns="0" rIns="0" bIns="0" rtlCol="0" anchor="ctr"/>
+          <a:lstStyle/>
+          <a:p>
+            <a:pPr indent="0" marL="0">
+              <a:buNone/>
+            </a:pPr>
+            <a:r>
+              <a:rPr lang="en-US" sz="1200" dirty="0">
                 <a:solidFill>
                   <a:srgbClr val="8E8E9C"/>
                 </a:solidFill>
@@ -5647,38 +5972,77 @@
                 <a:ea typeface="Arial" pitchFamily="34" charset="-122"/>
                 <a:cs typeface="Arial" pitchFamily="34" charset="-120"/>
               </a:rPr>
-              <a:t>07 / 10</a:t>
-            </a:r>
-            <a:endParaRPr lang="en-US" sz="900" dirty="0"/>
-          </a:p>
-        </p:txBody>
-      </p:sp>
-      <p:sp>
-        <p:nvSpPr>
-          <p:cNvPr id="4" name="Text 2"/>
-          <p:cNvSpPr txBox="1"/>
-          <p:nvPr/>
-        </p:nvSpPr>
-        <p:spPr>
-          <a:xfrm>
-            <a:off x="548640" y="731520"/>
-            <a:ext cx="8046720" cy="822960"/>
-          </a:xfrm>
-          <a:prstGeom prst="rect">
-            <a:avLst/>
-          </a:prstGeom>
-          <a:noFill/>
-          <a:ln/>
-        </p:spPr>
-        <p:txBody>
-          <a:bodyPr wrap="square" lIns="0" tIns="0" rIns="0" bIns="0" rtlCol="0" anchor="t"/>
-          <a:lstStyle/>
-          <a:p>
-            <a:pPr indent="0" marL="0">
-              <a:buNone/>
-            </a:pPr>
-            <a:r>
-              <a:rPr lang="en-US" sz="3400" b="1" dirty="0">
+              <a:t>С Тимати и Даней Милохиным</a:t>
+            </a:r>
+            <a:endParaRPr lang="en-US" sz="1200" dirty="0"/>
+          </a:p>
+        </p:txBody>
+      </p:sp>
+      <p:sp>
+        <p:nvSpPr>
+          <p:cNvPr id="7" name="Text 5"/>
+          <p:cNvSpPr txBox="1"/>
+          <p:nvPr/>
+        </p:nvSpPr>
+        <p:spPr>
+          <a:xfrm>
+            <a:off x="548640" y="2889504"/>
+            <a:ext cx="502920" cy="292608"/>
+          </a:xfrm>
+          <a:prstGeom prst="rect">
+            <a:avLst/>
+          </a:prstGeom>
+          <a:noFill/>
+          <a:ln/>
+        </p:spPr>
+        <p:txBody>
+          <a:bodyPr wrap="square" lIns="0" tIns="0" rIns="0" bIns="0" rtlCol="0" anchor="ctr"/>
+          <a:lstStyle/>
+          <a:p>
+            <a:pPr indent="0" marL="0">
+              <a:buNone/>
+            </a:pPr>
+            <a:r>
+              <a:rPr lang="en-US" sz="1400" b="1" dirty="0">
+                <a:solidFill>
+                  <a:srgbClr val="8B7CF6"/>
+                </a:solidFill>
+                <a:latin typeface="Arial" pitchFamily="34" charset="0"/>
+                <a:ea typeface="Arial" pitchFamily="34" charset="-122"/>
+                <a:cs typeface="Arial" pitchFamily="34" charset="-120"/>
+              </a:rPr>
+              <a:t>02</a:t>
+            </a:r>
+            <a:endParaRPr lang="en-US" sz="1400" dirty="0"/>
+          </a:p>
+        </p:txBody>
+      </p:sp>
+      <p:sp>
+        <p:nvSpPr>
+          <p:cNvPr id="8" name="Text 6"/>
+          <p:cNvSpPr txBox="1"/>
+          <p:nvPr/>
+        </p:nvSpPr>
+        <p:spPr>
+          <a:xfrm>
+            <a:off x="1097280" y="2889504"/>
+            <a:ext cx="2926080" cy="292608"/>
+          </a:xfrm>
+          <a:prstGeom prst="rect">
+            <a:avLst/>
+          </a:prstGeom>
+          <a:noFill/>
+          <a:ln/>
+        </p:spPr>
+        <p:txBody>
+          <a:bodyPr wrap="square" lIns="0" tIns="0" rIns="0" bIns="0" rtlCol="0" anchor="ctr"/>
+          <a:lstStyle/>
+          <a:p>
+            <a:pPr indent="0" marL="0">
+              <a:buNone/>
+            </a:pPr>
+            <a:r>
+              <a:rPr lang="en-US" sz="1600" b="1" dirty="0">
                 <a:solidFill>
                   <a:srgbClr val="F4F4F6"/>
                 </a:solidFill>
@@ -5686,67 +6050,171 @@
                 <a:ea typeface="Arial" pitchFamily="34" charset="-122"/>
                 <a:cs typeface="Arial" pitchFamily="34" charset="-120"/>
               </a:rPr>
-              <a:t>Из радио — в рилсы</a:t>
-            </a:r>
-            <a:endParaRPr lang="en-US" sz="3400" dirty="0"/>
-          </a:p>
-        </p:txBody>
-      </p:sp>
-      <p:sp>
-        <p:nvSpPr>
-          <p:cNvPr id="5" name="Shape 3"/>
-          <p:cNvSpPr/>
-          <p:nvPr/>
-        </p:nvSpPr>
-        <p:spPr>
-          <a:xfrm>
-            <a:off x="548640" y="1783080"/>
-            <a:ext cx="2468880" cy="2240280"/>
-          </a:xfrm>
-          <a:prstGeom prst="roundRect">
-            <a:avLst>
-              <a:gd name="adj" fmla="val 3265"/>
-            </a:avLst>
-          </a:prstGeom>
-          <a:solidFill>
-            <a:srgbClr val="15151D"/>
-          </a:solidFill>
-          <a:ln w="9525">
-            <a:solidFill>
-              <a:srgbClr val="2A2A36"/>
-            </a:solidFill>
-            <a:prstDash val="solid"/>
-          </a:ln>
-        </p:spPr>
-      </p:sp>
-      <p:sp>
-        <p:nvSpPr>
-          <p:cNvPr id="6" name="Shape 4"/>
-          <p:cNvSpPr/>
-          <p:nvPr/>
-        </p:nvSpPr>
-        <p:spPr>
-          <a:xfrm>
-            <a:off x="822960" y="2057400"/>
-            <a:ext cx="548640" cy="548640"/>
-          </a:xfrm>
-          <a:prstGeom prst="ellipse">
-            <a:avLst/>
-          </a:prstGeom>
-          <a:solidFill>
-            <a:srgbClr val="231F3D"/>
-          </a:solidFill>
-          <a:ln w="12700">
-            <a:solidFill>
-              <a:srgbClr val="231F3D"/>
-            </a:solidFill>
-            <a:prstDash val="solid"/>
-          </a:ln>
-        </p:spPr>
+              <a:t>«На чиле»</a:t>
+            </a:r>
+            <a:endParaRPr lang="en-US" sz="1600" dirty="0"/>
+          </a:p>
+        </p:txBody>
+      </p:sp>
+      <p:sp>
+        <p:nvSpPr>
+          <p:cNvPr id="9" name="Text 7"/>
+          <p:cNvSpPr txBox="1"/>
+          <p:nvPr/>
+        </p:nvSpPr>
+        <p:spPr>
+          <a:xfrm>
+            <a:off x="1097280" y="3182112"/>
+            <a:ext cx="2926080" cy="274320"/>
+          </a:xfrm>
+          <a:prstGeom prst="rect">
+            <a:avLst/>
+          </a:prstGeom>
+          <a:noFill/>
+          <a:ln/>
+        </p:spPr>
+        <p:txBody>
+          <a:bodyPr wrap="square" lIns="0" tIns="0" rIns="0" bIns="0" rtlCol="0" anchor="ctr"/>
+          <a:lstStyle/>
+          <a:p>
+            <a:pPr indent="0" marL="0">
+              <a:buNone/>
+            </a:pPr>
+            <a:r>
+              <a:rPr lang="en-US" sz="1200" dirty="0">
+                <a:solidFill>
+                  <a:srgbClr val="8E8E9C"/>
+                </a:solidFill>
+                <a:latin typeface="Arial" pitchFamily="34" charset="0"/>
+                <a:ea typeface="Arial" pitchFamily="34" charset="-122"/>
+                <a:cs typeface="Arial" pitchFamily="34" charset="-120"/>
+              </a:rPr>
+              <a:t>Сайфер с половиной рэп-тусовки</a:t>
+            </a:r>
+            <a:endParaRPr lang="en-US" sz="1200" dirty="0"/>
+          </a:p>
+        </p:txBody>
+      </p:sp>
+      <p:sp>
+        <p:nvSpPr>
+          <p:cNvPr id="10" name="Text 8"/>
+          <p:cNvSpPr txBox="1"/>
+          <p:nvPr/>
+        </p:nvSpPr>
+        <p:spPr>
+          <a:xfrm>
+            <a:off x="548640" y="3602736"/>
+            <a:ext cx="502920" cy="292608"/>
+          </a:xfrm>
+          <a:prstGeom prst="rect">
+            <a:avLst/>
+          </a:prstGeom>
+          <a:noFill/>
+          <a:ln/>
+        </p:spPr>
+        <p:txBody>
+          <a:bodyPr wrap="square" lIns="0" tIns="0" rIns="0" bIns="0" rtlCol="0" anchor="ctr"/>
+          <a:lstStyle/>
+          <a:p>
+            <a:pPr indent="0" marL="0">
+              <a:buNone/>
+            </a:pPr>
+            <a:r>
+              <a:rPr lang="en-US" sz="1400" b="1" dirty="0">
+                <a:solidFill>
+                  <a:srgbClr val="8B7CF6"/>
+                </a:solidFill>
+                <a:latin typeface="Arial" pitchFamily="34" charset="0"/>
+                <a:ea typeface="Arial" pitchFamily="34" charset="-122"/>
+                <a:cs typeface="Arial" pitchFamily="34" charset="-120"/>
+              </a:rPr>
+              <a:t>03</a:t>
+            </a:r>
+            <a:endParaRPr lang="en-US" sz="1400" dirty="0"/>
+          </a:p>
+        </p:txBody>
+      </p:sp>
+      <p:sp>
+        <p:nvSpPr>
+          <p:cNvPr id="11" name="Text 9"/>
+          <p:cNvSpPr txBox="1"/>
+          <p:nvPr/>
+        </p:nvSpPr>
+        <p:spPr>
+          <a:xfrm>
+            <a:off x="1097280" y="3602736"/>
+            <a:ext cx="2926080" cy="292608"/>
+          </a:xfrm>
+          <a:prstGeom prst="rect">
+            <a:avLst/>
+          </a:prstGeom>
+          <a:noFill/>
+          <a:ln/>
+        </p:spPr>
+        <p:txBody>
+          <a:bodyPr wrap="square" lIns="0" tIns="0" rIns="0" bIns="0" rtlCol="0" anchor="ctr"/>
+          <a:lstStyle/>
+          <a:p>
+            <a:pPr indent="0" marL="0">
+              <a:buNone/>
+            </a:pPr>
+            <a:r>
+              <a:rPr lang="en-US" sz="1600" b="1" dirty="0">
+                <a:solidFill>
+                  <a:srgbClr val="F4F4F6"/>
+                </a:solidFill>
+                <a:latin typeface="Arial" pitchFamily="34" charset="0"/>
+                <a:ea typeface="Arial" pitchFamily="34" charset="-122"/>
+                <a:cs typeface="Arial" pitchFamily="34" charset="-120"/>
+              </a:rPr>
+              <a:t>«Bang»</a:t>
+            </a:r>
+            <a:endParaRPr lang="en-US" sz="1600" dirty="0"/>
+          </a:p>
+        </p:txBody>
+      </p:sp>
+      <p:sp>
+        <p:nvSpPr>
+          <p:cNvPr id="12" name="Text 10"/>
+          <p:cNvSpPr txBox="1"/>
+          <p:nvPr/>
+        </p:nvSpPr>
+        <p:spPr>
+          <a:xfrm>
+            <a:off x="1097280" y="3895344"/>
+            <a:ext cx="2926080" cy="274320"/>
+          </a:xfrm>
+          <a:prstGeom prst="rect">
+            <a:avLst/>
+          </a:prstGeom>
+          <a:noFill/>
+          <a:ln/>
+        </p:spPr>
+        <p:txBody>
+          <a:bodyPr wrap="square" lIns="0" tIns="0" rIns="0" bIns="0" rtlCol="0" anchor="ctr"/>
+          <a:lstStyle/>
+          <a:p>
+            <a:pPr indent="0" marL="0">
+              <a:buNone/>
+            </a:pPr>
+            <a:r>
+              <a:rPr lang="en-US" sz="1200" dirty="0">
+                <a:solidFill>
+                  <a:srgbClr val="8E8E9C"/>
+                </a:solidFill>
+                <a:latin typeface="Arial" pitchFamily="34" charset="0"/>
+                <a:ea typeface="Arial" pitchFamily="34" charset="-122"/>
+                <a:cs typeface="Arial" pitchFamily="34" charset="-120"/>
+              </a:rPr>
+              <a:t>Альбом с автотюновым трэпом</a:t>
+            </a:r>
+            <a:endParaRPr lang="en-US" sz="1200" dirty="0"/>
+          </a:p>
+        </p:txBody>
       </p:sp>
       <p:pic>
         <p:nvPicPr>
-          <p:cNvPr id="7" name="Image 0" descr="preencoded.png">    </p:cNvPr>
+          <p:cNvPr id="13" name="Image 0" descr="Мем: когда фраза из стрима уже стала треком">    </p:cNvPr>
           <p:cNvPicPr>
             <a:picLocks noChangeAspect="1"/>
           </p:cNvPicPr>
@@ -5760,147 +6228,17 @@
         </p:blipFill>
         <p:spPr>
           <a:xfrm>
-            <a:off x="960120" y="2194560"/>
-            <a:ext cx="274320" cy="274320"/>
+            <a:off x="4206240" y="1188720"/>
+            <a:ext cx="2148840" cy="2148840"/>
           </a:xfrm>
           <a:prstGeom prst="rect">
             <a:avLst/>
           </a:prstGeom>
         </p:spPr>
       </p:pic>
-      <p:sp>
-        <p:nvSpPr>
-          <p:cNvPr id="8" name="Text 5"/>
-          <p:cNvSpPr txBox="1"/>
-          <p:nvPr/>
-        </p:nvSpPr>
-        <p:spPr>
-          <a:xfrm>
-            <a:off x="822960" y="2834640"/>
-            <a:ext cx="1920240" cy="365760"/>
-          </a:xfrm>
-          <a:prstGeom prst="rect">
-            <a:avLst/>
-          </a:prstGeom>
-          <a:noFill/>
-          <a:ln/>
-        </p:spPr>
-        <p:txBody>
-          <a:bodyPr wrap="square" lIns="0" tIns="0" rIns="0" bIns="0" rtlCol="0" anchor="ctr"/>
-          <a:lstStyle/>
-          <a:p>
-            <a:pPr indent="0" marL="0">
-              <a:buNone/>
-            </a:pPr>
-            <a:r>
-              <a:rPr lang="en-US" sz="1900" b="1" dirty="0">
-                <a:solidFill>
-                  <a:srgbClr val="F4F4F6"/>
-                </a:solidFill>
-                <a:latin typeface="Arial" pitchFamily="34" charset="0"/>
-                <a:ea typeface="Arial" pitchFamily="34" charset="-122"/>
-                <a:cs typeface="Arial" pitchFamily="34" charset="-120"/>
-              </a:rPr>
-              <a:t>«Хавчик»</a:t>
-            </a:r>
-            <a:endParaRPr lang="en-US" sz="1900" dirty="0"/>
-          </a:p>
-        </p:txBody>
-      </p:sp>
-      <p:sp>
-        <p:nvSpPr>
-          <p:cNvPr id="9" name="Text 6"/>
-          <p:cNvSpPr txBox="1"/>
-          <p:nvPr/>
-        </p:nvSpPr>
-        <p:spPr>
-          <a:xfrm>
-            <a:off x="822960" y="3246120"/>
-            <a:ext cx="1920240" cy="548640"/>
-          </a:xfrm>
-          <a:prstGeom prst="rect">
-            <a:avLst/>
-          </a:prstGeom>
-          <a:noFill/>
-          <a:ln/>
-        </p:spPr>
-        <p:txBody>
-          <a:bodyPr wrap="square" lIns="0" tIns="0" rIns="0" bIns="0" rtlCol="0" anchor="t"/>
-          <a:lstStyle/>
-          <a:p>
-            <a:pPr indent="0" marL="0">
-              <a:buNone/>
-            </a:pPr>
-            <a:r>
-              <a:rPr lang="en-US" sz="1200" dirty="0">
-                <a:solidFill>
-                  <a:srgbClr val="8E8E9C"/>
-                </a:solidFill>
-                <a:latin typeface="Arial" pitchFamily="34" charset="0"/>
-                <a:ea typeface="Arial" pitchFamily="34" charset="-122"/>
-                <a:cs typeface="Arial" pitchFamily="34" charset="-120"/>
-              </a:rPr>
-              <a:t>С Тимати и Даней Милохиным</a:t>
-            </a:r>
-            <a:endParaRPr lang="en-US" sz="1200" dirty="0"/>
-          </a:p>
-        </p:txBody>
-      </p:sp>
-      <p:sp>
-        <p:nvSpPr>
-          <p:cNvPr id="10" name="Shape 7"/>
-          <p:cNvSpPr/>
-          <p:nvPr/>
-        </p:nvSpPr>
-        <p:spPr>
-          <a:xfrm>
-            <a:off x="3337560" y="1783080"/>
-            <a:ext cx="2468880" cy="2240280"/>
-          </a:xfrm>
-          <a:prstGeom prst="roundRect">
-            <a:avLst>
-              <a:gd name="adj" fmla="val 3265"/>
-            </a:avLst>
-          </a:prstGeom>
-          <a:solidFill>
-            <a:srgbClr val="15151D"/>
-          </a:solidFill>
-          <a:ln w="9525">
-            <a:solidFill>
-              <a:srgbClr val="2A2A36"/>
-            </a:solidFill>
-            <a:prstDash val="solid"/>
-          </a:ln>
-        </p:spPr>
-      </p:sp>
-      <p:sp>
-        <p:nvSpPr>
-          <p:cNvPr id="11" name="Shape 8"/>
-          <p:cNvSpPr/>
-          <p:nvPr/>
-        </p:nvSpPr>
-        <p:spPr>
-          <a:xfrm>
-            <a:off x="3611880" y="2057400"/>
-            <a:ext cx="548640" cy="548640"/>
-          </a:xfrm>
-          <a:prstGeom prst="ellipse">
-            <a:avLst/>
-          </a:prstGeom>
-          <a:solidFill>
-            <a:srgbClr val="231F3D"/>
-          </a:solidFill>
-          <a:ln w="12700">
-            <a:solidFill>
-              <a:srgbClr val="231F3D"/>
-            </a:solidFill>
-            <a:prstDash val="solid"/>
-          </a:ln>
-        </p:spPr>
-      </p:sp>
       <p:pic>
         <p:nvPicPr>
-          <p:cNvPr id="12" name="Image 1" descr="preencoded.png">    </p:cNvPr>
+          <p:cNvPr id="14" name="Image 1" descr="Мем: критики про технику рифмы — я на чиле">    </p:cNvPr>
           <p:cNvPicPr>
             <a:picLocks noChangeAspect="1"/>
           </p:cNvPicPr>
@@ -5914,8 +6252,8 @@
         </p:blipFill>
         <p:spPr>
           <a:xfrm>
-            <a:off x="3749040" y="2194560"/>
-            <a:ext cx="274320" cy="274320"/>
+            <a:off x="6629400" y="1188720"/>
+            <a:ext cx="2148840" cy="2148840"/>
           </a:xfrm>
           <a:prstGeom prst="rect">
             <a:avLst/>
@@ -5924,69 +6262,69 @@
       </p:pic>
       <p:sp>
         <p:nvSpPr>
-          <p:cNvPr id="13" name="Text 9"/>
-          <p:cNvSpPr txBox="1"/>
-          <p:nvPr/>
-        </p:nvSpPr>
-        <p:spPr>
-          <a:xfrm>
-            <a:off x="3611880" y="2834640"/>
-            <a:ext cx="1920240" cy="365760"/>
-          </a:xfrm>
-          <a:prstGeom prst="rect">
-            <a:avLst/>
-          </a:prstGeom>
-          <a:noFill/>
-          <a:ln/>
-        </p:spPr>
-        <p:txBody>
-          <a:bodyPr wrap="square" lIns="0" tIns="0" rIns="0" bIns="0" rtlCol="0" anchor="ctr"/>
-          <a:lstStyle/>
-          <a:p>
-            <a:pPr indent="0" marL="0">
-              <a:buNone/>
-            </a:pPr>
-            <a:r>
-              <a:rPr lang="en-US" sz="1900" b="1" dirty="0">
-                <a:solidFill>
-                  <a:srgbClr val="F4F4F6"/>
-                </a:solidFill>
-                <a:latin typeface="Arial" pitchFamily="34" charset="0"/>
-                <a:ea typeface="Arial" pitchFamily="34" charset="-122"/>
-                <a:cs typeface="Arial" pitchFamily="34" charset="-120"/>
-              </a:rPr>
-              <a:t>«На чиле»</a:t>
-            </a:r>
-            <a:endParaRPr lang="en-US" sz="1900" dirty="0"/>
-          </a:p>
-        </p:txBody>
-      </p:sp>
-      <p:sp>
-        <p:nvSpPr>
-          <p:cNvPr id="14" name="Text 10"/>
-          <p:cNvSpPr txBox="1"/>
-          <p:nvPr/>
-        </p:nvSpPr>
-        <p:spPr>
-          <a:xfrm>
-            <a:off x="3611880" y="3246120"/>
-            <a:ext cx="1920240" cy="548640"/>
-          </a:xfrm>
-          <a:prstGeom prst="rect">
-            <a:avLst/>
-          </a:prstGeom>
-          <a:noFill/>
-          <a:ln/>
-        </p:spPr>
-        <p:txBody>
-          <a:bodyPr wrap="square" lIns="0" tIns="0" rIns="0" bIns="0" rtlCol="0" anchor="t"/>
-          <a:lstStyle/>
-          <a:p>
-            <a:pPr indent="0" marL="0">
-              <a:buNone/>
-            </a:pPr>
-            <a:r>
-              <a:rPr lang="en-US" sz="1200" dirty="0">
+          <p:cNvPr id="15" name="Text 11"/>
+          <p:cNvSpPr txBox="1"/>
+          <p:nvPr/>
+        </p:nvSpPr>
+        <p:spPr>
+          <a:xfrm>
+            <a:off x="4206240" y="3566160"/>
+            <a:ext cx="4572000" cy="274320"/>
+          </a:xfrm>
+          <a:prstGeom prst="rect">
+            <a:avLst/>
+          </a:prstGeom>
+          <a:noFill/>
+          <a:ln/>
+        </p:spPr>
+        <p:txBody>
+          <a:bodyPr wrap="square" lIns="0" tIns="0" rIns="0" bIns="0" rtlCol="0" anchor="ctr"/>
+          <a:lstStyle/>
+          <a:p>
+            <a:pPr indent="0" marL="0">
+              <a:buNone/>
+            </a:pPr>
+            <a:r>
+              <a:rPr lang="en-US" sz="1300" b="1" dirty="0">
+                <a:solidFill>
+                  <a:srgbClr val="8B7CF6"/>
+                </a:solidFill>
+                <a:latin typeface="Arial" pitchFamily="34" charset="0"/>
+                <a:ea typeface="Arial" pitchFamily="34" charset="-122"/>
+                <a:cs typeface="Arial" pitchFamily="34" charset="-120"/>
+              </a:rPr>
+              <a:t>Вирусная фраза → трек → охваты</a:t>
+            </a:r>
+            <a:endParaRPr lang="en-US" sz="1300" dirty="0"/>
+          </a:p>
+        </p:txBody>
+      </p:sp>
+      <p:sp>
+        <p:nvSpPr>
+          <p:cNvPr id="16" name="Text 12"/>
+          <p:cNvSpPr txBox="1"/>
+          <p:nvPr/>
+        </p:nvSpPr>
+        <p:spPr>
+          <a:xfrm>
+            <a:off x="4206240" y="3886200"/>
+            <a:ext cx="4572000" cy="228600"/>
+          </a:xfrm>
+          <a:prstGeom prst="rect">
+            <a:avLst/>
+          </a:prstGeom>
+          <a:noFill/>
+          <a:ln/>
+        </p:spPr>
+        <p:txBody>
+          <a:bodyPr wrap="square" lIns="0" tIns="0" rIns="0" bIns="0" rtlCol="0" anchor="ctr"/>
+          <a:lstStyle/>
+          <a:p>
+            <a:pPr indent="0" marL="0">
+              <a:buNone/>
+            </a:pPr>
+            <a:r>
+              <a:rPr lang="en-US" sz="800" dirty="0">
                 <a:solidFill>
                   <a:srgbClr val="8E8E9C"/>
                 </a:solidFill>
@@ -5994,153 +6332,38 @@
                 <a:ea typeface="Arial" pitchFamily="34" charset="-122"/>
                 <a:cs typeface="Arial" pitchFamily="34" charset="-120"/>
               </a:rPr>
-              <a:t>Сайфер с половиной рэп-тусовки</a:t>
-            </a:r>
-            <a:endParaRPr lang="en-US" sz="1200" dirty="0"/>
-          </a:p>
-        </p:txBody>
-      </p:sp>
-      <p:sp>
-        <p:nvSpPr>
-          <p:cNvPr id="15" name="Shape 11"/>
-          <p:cNvSpPr/>
-          <p:nvPr/>
-        </p:nvSpPr>
-        <p:spPr>
-          <a:xfrm>
-            <a:off x="6126480" y="1783080"/>
-            <a:ext cx="2468880" cy="2240280"/>
-          </a:xfrm>
-          <a:prstGeom prst="roundRect">
-            <a:avLst>
-              <a:gd name="adj" fmla="val 3265"/>
-            </a:avLst>
-          </a:prstGeom>
-          <a:solidFill>
-            <a:srgbClr val="15151D"/>
-          </a:solidFill>
-          <a:ln w="9525">
-            <a:solidFill>
-              <a:srgbClr val="2A2A36"/>
-            </a:solidFill>
-            <a:prstDash val="solid"/>
-          </a:ln>
-        </p:spPr>
-      </p:sp>
-      <p:sp>
-        <p:nvSpPr>
-          <p:cNvPr id="16" name="Shape 12"/>
-          <p:cNvSpPr/>
-          <p:nvPr/>
-        </p:nvSpPr>
-        <p:spPr>
-          <a:xfrm>
-            <a:off x="6400800" y="2057400"/>
-            <a:ext cx="548640" cy="548640"/>
-          </a:xfrm>
-          <a:prstGeom prst="ellipse">
-            <a:avLst/>
-          </a:prstGeom>
-          <a:solidFill>
-            <a:srgbClr val="231F3D"/>
-          </a:solidFill>
-          <a:ln w="12700">
-            <a:solidFill>
-              <a:srgbClr val="231F3D"/>
-            </a:solidFill>
-            <a:prstDash val="solid"/>
-          </a:ln>
-        </p:spPr>
-      </p:sp>
-      <p:pic>
-        <p:nvPicPr>
-          <p:cNvPr id="17" name="Image 2" descr="preencoded.png">    </p:cNvPr>
-          <p:cNvPicPr>
-            <a:picLocks noChangeAspect="1"/>
-          </p:cNvPicPr>
-          <p:nvPr/>
-        </p:nvPicPr>
-        <p:blipFill>
-          <a:blip r:embed="rId3"/>
-          <a:stretch>
-            <a:fillRect/>
-          </a:stretch>
-        </p:blipFill>
-        <p:spPr>
-          <a:xfrm>
-            <a:off x="6537960" y="2194560"/>
-            <a:ext cx="274320" cy="274320"/>
-          </a:xfrm>
-          <a:prstGeom prst="rect">
-            <a:avLst/>
-          </a:prstGeom>
-        </p:spPr>
-      </p:pic>
-      <p:sp>
-        <p:nvSpPr>
-          <p:cNvPr id="18" name="Text 13"/>
-          <p:cNvSpPr txBox="1"/>
-          <p:nvPr/>
-        </p:nvSpPr>
-        <p:spPr>
-          <a:xfrm>
-            <a:off x="6400800" y="2834640"/>
-            <a:ext cx="1920240" cy="365760"/>
-          </a:xfrm>
-          <a:prstGeom prst="rect">
-            <a:avLst/>
-          </a:prstGeom>
-          <a:noFill/>
-          <a:ln/>
-        </p:spPr>
-        <p:txBody>
-          <a:bodyPr wrap="square" lIns="0" tIns="0" rIns="0" bIns="0" rtlCol="0" anchor="ctr"/>
-          <a:lstStyle/>
-          <a:p>
-            <a:pPr indent="0" marL="0">
-              <a:buNone/>
-            </a:pPr>
-            <a:r>
-              <a:rPr lang="en-US" sz="1900" b="1" dirty="0">
-                <a:solidFill>
-                  <a:srgbClr val="F4F4F6"/>
-                </a:solidFill>
-                <a:latin typeface="Arial" pitchFamily="34" charset="0"/>
-                <a:ea typeface="Arial" pitchFamily="34" charset="-122"/>
-                <a:cs typeface="Arial" pitchFamily="34" charset="-120"/>
-              </a:rPr>
-              <a:t>«Bang»</a:t>
-            </a:r>
-            <a:endParaRPr lang="en-US" sz="1900" dirty="0"/>
-          </a:p>
-        </p:txBody>
-      </p:sp>
-      <p:sp>
-        <p:nvSpPr>
-          <p:cNvPr id="19" name="Text 14"/>
-          <p:cNvSpPr txBox="1"/>
-          <p:nvPr/>
-        </p:nvSpPr>
-        <p:spPr>
-          <a:xfrm>
-            <a:off x="6400800" y="3246120"/>
-            <a:ext cx="1920240" cy="548640"/>
-          </a:xfrm>
-          <a:prstGeom prst="rect">
-            <a:avLst/>
-          </a:prstGeom>
-          <a:noFill/>
-          <a:ln/>
-        </p:spPr>
-        <p:txBody>
-          <a:bodyPr wrap="square" lIns="0" tIns="0" rIns="0" bIns="0" rtlCol="0" anchor="t"/>
-          <a:lstStyle/>
-          <a:p>
-            <a:pPr indent="0" marL="0">
-              <a:buNone/>
-            </a:pPr>
-            <a:r>
-              <a:rPr lang="en-US" sz="1200" dirty="0">
+              <a:t>Мемы на основе фото: Okras; Алексей Гоманков · CC BY-SA 4.0</a:t>
+            </a:r>
+            <a:endParaRPr lang="en-US" sz="800" dirty="0"/>
+          </a:p>
+        </p:txBody>
+      </p:sp>
+      <p:sp>
+        <p:nvSpPr>
+          <p:cNvPr id="17" name="Text 13"/>
+          <p:cNvSpPr txBox="1"/>
+          <p:nvPr/>
+        </p:nvSpPr>
+        <p:spPr>
+          <a:xfrm>
+            <a:off x="7680960" y="4663440"/>
+            <a:ext cx="914400" cy="228600"/>
+          </a:xfrm>
+          <a:prstGeom prst="rect">
+            <a:avLst/>
+          </a:prstGeom>
+          <a:noFill/>
+          <a:ln/>
+        </p:spPr>
+        <p:txBody>
+          <a:bodyPr wrap="square" lIns="0" tIns="0" rIns="0" bIns="0" rtlCol="0" anchor="ctr"/>
+          <a:lstStyle/>
+          <a:p>
+            <a:pPr algn="r" indent="0" marL="0">
+              <a:buNone/>
+            </a:pPr>
+            <a:r>
+              <a:rPr lang="en-US" sz="900" dirty="0">
                 <a:solidFill>
                   <a:srgbClr val="8E8E9C"/>
                 </a:solidFill>
@@ -6148,48 +6371,9 @@
                 <a:ea typeface="Arial" pitchFamily="34" charset="-122"/>
                 <a:cs typeface="Arial" pitchFamily="34" charset="-120"/>
               </a:rPr>
-              <a:t>Альбом с автотюновым трэпом</a:t>
-            </a:r>
-            <a:endParaRPr lang="en-US" sz="1200" dirty="0"/>
-          </a:p>
-        </p:txBody>
-      </p:sp>
-      <p:sp>
-        <p:nvSpPr>
-          <p:cNvPr id="20" name="Text 15"/>
-          <p:cNvSpPr txBox="1"/>
-          <p:nvPr/>
-        </p:nvSpPr>
-        <p:spPr>
-          <a:xfrm>
-            <a:off x="548640" y="4251960"/>
-            <a:ext cx="5486400" cy="274320"/>
-          </a:xfrm>
-          <a:prstGeom prst="rect">
-            <a:avLst/>
-          </a:prstGeom>
-          <a:noFill/>
-          <a:ln/>
-        </p:spPr>
-        <p:txBody>
-          <a:bodyPr wrap="square" lIns="0" tIns="0" rIns="0" bIns="0" rtlCol="0" anchor="ctr"/>
-          <a:lstStyle/>
-          <a:p>
-            <a:pPr indent="0" marL="0">
-              <a:buNone/>
-            </a:pPr>
-            <a:r>
-              <a:rPr lang="en-US" sz="1200" b="1" dirty="0">
-                <a:solidFill>
-                  <a:srgbClr val="8B7CF6"/>
-                </a:solidFill>
-                <a:latin typeface="Arial" pitchFamily="34" charset="0"/>
-                <a:ea typeface="Arial" pitchFamily="34" charset="-122"/>
-                <a:cs typeface="Arial" pitchFamily="34" charset="-120"/>
-              </a:rPr>
-              <a:t>Вирусная фраза → трек → охваты</a:t>
-            </a:r>
-            <a:endParaRPr lang="en-US" sz="1200" dirty="0"/>
+              <a:t>07 / 10</a:t>
+            </a:r>
+            <a:endParaRPr lang="en-US" sz="900" dirty="0"/>
           </a:p>
         </p:txBody>
       </p:sp>
@@ -6234,7 +6418,7 @@
         <p:spPr>
           <a:xfrm>
             <a:off x="548640" y="411480"/>
-            <a:ext cx="5486400" cy="274320"/>
+            <a:ext cx="4572000" cy="274320"/>
           </a:xfrm>
           <a:prstGeom prst="rect">
             <a:avLst/>
@@ -6272,64 +6456,40 @@
         </p:nvSpPr>
         <p:spPr>
           <a:xfrm>
-            <a:off x="7680960" y="4663440"/>
-            <a:ext cx="914400" cy="228600"/>
-          </a:xfrm>
-          <a:prstGeom prst="rect">
-            <a:avLst/>
-          </a:prstGeom>
-          <a:noFill/>
-          <a:ln/>
-        </p:spPr>
-        <p:txBody>
-          <a:bodyPr wrap="square" lIns="0" tIns="0" rIns="0" bIns="0" rtlCol="0" anchor="ctr"/>
+            <a:off x="3474720" y="-274320"/>
+            <a:ext cx="5486400" cy="2926080"/>
+          </a:xfrm>
+          <a:prstGeom prst="rect">
+            <a:avLst/>
+          </a:prstGeom>
+          <a:noFill/>
+          <a:ln/>
+        </p:spPr>
+        <p:txBody>
+          <a:bodyPr wrap="square" lIns="0" tIns="0" rIns="0" bIns="0" rtlCol="0" anchor="b"/>
           <a:lstStyle/>
           <a:p>
             <a:pPr algn="r" indent="0" marL="0">
               <a:buNone/>
             </a:pPr>
             <a:r>
-              <a:rPr lang="en-US" sz="900" dirty="0">
-                <a:solidFill>
-                  <a:srgbClr val="8E8E9C"/>
-                </a:solidFill>
-                <a:latin typeface="Arial" pitchFamily="34" charset="0"/>
-                <a:ea typeface="Arial" pitchFamily="34" charset="-122"/>
-                <a:cs typeface="Arial" pitchFamily="34" charset="-120"/>
-              </a:rPr>
-              <a:t>08 / 10</a:t>
-            </a:r>
-            <a:endParaRPr lang="en-US" sz="900" dirty="0"/>
-          </a:p>
-        </p:txBody>
-      </p:sp>
-      <p:pic>
-        <p:nvPicPr>
-          <p:cNvPr id="4" name="Image 0" descr="preencoded.png">    </p:cNvPr>
-          <p:cNvPicPr>
-            <a:picLocks noChangeAspect="1"/>
-          </p:cNvPicPr>
-          <p:nvPr/>
-        </p:nvPicPr>
-        <p:blipFill>
-          <a:blip r:embed="rId1"/>
-          <a:stretch>
-            <a:fillRect/>
-          </a:stretch>
-        </p:blipFill>
-        <p:spPr>
-          <a:xfrm>
-            <a:off x="6583680" y="731520"/>
-            <a:ext cx="1828800" cy="1828800"/>
-          </a:xfrm>
-          <a:prstGeom prst="rect">
-            <a:avLst/>
-          </a:prstGeom>
-        </p:spPr>
-      </p:pic>
-      <p:sp>
-        <p:nvSpPr>
-          <p:cNvPr id="5" name="Text 2"/>
+              <a:rPr lang="en-US" sz="15000" b="1" dirty="0">
+                <a:solidFill>
+                  <a:srgbClr val="17171F"/>
+                </a:solidFill>
+                <a:latin typeface="Arial" pitchFamily="34" charset="0"/>
+                <a:ea typeface="Arial" pitchFamily="34" charset="-122"/>
+                <a:cs typeface="Arial" pitchFamily="34" charset="-120"/>
+              </a:rPr>
+              <a:t>2024</a:t>
+            </a:r>
+            <a:endParaRPr lang="en-US" sz="15000" dirty="0"/>
+          </a:p>
+        </p:txBody>
+      </p:sp>
+      <p:sp>
+        <p:nvSpPr>
+          <p:cNvPr id="4" name="Text 2"/>
           <p:cNvSpPr txBox="1"/>
           <p:nvPr/>
         </p:nvSpPr>
@@ -6368,7 +6528,7 @@
       </p:sp>
       <p:sp>
         <p:nvSpPr>
-          <p:cNvPr id="6" name="Text 3"/>
+          <p:cNvPr id="5" name="Text 3"/>
           <p:cNvSpPr txBox="1"/>
           <p:nvPr/>
         </p:nvSpPr>
@@ -6407,7 +6567,7 @@
       </p:sp>
       <p:sp>
         <p:nvSpPr>
-          <p:cNvPr id="7" name="Shape 4"/>
+          <p:cNvPr id="6" name="Shape 4"/>
           <p:cNvSpPr/>
           <p:nvPr/>
         </p:nvSpPr>
@@ -6434,7 +6594,7 @@
       </p:sp>
       <p:sp>
         <p:nvSpPr>
-          <p:cNvPr id="8" name="Text 5"/>
+          <p:cNvPr id="7" name="Text 5"/>
           <p:cNvSpPr txBox="1"/>
           <p:nvPr/>
         </p:nvSpPr>
@@ -6473,7 +6633,7 @@
       </p:sp>
       <p:sp>
         <p:nvSpPr>
-          <p:cNvPr id="9" name="Text 6"/>
+          <p:cNvPr id="8" name="Text 6"/>
           <p:cNvSpPr txBox="1"/>
           <p:nvPr/>
         </p:nvSpPr>
@@ -6529,7 +6689,7 @@
       </p:sp>
       <p:sp>
         <p:nvSpPr>
-          <p:cNvPr id="10" name="Shape 7"/>
+          <p:cNvPr id="9" name="Shape 7"/>
           <p:cNvSpPr/>
           <p:nvPr/>
         </p:nvSpPr>
@@ -6556,7 +6716,7 @@
       </p:sp>
       <p:sp>
         <p:nvSpPr>
-          <p:cNvPr id="11" name="Text 8"/>
+          <p:cNvPr id="10" name="Text 8"/>
           <p:cNvSpPr txBox="1"/>
           <p:nvPr/>
         </p:nvSpPr>
@@ -6595,7 +6755,7 @@
       </p:sp>
       <p:sp>
         <p:nvSpPr>
-          <p:cNvPr id="12" name="Text 9"/>
+          <p:cNvPr id="11" name="Text 9"/>
           <p:cNvSpPr txBox="1"/>
           <p:nvPr/>
         </p:nvSpPr>
@@ -6651,7 +6811,7 @@
       </p:sp>
       <p:sp>
         <p:nvSpPr>
-          <p:cNvPr id="13" name="Shape 10"/>
+          <p:cNvPr id="12" name="Shape 10"/>
           <p:cNvSpPr/>
           <p:nvPr/>
         </p:nvSpPr>
@@ -6678,7 +6838,7 @@
       </p:sp>
       <p:sp>
         <p:nvSpPr>
-          <p:cNvPr id="14" name="Text 11"/>
+          <p:cNvPr id="13" name="Text 11"/>
           <p:cNvSpPr txBox="1"/>
           <p:nvPr/>
         </p:nvSpPr>
@@ -6717,7 +6877,7 @@
       </p:sp>
       <p:sp>
         <p:nvSpPr>
-          <p:cNvPr id="15" name="Text 12"/>
+          <p:cNvPr id="14" name="Text 12"/>
           <p:cNvSpPr txBox="1"/>
           <p:nvPr/>
         </p:nvSpPr>
@@ -6768,6 +6928,45 @@
               <a:t>НФМИ по новым нормам</a:t>
             </a:r>
             <a:endParaRPr lang="en-US" sz="1200" dirty="0"/>
+          </a:p>
+        </p:txBody>
+      </p:sp>
+      <p:sp>
+        <p:nvSpPr>
+          <p:cNvPr id="15" name="Text 13"/>
+          <p:cNvSpPr txBox="1"/>
+          <p:nvPr/>
+        </p:nvSpPr>
+        <p:spPr>
+          <a:xfrm>
+            <a:off x="7680960" y="4663440"/>
+            <a:ext cx="914400" cy="228600"/>
+          </a:xfrm>
+          <a:prstGeom prst="rect">
+            <a:avLst/>
+          </a:prstGeom>
+          <a:noFill/>
+          <a:ln/>
+        </p:spPr>
+        <p:txBody>
+          <a:bodyPr wrap="square" lIns="0" tIns="0" rIns="0" bIns="0" rtlCol="0" anchor="ctr"/>
+          <a:lstStyle/>
+          <a:p>
+            <a:pPr algn="r" indent="0" marL="0">
+              <a:buNone/>
+            </a:pPr>
+            <a:r>
+              <a:rPr lang="en-US" sz="900" dirty="0">
+                <a:solidFill>
+                  <a:srgbClr val="8E8E9C"/>
+                </a:solidFill>
+                <a:latin typeface="Arial" pitchFamily="34" charset="0"/>
+                <a:ea typeface="Arial" pitchFamily="34" charset="-122"/>
+                <a:cs typeface="Arial" pitchFamily="34" charset="-120"/>
+              </a:rPr>
+              <a:t>08 / 10</a:t>
+            </a:r>
+            <a:endParaRPr lang="en-US" sz="900" dirty="0"/>
           </a:p>
         </p:txBody>
       </p:sp>
@@ -6812,7 +7011,7 @@
         <p:spPr>
           <a:xfrm>
             <a:off x="548640" y="411480"/>
-            <a:ext cx="5486400" cy="274320"/>
+            <a:ext cx="4572000" cy="274320"/>
           </a:xfrm>
           <a:prstGeom prst="rect">
             <a:avLst/>
@@ -6845,45 +7044,6 @@
       <p:sp>
         <p:nvSpPr>
           <p:cNvPr id="3" name="Text 1"/>
-          <p:cNvSpPr txBox="1"/>
-          <p:nvPr/>
-        </p:nvSpPr>
-        <p:spPr>
-          <a:xfrm>
-            <a:off x="7680960" y="4663440"/>
-            <a:ext cx="914400" cy="228600"/>
-          </a:xfrm>
-          <a:prstGeom prst="rect">
-            <a:avLst/>
-          </a:prstGeom>
-          <a:noFill/>
-          <a:ln/>
-        </p:spPr>
-        <p:txBody>
-          <a:bodyPr wrap="square" lIns="0" tIns="0" rIns="0" bIns="0" rtlCol="0" anchor="ctr"/>
-          <a:lstStyle/>
-          <a:p>
-            <a:pPr algn="r" indent="0" marL="0">
-              <a:buNone/>
-            </a:pPr>
-            <a:r>
-              <a:rPr lang="en-US" sz="900" dirty="0">
-                <a:solidFill>
-                  <a:srgbClr val="8E8E9C"/>
-                </a:solidFill>
-                <a:latin typeface="Arial" pitchFamily="34" charset="0"/>
-                <a:ea typeface="Arial" pitchFamily="34" charset="-122"/>
-                <a:cs typeface="Arial" pitchFamily="34" charset="-120"/>
-              </a:rPr>
-              <a:t>09 / 10</a:t>
-            </a:r>
-            <a:endParaRPr lang="en-US" sz="900" dirty="0"/>
-          </a:p>
-        </p:txBody>
-      </p:sp>
-      <p:sp>
-        <p:nvSpPr>
-          <p:cNvPr id="4" name="Text 2"/>
           <p:cNvSpPr txBox="1"/>
           <p:nvPr/>
         </p:nvSpPr>
@@ -6922,63 +7082,53 @@
       </p:sp>
       <p:sp>
         <p:nvSpPr>
-          <p:cNvPr id="5" name="Shape 3"/>
-          <p:cNvSpPr/>
-          <p:nvPr/>
-        </p:nvSpPr>
-        <p:spPr>
-          <a:xfrm>
-            <a:off x="548640" y="1737360"/>
-            <a:ext cx="502920" cy="502920"/>
-          </a:xfrm>
-          <a:prstGeom prst="ellipse">
-            <a:avLst/>
-          </a:prstGeom>
-          <a:solidFill>
-            <a:srgbClr val="231F3D"/>
-          </a:solidFill>
-          <a:ln w="12700">
-            <a:solidFill>
-              <a:srgbClr val="231F3D"/>
-            </a:solidFill>
-            <a:prstDash val="solid"/>
-          </a:ln>
-        </p:spPr>
-      </p:sp>
-      <p:pic>
-        <p:nvPicPr>
-          <p:cNvPr id="6" name="Image 0" descr="preencoded.png">    </p:cNvPr>
-          <p:cNvPicPr>
-            <a:picLocks noChangeAspect="1"/>
-          </p:cNvPicPr>
-          <p:nvPr/>
-        </p:nvPicPr>
-        <p:blipFill>
-          <a:blip r:embed="rId1"/>
-          <a:stretch>
-            <a:fillRect/>
-          </a:stretch>
-        </p:blipFill>
-        <p:spPr>
-          <a:xfrm>
-            <a:off x="674370" y="1863090"/>
-            <a:ext cx="251460" cy="251460"/>
-          </a:xfrm>
-          <a:prstGeom prst="rect">
-            <a:avLst/>
-          </a:prstGeom>
-        </p:spPr>
-      </p:pic>
-      <p:sp>
-        <p:nvSpPr>
-          <p:cNvPr id="7" name="Text 4"/>
-          <p:cNvSpPr txBox="1"/>
-          <p:nvPr/>
-        </p:nvSpPr>
-        <p:spPr>
-          <a:xfrm>
-            <a:off x="1234440" y="1719072"/>
-            <a:ext cx="3840480" cy="292608"/>
+          <p:cNvPr id="4" name="Text 2"/>
+          <p:cNvSpPr txBox="1"/>
+          <p:nvPr/>
+        </p:nvSpPr>
+        <p:spPr>
+          <a:xfrm>
+            <a:off x="548640" y="1719072"/>
+            <a:ext cx="502920" cy="292608"/>
+          </a:xfrm>
+          <a:prstGeom prst="rect">
+            <a:avLst/>
+          </a:prstGeom>
+          <a:noFill/>
+          <a:ln/>
+        </p:spPr>
+        <p:txBody>
+          <a:bodyPr wrap="square" lIns="0" tIns="0" rIns="0" bIns="0" rtlCol="0" anchor="ctr"/>
+          <a:lstStyle/>
+          <a:p>
+            <a:pPr indent="0" marL="0">
+              <a:buNone/>
+            </a:pPr>
+            <a:r>
+              <a:rPr lang="en-US" sz="1400" b="1" dirty="0">
+                <a:solidFill>
+                  <a:srgbClr val="8B7CF6"/>
+                </a:solidFill>
+                <a:latin typeface="Arial" pitchFamily="34" charset="0"/>
+                <a:ea typeface="Arial" pitchFamily="34" charset="-122"/>
+                <a:cs typeface="Arial" pitchFamily="34" charset="-120"/>
+              </a:rPr>
+              <a:t>01</a:t>
+            </a:r>
+            <a:endParaRPr lang="en-US" sz="1400" dirty="0"/>
+          </a:p>
+        </p:txBody>
+      </p:sp>
+      <p:sp>
+        <p:nvSpPr>
+          <p:cNvPr id="5" name="Text 3"/>
+          <p:cNvSpPr txBox="1"/>
+          <p:nvPr/>
+        </p:nvSpPr>
+        <p:spPr>
+          <a:xfrm>
+            <a:off x="1097280" y="1719072"/>
+            <a:ext cx="4023360" cy="292608"/>
           </a:xfrm>
           <a:prstGeom prst="rect">
             <a:avLst/>
@@ -7010,14 +7160,14 @@
       </p:sp>
       <p:sp>
         <p:nvSpPr>
-          <p:cNvPr id="8" name="Text 5"/>
-          <p:cNvSpPr txBox="1"/>
-          <p:nvPr/>
-        </p:nvSpPr>
-        <p:spPr>
-          <a:xfrm>
-            <a:off x="1234440" y="2011680"/>
-            <a:ext cx="3840480" cy="274320"/>
+          <p:cNvPr id="6" name="Text 4"/>
+          <p:cNvSpPr txBox="1"/>
+          <p:nvPr/>
+        </p:nvSpPr>
+        <p:spPr>
+          <a:xfrm>
+            <a:off x="1097280" y="2011680"/>
+            <a:ext cx="4023360" cy="274320"/>
           </a:xfrm>
           <a:prstGeom prst="rect">
             <a:avLst/>
@@ -7049,63 +7199,53 @@
       </p:sp>
       <p:sp>
         <p:nvSpPr>
-          <p:cNvPr id="9" name="Shape 6"/>
-          <p:cNvSpPr/>
-          <p:nvPr/>
-        </p:nvSpPr>
-        <p:spPr>
-          <a:xfrm>
-            <a:off x="548640" y="2606040"/>
-            <a:ext cx="502920" cy="502920"/>
-          </a:xfrm>
-          <a:prstGeom prst="ellipse">
-            <a:avLst/>
-          </a:prstGeom>
-          <a:solidFill>
-            <a:srgbClr val="231F3D"/>
-          </a:solidFill>
-          <a:ln w="12700">
-            <a:solidFill>
-              <a:srgbClr val="231F3D"/>
-            </a:solidFill>
-            <a:prstDash val="solid"/>
-          </a:ln>
-        </p:spPr>
-      </p:sp>
-      <p:pic>
-        <p:nvPicPr>
-          <p:cNvPr id="10" name="Image 1" descr="preencoded.png">    </p:cNvPr>
-          <p:cNvPicPr>
-            <a:picLocks noChangeAspect="1"/>
-          </p:cNvPicPr>
-          <p:nvPr/>
-        </p:nvPicPr>
-        <p:blipFill>
-          <a:blip r:embed="rId2"/>
-          <a:stretch>
-            <a:fillRect/>
-          </a:stretch>
-        </p:blipFill>
-        <p:spPr>
-          <a:xfrm>
-            <a:off x="674370" y="2731770"/>
-            <a:ext cx="251460" cy="251460"/>
-          </a:xfrm>
-          <a:prstGeom prst="rect">
-            <a:avLst/>
-          </a:prstGeom>
-        </p:spPr>
-      </p:pic>
-      <p:sp>
-        <p:nvSpPr>
-          <p:cNvPr id="11" name="Text 7"/>
-          <p:cNvSpPr txBox="1"/>
-          <p:nvPr/>
-        </p:nvSpPr>
-        <p:spPr>
-          <a:xfrm>
-            <a:off x="1234440" y="2587752"/>
-            <a:ext cx="3840480" cy="292608"/>
+          <p:cNvPr id="7" name="Text 5"/>
+          <p:cNvSpPr txBox="1"/>
+          <p:nvPr/>
+        </p:nvSpPr>
+        <p:spPr>
+          <a:xfrm>
+            <a:off x="548640" y="2587752"/>
+            <a:ext cx="502920" cy="292608"/>
+          </a:xfrm>
+          <a:prstGeom prst="rect">
+            <a:avLst/>
+          </a:prstGeom>
+          <a:noFill/>
+          <a:ln/>
+        </p:spPr>
+        <p:txBody>
+          <a:bodyPr wrap="square" lIns="0" tIns="0" rIns="0" bIns="0" rtlCol="0" anchor="ctr"/>
+          <a:lstStyle/>
+          <a:p>
+            <a:pPr indent="0" marL="0">
+              <a:buNone/>
+            </a:pPr>
+            <a:r>
+              <a:rPr lang="en-US" sz="1400" b="1" dirty="0">
+                <a:solidFill>
+                  <a:srgbClr val="8B7CF6"/>
+                </a:solidFill>
+                <a:latin typeface="Arial" pitchFamily="34" charset="0"/>
+                <a:ea typeface="Arial" pitchFamily="34" charset="-122"/>
+                <a:cs typeface="Arial" pitchFamily="34" charset="-120"/>
+              </a:rPr>
+              <a:t>02</a:t>
+            </a:r>
+            <a:endParaRPr lang="en-US" sz="1400" dirty="0"/>
+          </a:p>
+        </p:txBody>
+      </p:sp>
+      <p:sp>
+        <p:nvSpPr>
+          <p:cNvPr id="8" name="Text 6"/>
+          <p:cNvSpPr txBox="1"/>
+          <p:nvPr/>
+        </p:nvSpPr>
+        <p:spPr>
+          <a:xfrm>
+            <a:off x="1097280" y="2587752"/>
+            <a:ext cx="4023360" cy="292608"/>
           </a:xfrm>
           <a:prstGeom prst="rect">
             <a:avLst/>
@@ -7137,14 +7277,14 @@
       </p:sp>
       <p:sp>
         <p:nvSpPr>
-          <p:cNvPr id="12" name="Text 8"/>
-          <p:cNvSpPr txBox="1"/>
-          <p:nvPr/>
-        </p:nvSpPr>
-        <p:spPr>
-          <a:xfrm>
-            <a:off x="1234440" y="2880360"/>
-            <a:ext cx="3840480" cy="274320"/>
+          <p:cNvPr id="9" name="Text 7"/>
+          <p:cNvSpPr txBox="1"/>
+          <p:nvPr/>
+        </p:nvSpPr>
+        <p:spPr>
+          <a:xfrm>
+            <a:off x="1097280" y="2880360"/>
+            <a:ext cx="4023360" cy="274320"/>
           </a:xfrm>
           <a:prstGeom prst="rect">
             <a:avLst/>
@@ -7176,63 +7316,53 @@
       </p:sp>
       <p:sp>
         <p:nvSpPr>
-          <p:cNvPr id="13" name="Shape 9"/>
-          <p:cNvSpPr/>
-          <p:nvPr/>
-        </p:nvSpPr>
-        <p:spPr>
-          <a:xfrm>
-            <a:off x="548640" y="3474720"/>
-            <a:ext cx="502920" cy="502920"/>
-          </a:xfrm>
-          <a:prstGeom prst="ellipse">
-            <a:avLst/>
-          </a:prstGeom>
-          <a:solidFill>
-            <a:srgbClr val="231F3D"/>
-          </a:solidFill>
-          <a:ln w="12700">
-            <a:solidFill>
-              <a:srgbClr val="231F3D"/>
-            </a:solidFill>
-            <a:prstDash val="solid"/>
-          </a:ln>
-        </p:spPr>
-      </p:sp>
-      <p:pic>
-        <p:nvPicPr>
-          <p:cNvPr id="14" name="Image 2" descr="preencoded.png">    </p:cNvPr>
-          <p:cNvPicPr>
-            <a:picLocks noChangeAspect="1"/>
-          </p:cNvPicPr>
-          <p:nvPr/>
-        </p:nvPicPr>
-        <p:blipFill>
-          <a:blip r:embed="rId3"/>
-          <a:stretch>
-            <a:fillRect/>
-          </a:stretch>
-        </p:blipFill>
-        <p:spPr>
-          <a:xfrm>
-            <a:off x="674370" y="3600450"/>
-            <a:ext cx="251460" cy="251460"/>
-          </a:xfrm>
-          <a:prstGeom prst="rect">
-            <a:avLst/>
-          </a:prstGeom>
-        </p:spPr>
-      </p:pic>
-      <p:sp>
-        <p:nvSpPr>
-          <p:cNvPr id="15" name="Text 10"/>
-          <p:cNvSpPr txBox="1"/>
-          <p:nvPr/>
-        </p:nvSpPr>
-        <p:spPr>
-          <a:xfrm>
-            <a:off x="1234440" y="3456432"/>
-            <a:ext cx="3840480" cy="292608"/>
+          <p:cNvPr id="10" name="Text 8"/>
+          <p:cNvSpPr txBox="1"/>
+          <p:nvPr/>
+        </p:nvSpPr>
+        <p:spPr>
+          <a:xfrm>
+            <a:off x="548640" y="3456432"/>
+            <a:ext cx="502920" cy="292608"/>
+          </a:xfrm>
+          <a:prstGeom prst="rect">
+            <a:avLst/>
+          </a:prstGeom>
+          <a:noFill/>
+          <a:ln/>
+        </p:spPr>
+        <p:txBody>
+          <a:bodyPr wrap="square" lIns="0" tIns="0" rIns="0" bIns="0" rtlCol="0" anchor="ctr"/>
+          <a:lstStyle/>
+          <a:p>
+            <a:pPr indent="0" marL="0">
+              <a:buNone/>
+            </a:pPr>
+            <a:r>
+              <a:rPr lang="en-US" sz="1400" b="1" dirty="0">
+                <a:solidFill>
+                  <a:srgbClr val="8B7CF6"/>
+                </a:solidFill>
+                <a:latin typeface="Arial" pitchFamily="34" charset="0"/>
+                <a:ea typeface="Arial" pitchFamily="34" charset="-122"/>
+                <a:cs typeface="Arial" pitchFamily="34" charset="-120"/>
+              </a:rPr>
+              <a:t>03</a:t>
+            </a:r>
+            <a:endParaRPr lang="en-US" sz="1400" dirty="0"/>
+          </a:p>
+        </p:txBody>
+      </p:sp>
+      <p:sp>
+        <p:nvSpPr>
+          <p:cNvPr id="11" name="Text 9"/>
+          <p:cNvSpPr txBox="1"/>
+          <p:nvPr/>
+        </p:nvSpPr>
+        <p:spPr>
+          <a:xfrm>
+            <a:off x="1097280" y="3456432"/>
+            <a:ext cx="4023360" cy="292608"/>
           </a:xfrm>
           <a:prstGeom prst="rect">
             <a:avLst/>
@@ -7264,14 +7394,14 @@
       </p:sp>
       <p:sp>
         <p:nvSpPr>
-          <p:cNvPr id="16" name="Text 11"/>
-          <p:cNvSpPr txBox="1"/>
-          <p:nvPr/>
-        </p:nvSpPr>
-        <p:spPr>
-          <a:xfrm>
-            <a:off x="1234440" y="3749040"/>
-            <a:ext cx="3840480" cy="274320"/>
+          <p:cNvPr id="12" name="Text 10"/>
+          <p:cNvSpPr txBox="1"/>
+          <p:nvPr/>
+        </p:nvSpPr>
+        <p:spPr>
+          <a:xfrm>
+            <a:off x="1097280" y="3749040"/>
+            <a:ext cx="4023360" cy="274320"/>
           </a:xfrm>
           <a:prstGeom prst="rect">
             <a:avLst/>
@@ -7303,7 +7433,7 @@
       </p:sp>
       <p:sp>
         <p:nvSpPr>
-          <p:cNvPr id="17" name="Shape 12"/>
+          <p:cNvPr id="13" name="Shape 11"/>
           <p:cNvSpPr/>
           <p:nvPr/>
         </p:nvSpPr>
@@ -7330,7 +7460,7 @@
       </p:sp>
       <p:sp>
         <p:nvSpPr>
-          <p:cNvPr id="18" name="Text 13"/>
+          <p:cNvPr id="14" name="Text 12"/>
           <p:cNvSpPr txBox="1"/>
           <p:nvPr/>
         </p:nvSpPr>
@@ -7387,6 +7517,45 @@
               <a:t>а чутьё на хит и на людей</a:t>
             </a:r>
             <a:endParaRPr lang="en-US" sz="1800" dirty="0"/>
+          </a:p>
+        </p:txBody>
+      </p:sp>
+      <p:sp>
+        <p:nvSpPr>
+          <p:cNvPr id="15" name="Text 13"/>
+          <p:cNvSpPr txBox="1"/>
+          <p:nvPr/>
+        </p:nvSpPr>
+        <p:spPr>
+          <a:xfrm>
+            <a:off x="7680960" y="4663440"/>
+            <a:ext cx="914400" cy="228600"/>
+          </a:xfrm>
+          <a:prstGeom prst="rect">
+            <a:avLst/>
+          </a:prstGeom>
+          <a:noFill/>
+          <a:ln/>
+        </p:spPr>
+        <p:txBody>
+          <a:bodyPr wrap="square" lIns="0" tIns="0" rIns="0" bIns="0" rtlCol="0" anchor="ctr"/>
+          <a:lstStyle/>
+          <a:p>
+            <a:pPr algn="r" indent="0" marL="0">
+              <a:buNone/>
+            </a:pPr>
+            <a:r>
+              <a:rPr lang="en-US" sz="900" dirty="0">
+                <a:solidFill>
+                  <a:srgbClr val="8E8E9C"/>
+                </a:solidFill>
+                <a:latin typeface="Arial" pitchFamily="34" charset="0"/>
+                <a:ea typeface="Arial" pitchFamily="34" charset="-122"/>
+                <a:cs typeface="Arial" pitchFamily="34" charset="-120"/>
+              </a:rPr>
+              <a:t>09 / 10</a:t>
+            </a:r>
+            <a:endParaRPr lang="en-US" sz="900" dirty="0"/>
           </a:p>
         </p:txBody>
       </p:sp>

</xml_diff>

<commit_message>
Dzhigan v2: use real memes on slide 7
Co-Authored-By: Claude Opus 5.5 <noreply@anthropic.com>
Claude-Session: https://claude.ai/code/session_01ESKVy2aSLgHDCNezBhnSbq
</commit_message>
<xml_diff>
--- a/Dzhigan_v2.pptx
+++ b/Dzhigan_v2.pptx
@@ -5814,7 +5814,7 @@
         <p:spPr>
           <a:xfrm>
             <a:off x="548640" y="731520"/>
-            <a:ext cx="3657600" cy="1188720"/>
+            <a:ext cx="8046720" cy="822960"/>
           </a:xfrm>
           <a:prstGeom prst="rect">
             <a:avLst/>
@@ -5830,7 +5830,7 @@
               <a:buNone/>
             </a:pPr>
             <a:r>
-              <a:rPr lang="en-US" sz="3400" b="1" dirty="0">
+              <a:rPr lang="en-US" sz="3200" b="1" dirty="0">
                 <a:solidFill>
                   <a:srgbClr val="F4F4F6"/>
                 </a:solidFill>
@@ -5838,383 +5838,15 @@
                 <a:ea typeface="Arial" pitchFamily="34" charset="-122"/>
                 <a:cs typeface="Arial" pitchFamily="34" charset="-120"/>
               </a:rPr>
-              <a:t>Из радио —</a:t>
-            </a:r>
-            <a:endParaRPr lang="en-US" sz="3400" dirty="0"/>
-          </a:p>
-          <a:p>
-            <a:pPr indent="0" marL="0">
-              <a:buNone/>
-            </a:pPr>
-            <a:r>
-              <a:rPr lang="en-US" sz="3400" b="1" dirty="0">
-                <a:solidFill>
-                  <a:srgbClr val="F4F4F6"/>
-                </a:solidFill>
-                <a:latin typeface="Arial" pitchFamily="34" charset="0"/>
-                <a:ea typeface="Arial" pitchFamily="34" charset="-122"/>
-                <a:cs typeface="Arial" pitchFamily="34" charset="-120"/>
-              </a:rPr>
-              <a:t>в рилсы</a:t>
-            </a:r>
-            <a:endParaRPr lang="en-US" sz="3400" dirty="0"/>
-          </a:p>
-        </p:txBody>
-      </p:sp>
-      <p:sp>
-        <p:nvSpPr>
-          <p:cNvPr id="4" name="Text 2"/>
-          <p:cNvSpPr txBox="1"/>
-          <p:nvPr/>
-        </p:nvSpPr>
-        <p:spPr>
-          <a:xfrm>
-            <a:off x="548640" y="2176272"/>
-            <a:ext cx="502920" cy="292608"/>
-          </a:xfrm>
-          <a:prstGeom prst="rect">
-            <a:avLst/>
-          </a:prstGeom>
-          <a:noFill/>
-          <a:ln/>
-        </p:spPr>
-        <p:txBody>
-          <a:bodyPr wrap="square" lIns="0" tIns="0" rIns="0" bIns="0" rtlCol="0" anchor="ctr"/>
-          <a:lstStyle/>
-          <a:p>
-            <a:pPr indent="0" marL="0">
-              <a:buNone/>
-            </a:pPr>
-            <a:r>
-              <a:rPr lang="en-US" sz="1400" b="1" dirty="0">
-                <a:solidFill>
-                  <a:srgbClr val="8B7CF6"/>
-                </a:solidFill>
-                <a:latin typeface="Arial" pitchFamily="34" charset="0"/>
-                <a:ea typeface="Arial" pitchFamily="34" charset="-122"/>
-                <a:cs typeface="Arial" pitchFamily="34" charset="-120"/>
-              </a:rPr>
-              <a:t>01</a:t>
-            </a:r>
-            <a:endParaRPr lang="en-US" sz="1400" dirty="0"/>
-          </a:p>
-        </p:txBody>
-      </p:sp>
-      <p:sp>
-        <p:nvSpPr>
-          <p:cNvPr id="5" name="Text 3"/>
-          <p:cNvSpPr txBox="1"/>
-          <p:nvPr/>
-        </p:nvSpPr>
-        <p:spPr>
-          <a:xfrm>
-            <a:off x="1097280" y="2176272"/>
-            <a:ext cx="2926080" cy="292608"/>
-          </a:xfrm>
-          <a:prstGeom prst="rect">
-            <a:avLst/>
-          </a:prstGeom>
-          <a:noFill/>
-          <a:ln/>
-        </p:spPr>
-        <p:txBody>
-          <a:bodyPr wrap="square" lIns="0" tIns="0" rIns="0" bIns="0" rtlCol="0" anchor="ctr"/>
-          <a:lstStyle/>
-          <a:p>
-            <a:pPr indent="0" marL="0">
-              <a:buNone/>
-            </a:pPr>
-            <a:r>
-              <a:rPr lang="en-US" sz="1600" b="1" dirty="0">
-                <a:solidFill>
-                  <a:srgbClr val="F4F4F6"/>
-                </a:solidFill>
-                <a:latin typeface="Arial" pitchFamily="34" charset="0"/>
-                <a:ea typeface="Arial" pitchFamily="34" charset="-122"/>
-                <a:cs typeface="Arial" pitchFamily="34" charset="-120"/>
-              </a:rPr>
-              <a:t>«Хавчик»</a:t>
-            </a:r>
-            <a:endParaRPr lang="en-US" sz="1600" dirty="0"/>
-          </a:p>
-        </p:txBody>
-      </p:sp>
-      <p:sp>
-        <p:nvSpPr>
-          <p:cNvPr id="6" name="Text 4"/>
-          <p:cNvSpPr txBox="1"/>
-          <p:nvPr/>
-        </p:nvSpPr>
-        <p:spPr>
-          <a:xfrm>
-            <a:off x="1097280" y="2468880"/>
-            <a:ext cx="2926080" cy="274320"/>
-          </a:xfrm>
-          <a:prstGeom prst="rect">
-            <a:avLst/>
-          </a:prstGeom>
-          <a:noFill/>
-          <a:ln/>
-        </p:spPr>
-        <p:txBody>
-          <a:bodyPr wrap="square" lIns="0" tIns="0" rIns="0" bIns="0" rtlCol="0" anchor="ctr"/>
-          <a:lstStyle/>
-          <a:p>
-            <a:pPr indent="0" marL="0">
-              <a:buNone/>
-            </a:pPr>
-            <a:r>
-              <a:rPr lang="en-US" sz="1200" dirty="0">
-                <a:solidFill>
-                  <a:srgbClr val="8E8E9C"/>
-                </a:solidFill>
-                <a:latin typeface="Arial" pitchFamily="34" charset="0"/>
-                <a:ea typeface="Arial" pitchFamily="34" charset="-122"/>
-                <a:cs typeface="Arial" pitchFamily="34" charset="-120"/>
-              </a:rPr>
-              <a:t>С Тимати и Даней Милохиным</a:t>
-            </a:r>
-            <a:endParaRPr lang="en-US" sz="1200" dirty="0"/>
-          </a:p>
-        </p:txBody>
-      </p:sp>
-      <p:sp>
-        <p:nvSpPr>
-          <p:cNvPr id="7" name="Text 5"/>
-          <p:cNvSpPr txBox="1"/>
-          <p:nvPr/>
-        </p:nvSpPr>
-        <p:spPr>
-          <a:xfrm>
-            <a:off x="548640" y="2889504"/>
-            <a:ext cx="502920" cy="292608"/>
-          </a:xfrm>
-          <a:prstGeom prst="rect">
-            <a:avLst/>
-          </a:prstGeom>
-          <a:noFill/>
-          <a:ln/>
-        </p:spPr>
-        <p:txBody>
-          <a:bodyPr wrap="square" lIns="0" tIns="0" rIns="0" bIns="0" rtlCol="0" anchor="ctr"/>
-          <a:lstStyle/>
-          <a:p>
-            <a:pPr indent="0" marL="0">
-              <a:buNone/>
-            </a:pPr>
-            <a:r>
-              <a:rPr lang="en-US" sz="1400" b="1" dirty="0">
-                <a:solidFill>
-                  <a:srgbClr val="8B7CF6"/>
-                </a:solidFill>
-                <a:latin typeface="Arial" pitchFamily="34" charset="0"/>
-                <a:ea typeface="Arial" pitchFamily="34" charset="-122"/>
-                <a:cs typeface="Arial" pitchFamily="34" charset="-120"/>
-              </a:rPr>
-              <a:t>02</a:t>
-            </a:r>
-            <a:endParaRPr lang="en-US" sz="1400" dirty="0"/>
-          </a:p>
-        </p:txBody>
-      </p:sp>
-      <p:sp>
-        <p:nvSpPr>
-          <p:cNvPr id="8" name="Text 6"/>
-          <p:cNvSpPr txBox="1"/>
-          <p:nvPr/>
-        </p:nvSpPr>
-        <p:spPr>
-          <a:xfrm>
-            <a:off x="1097280" y="2889504"/>
-            <a:ext cx="2926080" cy="292608"/>
-          </a:xfrm>
-          <a:prstGeom prst="rect">
-            <a:avLst/>
-          </a:prstGeom>
-          <a:noFill/>
-          <a:ln/>
-        </p:spPr>
-        <p:txBody>
-          <a:bodyPr wrap="square" lIns="0" tIns="0" rIns="0" bIns="0" rtlCol="0" anchor="ctr"/>
-          <a:lstStyle/>
-          <a:p>
-            <a:pPr indent="0" marL="0">
-              <a:buNone/>
-            </a:pPr>
-            <a:r>
-              <a:rPr lang="en-US" sz="1600" b="1" dirty="0">
-                <a:solidFill>
-                  <a:srgbClr val="F4F4F6"/>
-                </a:solidFill>
-                <a:latin typeface="Arial" pitchFamily="34" charset="0"/>
-                <a:ea typeface="Arial" pitchFamily="34" charset="-122"/>
-                <a:cs typeface="Arial" pitchFamily="34" charset="-120"/>
-              </a:rPr>
-              <a:t>«На чиле»</a:t>
-            </a:r>
-            <a:endParaRPr lang="en-US" sz="1600" dirty="0"/>
-          </a:p>
-        </p:txBody>
-      </p:sp>
-      <p:sp>
-        <p:nvSpPr>
-          <p:cNvPr id="9" name="Text 7"/>
-          <p:cNvSpPr txBox="1"/>
-          <p:nvPr/>
-        </p:nvSpPr>
-        <p:spPr>
-          <a:xfrm>
-            <a:off x="1097280" y="3182112"/>
-            <a:ext cx="2926080" cy="274320"/>
-          </a:xfrm>
-          <a:prstGeom prst="rect">
-            <a:avLst/>
-          </a:prstGeom>
-          <a:noFill/>
-          <a:ln/>
-        </p:spPr>
-        <p:txBody>
-          <a:bodyPr wrap="square" lIns="0" tIns="0" rIns="0" bIns="0" rtlCol="0" anchor="ctr"/>
-          <a:lstStyle/>
-          <a:p>
-            <a:pPr indent="0" marL="0">
-              <a:buNone/>
-            </a:pPr>
-            <a:r>
-              <a:rPr lang="en-US" sz="1200" dirty="0">
-                <a:solidFill>
-                  <a:srgbClr val="8E8E9C"/>
-                </a:solidFill>
-                <a:latin typeface="Arial" pitchFamily="34" charset="0"/>
-                <a:ea typeface="Arial" pitchFamily="34" charset="-122"/>
-                <a:cs typeface="Arial" pitchFamily="34" charset="-120"/>
-              </a:rPr>
-              <a:t>Сайфер с половиной рэп-тусовки</a:t>
-            </a:r>
-            <a:endParaRPr lang="en-US" sz="1200" dirty="0"/>
-          </a:p>
-        </p:txBody>
-      </p:sp>
-      <p:sp>
-        <p:nvSpPr>
-          <p:cNvPr id="10" name="Text 8"/>
-          <p:cNvSpPr txBox="1"/>
-          <p:nvPr/>
-        </p:nvSpPr>
-        <p:spPr>
-          <a:xfrm>
-            <a:off x="548640" y="3602736"/>
-            <a:ext cx="502920" cy="292608"/>
-          </a:xfrm>
-          <a:prstGeom prst="rect">
-            <a:avLst/>
-          </a:prstGeom>
-          <a:noFill/>
-          <a:ln/>
-        </p:spPr>
-        <p:txBody>
-          <a:bodyPr wrap="square" lIns="0" tIns="0" rIns="0" bIns="0" rtlCol="0" anchor="ctr"/>
-          <a:lstStyle/>
-          <a:p>
-            <a:pPr indent="0" marL="0">
-              <a:buNone/>
-            </a:pPr>
-            <a:r>
-              <a:rPr lang="en-US" sz="1400" b="1" dirty="0">
-                <a:solidFill>
-                  <a:srgbClr val="8B7CF6"/>
-                </a:solidFill>
-                <a:latin typeface="Arial" pitchFamily="34" charset="0"/>
-                <a:ea typeface="Arial" pitchFamily="34" charset="-122"/>
-                <a:cs typeface="Arial" pitchFamily="34" charset="-120"/>
-              </a:rPr>
-              <a:t>03</a:t>
-            </a:r>
-            <a:endParaRPr lang="en-US" sz="1400" dirty="0"/>
-          </a:p>
-        </p:txBody>
-      </p:sp>
-      <p:sp>
-        <p:nvSpPr>
-          <p:cNvPr id="11" name="Text 9"/>
-          <p:cNvSpPr txBox="1"/>
-          <p:nvPr/>
-        </p:nvSpPr>
-        <p:spPr>
-          <a:xfrm>
-            <a:off x="1097280" y="3602736"/>
-            <a:ext cx="2926080" cy="292608"/>
-          </a:xfrm>
-          <a:prstGeom prst="rect">
-            <a:avLst/>
-          </a:prstGeom>
-          <a:noFill/>
-          <a:ln/>
-        </p:spPr>
-        <p:txBody>
-          <a:bodyPr wrap="square" lIns="0" tIns="0" rIns="0" bIns="0" rtlCol="0" anchor="ctr"/>
-          <a:lstStyle/>
-          <a:p>
-            <a:pPr indent="0" marL="0">
-              <a:buNone/>
-            </a:pPr>
-            <a:r>
-              <a:rPr lang="en-US" sz="1600" b="1" dirty="0">
-                <a:solidFill>
-                  <a:srgbClr val="F4F4F6"/>
-                </a:solidFill>
-                <a:latin typeface="Arial" pitchFamily="34" charset="0"/>
-                <a:ea typeface="Arial" pitchFamily="34" charset="-122"/>
-                <a:cs typeface="Arial" pitchFamily="34" charset="-120"/>
-              </a:rPr>
-              <a:t>«Bang»</a:t>
-            </a:r>
-            <a:endParaRPr lang="en-US" sz="1600" dirty="0"/>
-          </a:p>
-        </p:txBody>
-      </p:sp>
-      <p:sp>
-        <p:nvSpPr>
-          <p:cNvPr id="12" name="Text 10"/>
-          <p:cNvSpPr txBox="1"/>
-          <p:nvPr/>
-        </p:nvSpPr>
-        <p:spPr>
-          <a:xfrm>
-            <a:off x="1097280" y="3895344"/>
-            <a:ext cx="2926080" cy="274320"/>
-          </a:xfrm>
-          <a:prstGeom prst="rect">
-            <a:avLst/>
-          </a:prstGeom>
-          <a:noFill/>
-          <a:ln/>
-        </p:spPr>
-        <p:txBody>
-          <a:bodyPr wrap="square" lIns="0" tIns="0" rIns="0" bIns="0" rtlCol="0" anchor="ctr"/>
-          <a:lstStyle/>
-          <a:p>
-            <a:pPr indent="0" marL="0">
-              <a:buNone/>
-            </a:pPr>
-            <a:r>
-              <a:rPr lang="en-US" sz="1200" dirty="0">
-                <a:solidFill>
-                  <a:srgbClr val="8E8E9C"/>
-                </a:solidFill>
-                <a:latin typeface="Arial" pitchFamily="34" charset="0"/>
-                <a:ea typeface="Arial" pitchFamily="34" charset="-122"/>
-                <a:cs typeface="Arial" pitchFamily="34" charset="-120"/>
-              </a:rPr>
-              <a:t>Альбом с автотюновым трэпом</a:t>
-            </a:r>
-            <a:endParaRPr lang="en-US" sz="1200" dirty="0"/>
+              <a:t>Праймовый Джиган</a:t>
+            </a:r>
+            <a:endParaRPr lang="en-US" sz="3200" dirty="0"/>
           </a:p>
         </p:txBody>
       </p:sp>
       <p:pic>
         <p:nvPicPr>
-          <p:cNvPr id="13" name="Image 0" descr="Мем: когда фраза из стрима уже стала треком">    </p:cNvPr>
+          <p:cNvPr id="4" name="Image 0" descr="Мем: сможет ли праймовый Джиган репикнуть французскую империю в 1812 году">    </p:cNvPr>
           <p:cNvPicPr>
             <a:picLocks noChangeAspect="1"/>
           </p:cNvPicPr>
@@ -6228,8 +5860,8 @@
         </p:blipFill>
         <p:spPr>
           <a:xfrm>
-            <a:off x="4206240" y="1188720"/>
-            <a:ext cx="2148840" cy="2148840"/>
+            <a:off x="595732" y="1417320"/>
+            <a:ext cx="3308299" cy="2468880"/>
           </a:xfrm>
           <a:prstGeom prst="rect">
             <a:avLst/>
@@ -6238,7 +5870,7 @@
       </p:pic>
       <p:pic>
         <p:nvPicPr>
-          <p:cNvPr id="14" name="Image 1" descr="Мем: критики про технику рифмы — я на чиле">    </p:cNvPr>
+          <p:cNvPr id="5" name="Image 1" descr="Мем: сможет ли праймовый Джиган взять 1 v 5 против Vitality">    </p:cNvPr>
           <p:cNvPicPr>
             <a:picLocks noChangeAspect="1"/>
           </p:cNvPicPr>
@@ -6252,8 +5884,8 @@
         </p:blipFill>
         <p:spPr>
           <a:xfrm>
-            <a:off x="6629400" y="1188720"/>
-            <a:ext cx="2148840" cy="2148840"/>
+            <a:off x="4178351" y="1417320"/>
+            <a:ext cx="4369918" cy="2468880"/>
           </a:xfrm>
           <a:prstGeom prst="rect">
             <a:avLst/>
@@ -6262,30 +5894,30 @@
       </p:pic>
       <p:sp>
         <p:nvSpPr>
-          <p:cNvPr id="15" name="Text 11"/>
-          <p:cNvSpPr txBox="1"/>
-          <p:nvPr/>
-        </p:nvSpPr>
-        <p:spPr>
-          <a:xfrm>
-            <a:off x="4206240" y="3566160"/>
-            <a:ext cx="4572000" cy="274320"/>
-          </a:xfrm>
-          <a:prstGeom prst="rect">
-            <a:avLst/>
-          </a:prstGeom>
-          <a:noFill/>
-          <a:ln/>
-        </p:spPr>
-        <p:txBody>
-          <a:bodyPr wrap="square" lIns="0" tIns="0" rIns="0" bIns="0" rtlCol="0" anchor="ctr"/>
-          <a:lstStyle/>
-          <a:p>
-            <a:pPr indent="0" marL="0">
-              <a:buNone/>
-            </a:pPr>
-            <a:r>
-              <a:rPr lang="en-US" sz="1300" b="1" dirty="0">
+          <p:cNvPr id="6" name="Text 2"/>
+          <p:cNvSpPr txBox="1"/>
+          <p:nvPr/>
+        </p:nvSpPr>
+        <p:spPr>
+          <a:xfrm>
+            <a:off x="548640" y="4114800"/>
+            <a:ext cx="6858000" cy="320040"/>
+          </a:xfrm>
+          <a:prstGeom prst="rect">
+            <a:avLst/>
+          </a:prstGeom>
+          <a:noFill/>
+          <a:ln/>
+        </p:spPr>
+        <p:txBody>
+          <a:bodyPr wrap="square" lIns="0" tIns="0" rIns="0" bIns="0" rtlCol="0" anchor="ctr"/>
+          <a:lstStyle/>
+          <a:p>
+            <a:pPr indent="0" marL="0">
+              <a:buNone/>
+            </a:pPr>
+            <a:r>
+              <a:rPr lang="en-US" sz="1400" b="1" dirty="0">
                 <a:solidFill>
                   <a:srgbClr val="8B7CF6"/>
                 </a:solidFill>
@@ -6293,22 +5925,36 @@
                 <a:ea typeface="Arial" pitchFamily="34" charset="-122"/>
                 <a:cs typeface="Arial" pitchFamily="34" charset="-120"/>
               </a:rPr>
-              <a:t>Вирусная фраза → трек → охваты</a:t>
-            </a:r>
-            <a:endParaRPr lang="en-US" sz="1300" dirty="0"/>
-          </a:p>
-        </p:txBody>
-      </p:sp>
-      <p:sp>
-        <p:nvSpPr>
-          <p:cNvPr id="16" name="Text 12"/>
-          <p:cNvSpPr txBox="1"/>
-          <p:nvPr/>
-        </p:nvSpPr>
-        <p:spPr>
-          <a:xfrm>
-            <a:off x="4206240" y="3886200"/>
-            <a:ext cx="4572000" cy="228600"/>
+              <a:t>Мем → трек:  </a:t>
+            </a:r>
+            <a:pPr indent="0" marL="0">
+              <a:buNone/>
+            </a:pPr>
+            <a:r>
+              <a:rPr lang="en-US" sz="1400" b="1" dirty="0">
+                <a:solidFill>
+                  <a:srgbClr val="F4F4F6"/>
+                </a:solidFill>
+                <a:latin typeface="Arial" pitchFamily="34" charset="0"/>
+                <a:ea typeface="Arial" pitchFamily="34" charset="-122"/>
+                <a:cs typeface="Arial" pitchFamily="34" charset="-120"/>
+              </a:rPr>
+              <a:t>«Хавчик» · «На чиле» · альбом «Bang»</a:t>
+            </a:r>
+            <a:endParaRPr lang="en-US" sz="1400" dirty="0"/>
+          </a:p>
+        </p:txBody>
+      </p:sp>
+      <p:sp>
+        <p:nvSpPr>
+          <p:cNvPr id="7" name="Text 3"/>
+          <p:cNvSpPr txBox="1"/>
+          <p:nvPr/>
+        </p:nvSpPr>
+        <p:spPr>
+          <a:xfrm>
+            <a:off x="548640" y="4480560"/>
+            <a:ext cx="5486400" cy="228600"/>
           </a:xfrm>
           <a:prstGeom prst="rect">
             <a:avLst/>
@@ -6332,7 +5978,7 @@
                 <a:ea typeface="Arial" pitchFamily="34" charset="-122"/>
                 <a:cs typeface="Arial" pitchFamily="34" charset="-120"/>
               </a:rPr>
-              <a:t>Мемы на основе фото: Okras; Алексей Гоманков · CC BY-SA 4.0</a:t>
+              <a:t>Мемы: пользователи соцсетей</a:t>
             </a:r>
             <a:endParaRPr lang="en-US" sz="800" dirty="0"/>
           </a:p>
@@ -6340,7 +5986,7 @@
       </p:sp>
       <p:sp>
         <p:nvSpPr>
-          <p:cNvPr id="17" name="Text 13"/>
+          <p:cNvPr id="8" name="Text 4"/>
           <p:cNvSpPr txBox="1"/>
           <p:nvPr/>
         </p:nvSpPr>

</xml_diff>

<commit_message>
Dzhigan v2: add meme stickers across slides
Co-Authored-By: Claude Opus 5.5 <noreply@anthropic.com>
Claude-Session: https://claude.ai/code/session_01ESKVy2aSLgHDCNezBhnSbq
</commit_message>
<xml_diff>
--- a/Dzhigan_v2.pptx
+++ b/Dzhigan_v2.pptx
@@ -3369,9 +3369,33 @@
           </a:p>
         </p:txBody>
       </p:sp>
-      <p:sp>
-        <p:nvSpPr>
-          <p:cNvPr id="17" name="Text 14"/>
+      <p:pic>
+        <p:nvPicPr>
+          <p:cNvPr id="17" name="Image 1" descr="Мем: кот, который планирует спать до моего возвращения — пока на расслабоне, на чиле">    </p:cNvPr>
+          <p:cNvPicPr>
+            <a:picLocks noChangeAspect="1"/>
+          </p:cNvPicPr>
+          <p:nvPr/>
+        </p:nvPicPr>
+        <p:blipFill>
+          <a:blip r:embed="rId2"/>
+          <a:stretch>
+            <a:fillRect/>
+          </a:stretch>
+        </p:blipFill>
+        <p:spPr>
+          <a:xfrm rot="-300000">
+            <a:off x="1920240" y="2788920"/>
+            <a:ext cx="1554480" cy="1488966"/>
+          </a:xfrm>
+          <a:prstGeom prst="rect">
+            <a:avLst/>
+          </a:prstGeom>
+        </p:spPr>
+      </p:pic>
+      <p:sp>
+        <p:nvSpPr>
+          <p:cNvPr id="18" name="Text 14"/>
           <p:cNvSpPr txBox="1"/>
           <p:nvPr/>
         </p:nvSpPr>
@@ -4028,9 +4052,33 @@
           </a:p>
         </p:txBody>
       </p:sp>
-      <p:sp>
-        <p:nvSpPr>
-          <p:cNvPr id="18" name="Text 16"/>
+      <p:pic>
+        <p:nvPicPr>
+          <p:cNvPr id="18" name="Image 0" descr="Мем: мой безработный друг — пока на расслабоне, на чиле">    </p:cNvPr>
+          <p:cNvPicPr>
+            <a:picLocks noChangeAspect="1"/>
+          </p:cNvPicPr>
+          <p:nvPr/>
+        </p:nvPicPr>
+        <p:blipFill>
+          <a:blip r:embed="rId1"/>
+          <a:stretch>
+            <a:fillRect/>
+          </a:stretch>
+        </p:blipFill>
+        <p:spPr>
+          <a:xfrm rot="300000">
+            <a:off x="7178040" y="274320"/>
+            <a:ext cx="1371600" cy="1237906"/>
+          </a:xfrm>
+          <a:prstGeom prst="rect">
+            <a:avLst/>
+          </a:prstGeom>
+        </p:spPr>
+      </p:pic>
+      <p:sp>
+        <p:nvSpPr>
+          <p:cNvPr id="19" name="Text 16"/>
           <p:cNvSpPr txBox="1"/>
           <p:nvPr/>
         </p:nvSpPr>
@@ -4644,9 +4692,33 @@
           </a:p>
         </p:txBody>
       </p:sp>
-      <p:sp>
-        <p:nvSpPr>
-          <p:cNvPr id="15" name="Text 13"/>
+      <p:pic>
+        <p:nvPicPr>
+          <p:cNvPr id="15" name="Image 0" descr="Мем: огромная очередь, второй кассир — пока на расслабоне, на чиле">    </p:cNvPr>
+          <p:cNvPicPr>
+            <a:picLocks noChangeAspect="1"/>
+          </p:cNvPicPr>
+          <p:nvPr/>
+        </p:nvPicPr>
+        <p:blipFill>
+          <a:blip r:embed="rId1"/>
+          <a:stretch>
+            <a:fillRect/>
+          </a:stretch>
+        </p:blipFill>
+        <p:spPr>
+          <a:xfrm rot="-240000">
+            <a:off x="7269480" y="228600"/>
+            <a:ext cx="1325880" cy="1325880"/>
+          </a:xfrm>
+          <a:prstGeom prst="rect">
+            <a:avLst/>
+          </a:prstGeom>
+        </p:spPr>
+      </p:pic>
+      <p:sp>
+        <p:nvSpPr>
+          <p:cNvPr id="16" name="Text 13"/>
           <p:cNvSpPr txBox="1"/>
           <p:nvPr/>
         </p:nvSpPr>
@@ -5273,9 +5345,33 @@
           </a:p>
         </p:txBody>
       </p:sp>
-      <p:sp>
-        <p:nvSpPr>
-          <p:cNvPr id="17" name="Text 14"/>
+      <p:pic>
+        <p:nvPicPr>
+          <p:cNvPr id="17" name="Image 1" descr="Мем: сверстники строят карьеру, а я — пока на расслабоне, на чиле">    </p:cNvPr>
+          <p:cNvPicPr>
+            <a:picLocks noChangeAspect="1"/>
+          </p:cNvPicPr>
+          <p:nvPr/>
+        </p:nvPicPr>
+        <p:blipFill>
+          <a:blip r:embed="rId2"/>
+          <a:stretch>
+            <a:fillRect/>
+          </a:stretch>
+        </p:blipFill>
+        <p:spPr>
+          <a:xfrm rot="240000">
+            <a:off x="3840480" y="1965960"/>
+            <a:ext cx="1188720" cy="1664874"/>
+          </a:xfrm>
+          <a:prstGeom prst="rect">
+            <a:avLst/>
+          </a:prstGeom>
+        </p:spPr>
+      </p:pic>
+      <p:sp>
+        <p:nvSpPr>
+          <p:cNvPr id="18" name="Text 14"/>
           <p:cNvSpPr txBox="1"/>
           <p:nvPr/>
         </p:nvSpPr>
@@ -5695,9 +5791,33 @@
           </a:p>
         </p:txBody>
       </p:sp>
-      <p:sp>
-        <p:nvSpPr>
-          <p:cNvPr id="10" name="Text 8"/>
+      <p:pic>
+        <p:nvPicPr>
+          <p:cNvPr id="10" name="Image 0" descr="Мем с котами: Джиган, хватит чилить">    </p:cNvPr>
+          <p:cNvPicPr>
+            <a:picLocks noChangeAspect="1"/>
+          </p:cNvPicPr>
+          <p:nvPr/>
+        </p:nvPicPr>
+        <p:blipFill>
+          <a:blip r:embed="rId1"/>
+          <a:stretch>
+            <a:fillRect/>
+          </a:stretch>
+        </p:blipFill>
+        <p:spPr>
+          <a:xfrm rot="-240000">
+            <a:off x="2834640" y="1143000"/>
+            <a:ext cx="1783080" cy="1358020"/>
+          </a:xfrm>
+          <a:prstGeom prst="rect">
+            <a:avLst/>
+          </a:prstGeom>
+        </p:spPr>
+      </p:pic>
+      <p:sp>
+        <p:nvSpPr>
+          <p:cNvPr id="11" name="Text 8"/>
           <p:cNvSpPr txBox="1"/>
           <p:nvPr/>
         </p:nvSpPr>
@@ -6577,9 +6697,33 @@
           </a:p>
         </p:txBody>
       </p:sp>
-      <p:sp>
-        <p:nvSpPr>
-          <p:cNvPr id="15" name="Text 13"/>
+      <p:pic>
+        <p:nvPicPr>
+          <p:cNvPr id="15" name="Image 0" descr="Мем: Джиган сражается с медузой, используя краба как щит и барракуду как меч">    </p:cNvPr>
+          <p:cNvPicPr>
+            <a:picLocks noChangeAspect="1"/>
+          </p:cNvPicPr>
+          <p:nvPr/>
+        </p:nvPicPr>
+        <p:blipFill>
+          <a:blip r:embed="rId1"/>
+          <a:stretch>
+            <a:fillRect/>
+          </a:stretch>
+        </p:blipFill>
+        <p:spPr>
+          <a:xfrm rot="240000">
+            <a:off x="6720840" y="274320"/>
+            <a:ext cx="1737360" cy="1872155"/>
+          </a:xfrm>
+          <a:prstGeom prst="rect">
+            <a:avLst/>
+          </a:prstGeom>
+        </p:spPr>
+      </p:pic>
+      <p:sp>
+        <p:nvSpPr>
+          <p:cNvPr id="16" name="Text 13"/>
           <p:cNvSpPr txBox="1"/>
           <p:nvPr/>
         </p:nvSpPr>
@@ -7166,9 +7310,33 @@
           </a:p>
         </p:txBody>
       </p:sp>
-      <p:sp>
-        <p:nvSpPr>
-          <p:cNvPr id="15" name="Text 13"/>
+      <p:pic>
+        <p:nvPicPr>
+          <p:cNvPr id="15" name="Image 0" descr="Твит: никогда не жалею ни о чём, кроме того, что Джиган не мой батя">    </p:cNvPr>
+          <p:cNvPicPr>
+            <a:picLocks noChangeAspect="1"/>
+          </p:cNvPicPr>
+          <p:nvPr/>
+        </p:nvPicPr>
+        <p:blipFill>
+          <a:blip r:embed="rId1"/>
+          <a:stretch>
+            <a:fillRect/>
+          </a:stretch>
+        </p:blipFill>
+        <p:spPr>
+          <a:xfrm rot="120000">
+            <a:off x="4937760" y="365760"/>
+            <a:ext cx="3657600" cy="1028571"/>
+          </a:xfrm>
+          <a:prstGeom prst="rect">
+            <a:avLst/>
+          </a:prstGeom>
+        </p:spPr>
+      </p:pic>
+      <p:sp>
+        <p:nvSpPr>
+          <p:cNvPr id="16" name="Text 13"/>
           <p:cNvSpPr txBox="1"/>
           <p:nvPr/>
         </p:nvSpPr>

</xml_diff>

<commit_message>
Dzhigan v2: restore slide 7, move prime memes to farewell slide
Co-Authored-By: Claude Opus 5.5 <noreply@anthropic.com>
Claude-Session: https://claude.ai/code/session_01ESKVy2aSLgHDCNezBhnSbq
</commit_message>
<xml_diff>
--- a/Dzhigan_v2.pptx
+++ b/Dzhigan_v2.pptx
@@ -15,9 +15,10 @@
     <p:sldId id="263" r:id="rId9"/>
     <p:sldId id="264" r:id="rId10"/>
     <p:sldId id="265" r:id="rId11"/>
+    <p:sldId id="266" r:id="rId12"/>
   </p:sldIdLst>
   <p:notesMasterIdLst>
-    <p:notesMasterId r:id="rId12"/>
+    <p:notesMasterId r:id="rId13"/>
   </p:notesMasterIdLst>
   <p:sldSz cx="9144000" cy="5143500"/>
   <p:notesSz cx="5143500" cy="9144000"/>
@@ -599,7 +600,7 @@
           <a:p>
             <a:r>
               <a:rPr lang="en-US" dirty="0"/>
-              <a:t>За двадцать лет Джиган прошел путь от клубных сетов в Одессе до высших наград стриминговой эпохи. Даже сейчас, когда музыка отошла для него на второй план, он остается редким примером артиста, сумевшего пройти через несколько смен трендов исключительно за счет нюха на хиты. Спасибо за внимание!</a:t>
+              <a:t>За двадцать лет Джиган прошел путь от клубных сетов в Одессе до высших наград стриминговой эпохи. Даже сейчас, когда музыка отошла для него на второй план, он остается редким примером артиста, сумевшего пройти через несколько смен трендов исключительно за счет нюха на хиты.</a:t>
             </a:r>
             <a:endParaRPr lang="en-US" dirty="0"/>
           </a:p>
@@ -623,6 +624,94 @@
             <a:fld id="{F7021451-1387-4CA6-816F-3879F97B5CBC}" type="slidenum">
               <a:rPr lang="en-US"/>
               <a:t>10</a:t>
+            </a:fld>
+            <a:endParaRPr lang="en-US"/>
+          </a:p>
+        </p:txBody>
+      </p:sp>
+    </p:spTree>
+    <p:extLst>
+      <p:ext uri="{BB962C8B-B14F-4D97-AF65-F5344CB8AC3E}">
+        <p14:creationId xmlns:p14="http://schemas.microsoft.com/office/powerpoint/2010/main" val="1024086991"/>
+      </p:ext>
+    </p:extLst>
+  </p:cSld>
+  <p:clrMapOvr>
+    <a:masterClrMapping/>
+  </p:clrMapOvr>
+</p:notes>
+</file>
+
+<file path=ppt/notesSlides/notesSlide11.xml><?xml version="1.0" encoding="utf-8"?>
+<p:notes xmlns:a="http://schemas.openxmlformats.org/drawingml/2006/main" xmlns:r="http://schemas.openxmlformats.org/officeDocument/2006/relationships" xmlns:p="http://schemas.openxmlformats.org/presentationml/2006/main">
+  <p:cSld>
+    <p:spTree>
+      <p:nvGrpSpPr>
+        <p:cNvPr id="1" name=""/>
+        <p:cNvGrpSpPr/>
+        <p:nvPr/>
+      </p:nvGrpSpPr>
+      <p:grpSpPr>
+        <a:xfrm>
+          <a:off x="0" y="0"/>
+          <a:ext cx="0" cy="0"/>
+          <a:chOff x="0" y="0"/>
+          <a:chExt cx="0" cy="0"/>
+        </a:xfrm>
+      </p:grpSpPr>
+      <p:sp>
+        <p:nvSpPr>
+          <p:cNvPr id="2" name="Slide Image Placeholder 1"/>
+          <p:cNvSpPr>
+            <a:spLocks noGrp="1" noRot="1" noChangeAspect="1"/>
+          </p:cNvSpPr>
+          <p:nvPr>
+            <p:ph type="sldImg"/>
+          </p:nvPr>
+        </p:nvSpPr>
+        <p:spPr/>
+      </p:sp>
+      <p:sp>
+        <p:nvSpPr>
+          <p:cNvPr id="3" name="Notes Placeholder 2"/>
+          <p:cNvSpPr>
+            <a:spLocks noGrp="1"/>
+          </p:cNvSpPr>
+          <p:nvPr>
+            <p:ph type="body" idx="1"/>
+          </p:nvPr>
+        </p:nvSpPr>
+        <p:spPr/>
+        <p:txBody>
+          <a:bodyPr/>
+          <a:lstStyle/>
+          <a:p>
+            <a:r>
+              <a:rPr lang="en-US" dirty="0"/>
+              <a:t>Спасибо за внимание! Напоследок — «праймовый Джиган»: мем, где его ставят против целой империи или против киберспортивной команды. Лучшая иллюстрация того, каким масштабным он остается в глазах интернета. Готов ответить на ваши вопросы.</a:t>
+            </a:r>
+            <a:endParaRPr lang="en-US" dirty="0"/>
+          </a:p>
+        </p:txBody>
+      </p:sp>
+      <p:sp>
+        <p:nvSpPr>
+          <p:cNvPr id="4" name="Slide Number Placeholder 3"/>
+          <p:cNvSpPr>
+            <a:spLocks noGrp="1"/>
+          </p:cNvSpPr>
+          <p:nvPr>
+            <p:ph type="sldNum" sz="quarter" idx="10"/>
+          </p:nvPr>
+        </p:nvSpPr>
+        <p:spPr/>
+        <p:txBody>
+          <a:bodyPr/>
+          <a:lstStyle/>
+          <a:p>
+            <a:fld id="{F7021451-1387-4CA6-816F-3879F97B5CBC}" type="slidenum">
+              <a:rPr lang="en-US"/>
+              <a:t>11</a:t>
             </a:fld>
             <a:endParaRPr lang="en-US"/>
           </a:p>
@@ -2700,7 +2789,7 @@
               <a:buNone/>
             </a:pPr>
             <a:r>
-              <a:rPr lang="en-US" sz="2800" b="1" dirty="0">
+              <a:rPr lang="en-US" sz="2600" b="1" dirty="0">
                 <a:solidFill>
                   <a:srgbClr val="F4F4F6"/>
                 </a:solidFill>
@@ -2708,9 +2797,9 @@
                 <a:ea typeface="Arial" pitchFamily="34" charset="-122"/>
                 <a:cs typeface="Arial" pitchFamily="34" charset="-120"/>
               </a:rPr>
-              <a:t>Спасибо за внимание!</a:t>
-            </a:r>
-            <a:endParaRPr lang="en-US" sz="2800" dirty="0"/>
+              <a:t>Главное оружие — нюх на хиты</a:t>
+            </a:r>
+            <a:endParaRPr lang="en-US" sz="2600" dirty="0"/>
           </a:p>
         </p:txBody>
       </p:sp>
@@ -2747,7 +2836,282 @@
                 <a:ea typeface="Arial" pitchFamily="34" charset="-122"/>
                 <a:cs typeface="Arial" pitchFamily="34" charset="-120"/>
               </a:rPr>
-              <a:t>10 / 10</a:t>
+              <a:t>10 / 11</a:t>
+            </a:r>
+            <a:endParaRPr lang="en-US" sz="900" dirty="0"/>
+          </a:p>
+        </p:txBody>
+      </p:sp>
+    </p:spTree>
+  </p:cSld>
+  <p:clrMapOvr>
+    <a:masterClrMapping/>
+  </p:clrMapOvr>
+</p:sld>
+</file>
+
+<file path=ppt/slides/slide11.xml><?xml version="1.0" encoding="utf-8"?>
+<p:sld xmlns:a="http://schemas.openxmlformats.org/drawingml/2006/main" xmlns:r="http://schemas.openxmlformats.org/officeDocument/2006/relationships" xmlns:p="http://schemas.openxmlformats.org/presentationml/2006/main">
+  <p:cSld name="Slide 11">
+    <p:bg>
+      <p:bgPr>
+        <a:solidFill>
+          <a:srgbClr val="0B0B10"/>
+        </a:solidFill>
+      </p:bgPr>
+    </p:bg>
+    <p:spTree>
+      <p:nvGrpSpPr>
+        <p:cNvPr id="1" name=""/>
+        <p:cNvGrpSpPr/>
+        <p:nvPr/>
+      </p:nvGrpSpPr>
+      <p:grpSpPr>
+        <a:xfrm>
+          <a:off x="0" y="0"/>
+          <a:ext cx="0" cy="0"/>
+          <a:chOff x="0" y="0"/>
+          <a:chExt cx="0" cy="0"/>
+        </a:xfrm>
+      </p:grpSpPr>
+      <p:sp>
+        <p:nvSpPr>
+          <p:cNvPr id="2" name="Text 0"/>
+          <p:cNvSpPr txBox="1"/>
+          <p:nvPr/>
+        </p:nvSpPr>
+        <p:spPr>
+          <a:xfrm>
+            <a:off x="548640" y="411480"/>
+            <a:ext cx="4572000" cy="274320"/>
+          </a:xfrm>
+          <a:prstGeom prst="rect">
+            <a:avLst/>
+          </a:prstGeom>
+          <a:noFill/>
+          <a:ln/>
+        </p:spPr>
+        <p:txBody>
+          <a:bodyPr wrap="square" lIns="0" tIns="0" rIns="0" bIns="0" rtlCol="0" anchor="ctr"/>
+          <a:lstStyle/>
+          <a:p>
+            <a:pPr indent="0" marL="0">
+              <a:buNone/>
+            </a:pPr>
+            <a:r>
+              <a:rPr lang="en-US" sz="1000" b="1" spc="300" kern="0" dirty="0">
+                <a:solidFill>
+                  <a:srgbClr val="8B7CF6"/>
+                </a:solidFill>
+                <a:latin typeface="Arial" pitchFamily="34" charset="0"/>
+                <a:ea typeface="Arial" pitchFamily="34" charset="-122"/>
+                <a:cs typeface="Arial" pitchFamily="34" charset="-120"/>
+              </a:rPr>
+              <a:t>ФИНАЛ</a:t>
+            </a:r>
+            <a:endParaRPr lang="en-US" sz="1000" dirty="0"/>
+          </a:p>
+        </p:txBody>
+      </p:sp>
+      <p:pic>
+        <p:nvPicPr>
+          <p:cNvPr id="3" name="Image 0" descr="Мем: сможет ли праймовый Джиган репикнуть французскую империю в 1812 году">    </p:cNvPr>
+          <p:cNvPicPr>
+            <a:picLocks noChangeAspect="1"/>
+          </p:cNvPicPr>
+          <p:nvPr/>
+        </p:nvPicPr>
+        <p:blipFill>
+          <a:blip r:embed="rId1"/>
+          <a:stretch>
+            <a:fillRect/>
+          </a:stretch>
+        </p:blipFill>
+        <p:spPr>
+          <a:xfrm>
+            <a:off x="595732" y="868680"/>
+            <a:ext cx="3308299" cy="2468880"/>
+          </a:xfrm>
+          <a:prstGeom prst="rect">
+            <a:avLst/>
+          </a:prstGeom>
+        </p:spPr>
+      </p:pic>
+      <p:pic>
+        <p:nvPicPr>
+          <p:cNvPr id="4" name="Image 1" descr="Мем: сможет ли праймовый Джиган взять 1 v 5 против Vitality">    </p:cNvPr>
+          <p:cNvPicPr>
+            <a:picLocks noChangeAspect="1"/>
+          </p:cNvPicPr>
+          <p:nvPr/>
+        </p:nvPicPr>
+        <p:blipFill>
+          <a:blip r:embed="rId2"/>
+          <a:stretch>
+            <a:fillRect/>
+          </a:stretch>
+        </p:blipFill>
+        <p:spPr>
+          <a:xfrm>
+            <a:off x="4178351" y="868680"/>
+            <a:ext cx="4369918" cy="2468880"/>
+          </a:xfrm>
+          <a:prstGeom prst="rect">
+            <a:avLst/>
+          </a:prstGeom>
+        </p:spPr>
+      </p:pic>
+      <p:sp>
+        <p:nvSpPr>
+          <p:cNvPr id="5" name="Text 1"/>
+          <p:cNvSpPr txBox="1"/>
+          <p:nvPr/>
+        </p:nvSpPr>
+        <p:spPr>
+          <a:xfrm>
+            <a:off x="548640" y="3611880"/>
+            <a:ext cx="8046720" cy="548640"/>
+          </a:xfrm>
+          <a:prstGeom prst="rect">
+            <a:avLst/>
+          </a:prstGeom>
+          <a:noFill/>
+          <a:ln/>
+        </p:spPr>
+        <p:txBody>
+          <a:bodyPr wrap="square" lIns="0" tIns="0" rIns="0" bIns="0" rtlCol="0" anchor="ctr"/>
+          <a:lstStyle/>
+          <a:p>
+            <a:pPr algn="ctr" indent="0" marL="0">
+              <a:buNone/>
+            </a:pPr>
+            <a:r>
+              <a:rPr lang="en-US" sz="3200" b="1" dirty="0">
+                <a:solidFill>
+                  <a:srgbClr val="F4F4F6"/>
+                </a:solidFill>
+                <a:latin typeface="Arial" pitchFamily="34" charset="0"/>
+                <a:ea typeface="Arial" pitchFamily="34" charset="-122"/>
+                <a:cs typeface="Arial" pitchFamily="34" charset="-120"/>
+              </a:rPr>
+              <a:t>Спасибо за внимание!</a:t>
+            </a:r>
+            <a:endParaRPr lang="en-US" sz="3200" dirty="0"/>
+          </a:p>
+        </p:txBody>
+      </p:sp>
+      <p:sp>
+        <p:nvSpPr>
+          <p:cNvPr id="6" name="Text 2"/>
+          <p:cNvSpPr txBox="1"/>
+          <p:nvPr/>
+        </p:nvSpPr>
+        <p:spPr>
+          <a:xfrm>
+            <a:off x="548640" y="4160520"/>
+            <a:ext cx="8046720" cy="320040"/>
+          </a:xfrm>
+          <a:prstGeom prst="rect">
+            <a:avLst/>
+          </a:prstGeom>
+          <a:noFill/>
+          <a:ln/>
+        </p:spPr>
+        <p:txBody>
+          <a:bodyPr wrap="square" lIns="0" tIns="0" rIns="0" bIns="0" rtlCol="0" anchor="ctr"/>
+          <a:lstStyle/>
+          <a:p>
+            <a:pPr algn="ctr" indent="0" marL="0">
+              <a:buNone/>
+            </a:pPr>
+            <a:r>
+              <a:rPr lang="en-US" sz="1400" dirty="0">
+                <a:solidFill>
+                  <a:srgbClr val="8B7CF6"/>
+                </a:solidFill>
+                <a:latin typeface="Arial" pitchFamily="34" charset="0"/>
+                <a:ea typeface="Arial" pitchFamily="34" charset="-122"/>
+                <a:cs typeface="Arial" pitchFamily="34" charset="-120"/>
+              </a:rPr>
+              <a:t>Сможет ли праймовый Джиган ответить на ваши вопросы? Проверим</a:t>
+            </a:r>
+            <a:endParaRPr lang="en-US" sz="1400" dirty="0"/>
+          </a:p>
+        </p:txBody>
+      </p:sp>
+      <p:sp>
+        <p:nvSpPr>
+          <p:cNvPr id="7" name="Text 3"/>
+          <p:cNvSpPr txBox="1"/>
+          <p:nvPr/>
+        </p:nvSpPr>
+        <p:spPr>
+          <a:xfrm>
+            <a:off x="548640" y="4663440"/>
+            <a:ext cx="4572000" cy="228600"/>
+          </a:xfrm>
+          <a:prstGeom prst="rect">
+            <a:avLst/>
+          </a:prstGeom>
+          <a:noFill/>
+          <a:ln/>
+        </p:spPr>
+        <p:txBody>
+          <a:bodyPr wrap="square" lIns="0" tIns="0" rIns="0" bIns="0" rtlCol="0" anchor="ctr"/>
+          <a:lstStyle/>
+          <a:p>
+            <a:pPr indent="0" marL="0">
+              <a:buNone/>
+            </a:pPr>
+            <a:r>
+              <a:rPr lang="en-US" sz="800" dirty="0">
+                <a:solidFill>
+                  <a:srgbClr val="8E8E9C"/>
+                </a:solidFill>
+                <a:latin typeface="Arial" pitchFamily="34" charset="0"/>
+                <a:ea typeface="Arial" pitchFamily="34" charset="-122"/>
+                <a:cs typeface="Arial" pitchFamily="34" charset="-120"/>
+              </a:rPr>
+              <a:t>Мемы: пользователи соцсетей</a:t>
+            </a:r>
+            <a:endParaRPr lang="en-US" sz="800" dirty="0"/>
+          </a:p>
+        </p:txBody>
+      </p:sp>
+      <p:sp>
+        <p:nvSpPr>
+          <p:cNvPr id="8" name="Text 4"/>
+          <p:cNvSpPr txBox="1"/>
+          <p:nvPr/>
+        </p:nvSpPr>
+        <p:spPr>
+          <a:xfrm>
+            <a:off x="7680960" y="4663440"/>
+            <a:ext cx="914400" cy="228600"/>
+          </a:xfrm>
+          <a:prstGeom prst="rect">
+            <a:avLst/>
+          </a:prstGeom>
+          <a:noFill/>
+          <a:ln/>
+        </p:spPr>
+        <p:txBody>
+          <a:bodyPr wrap="square" lIns="0" tIns="0" rIns="0" bIns="0" rtlCol="0" anchor="ctr"/>
+          <a:lstStyle/>
+          <a:p>
+            <a:pPr algn="r" indent="0" marL="0">
+              <a:buNone/>
+            </a:pPr>
+            <a:r>
+              <a:rPr lang="en-US" sz="900" dirty="0">
+                <a:solidFill>
+                  <a:srgbClr val="8E8E9C"/>
+                </a:solidFill>
+                <a:latin typeface="Arial" pitchFamily="34" charset="0"/>
+                <a:ea typeface="Arial" pitchFamily="34" charset="-122"/>
+                <a:cs typeface="Arial" pitchFamily="34" charset="-120"/>
+              </a:rPr>
+              <a:t>11 / 11</a:t>
             </a:r>
             <a:endParaRPr lang="en-US" sz="900" dirty="0"/>
           </a:p>
@@ -3426,7 +3790,7 @@
                 <a:ea typeface="Arial" pitchFamily="34" charset="-122"/>
                 <a:cs typeface="Arial" pitchFamily="34" charset="-120"/>
               </a:rPr>
-              <a:t>02 / 10</a:t>
+              <a:t>02 / 11</a:t>
             </a:r>
             <a:endParaRPr lang="en-US" sz="900" dirty="0"/>
           </a:p>
@@ -4109,7 +4473,7 @@
                 <a:ea typeface="Arial" pitchFamily="34" charset="-122"/>
                 <a:cs typeface="Arial" pitchFamily="34" charset="-120"/>
               </a:rPr>
-              <a:t>03 / 10</a:t>
+              <a:t>03 / 11</a:t>
             </a:r>
             <a:endParaRPr lang="en-US" sz="900" dirty="0"/>
           </a:p>
@@ -4749,7 +5113,7 @@
                 <a:ea typeface="Arial" pitchFamily="34" charset="-122"/>
                 <a:cs typeface="Arial" pitchFamily="34" charset="-120"/>
               </a:rPr>
-              <a:t>04 / 10</a:t>
+              <a:t>04 / 11</a:t>
             </a:r>
             <a:endParaRPr lang="en-US" sz="900" dirty="0"/>
           </a:p>
@@ -5402,7 +5766,7 @@
                 <a:ea typeface="Arial" pitchFamily="34" charset="-122"/>
                 <a:cs typeface="Arial" pitchFamily="34" charset="-120"/>
               </a:rPr>
-              <a:t>05 / 10</a:t>
+              <a:t>05 / 11</a:t>
             </a:r>
             <a:endParaRPr lang="en-US" sz="900" dirty="0"/>
           </a:p>
@@ -5848,7 +6212,7 @@
                 <a:ea typeface="Arial" pitchFamily="34" charset="-122"/>
                 <a:cs typeface="Arial" pitchFamily="34" charset="-120"/>
               </a:rPr>
-              <a:t>06 / 10</a:t>
+              <a:t>06 / 11</a:t>
             </a:r>
             <a:endParaRPr lang="en-US" sz="900" dirty="0"/>
           </a:p>
@@ -5950,7 +6314,7 @@
               <a:buNone/>
             </a:pPr>
             <a:r>
-              <a:rPr lang="en-US" sz="3200" b="1" dirty="0">
+              <a:rPr lang="en-US" sz="3400" b="1" dirty="0">
                 <a:solidFill>
                   <a:srgbClr val="F4F4F6"/>
                 </a:solidFill>
@@ -5958,86 +6322,470 @@
                 <a:ea typeface="Arial" pitchFamily="34" charset="-122"/>
                 <a:cs typeface="Arial" pitchFamily="34" charset="-120"/>
               </a:rPr>
-              <a:t>Праймовый Джиган</a:t>
-            </a:r>
-            <a:endParaRPr lang="en-US" sz="3200" dirty="0"/>
-          </a:p>
-        </p:txBody>
-      </p:sp>
-      <p:pic>
-        <p:nvPicPr>
-          <p:cNvPr id="4" name="Image 0" descr="Мем: сможет ли праймовый Джиган репикнуть французскую империю в 1812 году">    </p:cNvPr>
-          <p:cNvPicPr>
-            <a:picLocks noChangeAspect="1"/>
-          </p:cNvPicPr>
-          <p:nvPr/>
-        </p:nvPicPr>
-        <p:blipFill>
-          <a:blip r:embed="rId1"/>
-          <a:stretch>
-            <a:fillRect/>
-          </a:stretch>
-        </p:blipFill>
-        <p:spPr>
-          <a:xfrm>
-            <a:off x="595732" y="1417320"/>
-            <a:ext cx="3308299" cy="2468880"/>
-          </a:xfrm>
-          <a:prstGeom prst="rect">
-            <a:avLst/>
-          </a:prstGeom>
-        </p:spPr>
-      </p:pic>
-      <p:pic>
-        <p:nvPicPr>
-          <p:cNvPr id="5" name="Image 1" descr="Мем: сможет ли праймовый Джиган взять 1 v 5 против Vitality">    </p:cNvPr>
-          <p:cNvPicPr>
-            <a:picLocks noChangeAspect="1"/>
-          </p:cNvPicPr>
-          <p:nvPr/>
-        </p:nvPicPr>
-        <p:blipFill>
-          <a:blip r:embed="rId2"/>
-          <a:stretch>
-            <a:fillRect/>
-          </a:stretch>
-        </p:blipFill>
-        <p:spPr>
-          <a:xfrm>
-            <a:off x="4178351" y="1417320"/>
-            <a:ext cx="4369918" cy="2468880"/>
-          </a:xfrm>
-          <a:prstGeom prst="rect">
-            <a:avLst/>
-          </a:prstGeom>
-        </p:spPr>
-      </p:pic>
-      <p:sp>
-        <p:nvSpPr>
-          <p:cNvPr id="6" name="Text 2"/>
+              <a:t>Из радио — в рилсы</a:t>
+            </a:r>
+            <a:endParaRPr lang="en-US" sz="3400" dirty="0"/>
+          </a:p>
+        </p:txBody>
+      </p:sp>
+      <p:sp>
+        <p:nvSpPr>
+          <p:cNvPr id="4" name="Shape 2"/>
+          <p:cNvSpPr/>
+          <p:nvPr/>
+        </p:nvSpPr>
+        <p:spPr>
+          <a:xfrm>
+            <a:off x="548640" y="1783080"/>
+            <a:ext cx="2468880" cy="2011680"/>
+          </a:xfrm>
+          <a:prstGeom prst="roundRect">
+            <a:avLst>
+              <a:gd name="adj" fmla="val 3636"/>
+            </a:avLst>
+          </a:prstGeom>
+          <a:solidFill>
+            <a:srgbClr val="15151D"/>
+          </a:solidFill>
+          <a:ln w="9525">
+            <a:solidFill>
+              <a:srgbClr val="2A2A36"/>
+            </a:solidFill>
+            <a:prstDash val="solid"/>
+          </a:ln>
+        </p:spPr>
+      </p:sp>
+      <p:sp>
+        <p:nvSpPr>
+          <p:cNvPr id="5" name="Text 3"/>
+          <p:cNvSpPr txBox="1"/>
+          <p:nvPr/>
+        </p:nvSpPr>
+        <p:spPr>
+          <a:xfrm>
+            <a:off x="822960" y="2011680"/>
+            <a:ext cx="914400" cy="365760"/>
+          </a:xfrm>
+          <a:prstGeom prst="rect">
+            <a:avLst/>
+          </a:prstGeom>
+          <a:noFill/>
+          <a:ln/>
+        </p:spPr>
+        <p:txBody>
+          <a:bodyPr wrap="square" lIns="0" tIns="0" rIns="0" bIns="0" rtlCol="0" anchor="ctr"/>
+          <a:lstStyle/>
+          <a:p>
+            <a:pPr indent="0" marL="0">
+              <a:buNone/>
+            </a:pPr>
+            <a:r>
+              <a:rPr lang="en-US" sz="2000" b="1" dirty="0">
+                <a:solidFill>
+                  <a:srgbClr val="8B7CF6"/>
+                </a:solidFill>
+                <a:latin typeface="Arial" pitchFamily="34" charset="0"/>
+                <a:ea typeface="Arial" pitchFamily="34" charset="-122"/>
+                <a:cs typeface="Arial" pitchFamily="34" charset="-120"/>
+              </a:rPr>
+              <a:t>01</a:t>
+            </a:r>
+            <a:endParaRPr lang="en-US" sz="2000" dirty="0"/>
+          </a:p>
+        </p:txBody>
+      </p:sp>
+      <p:sp>
+        <p:nvSpPr>
+          <p:cNvPr id="6" name="Text 4"/>
+          <p:cNvSpPr txBox="1"/>
+          <p:nvPr/>
+        </p:nvSpPr>
+        <p:spPr>
+          <a:xfrm>
+            <a:off x="822960" y="2651760"/>
+            <a:ext cx="1920240" cy="365760"/>
+          </a:xfrm>
+          <a:prstGeom prst="rect">
+            <a:avLst/>
+          </a:prstGeom>
+          <a:noFill/>
+          <a:ln/>
+        </p:spPr>
+        <p:txBody>
+          <a:bodyPr wrap="square" lIns="0" tIns="0" rIns="0" bIns="0" rtlCol="0" anchor="ctr"/>
+          <a:lstStyle/>
+          <a:p>
+            <a:pPr indent="0" marL="0">
+              <a:buNone/>
+            </a:pPr>
+            <a:r>
+              <a:rPr lang="en-US" sz="1900" b="1" dirty="0">
+                <a:solidFill>
+                  <a:srgbClr val="F4F4F6"/>
+                </a:solidFill>
+                <a:latin typeface="Arial" pitchFamily="34" charset="0"/>
+                <a:ea typeface="Arial" pitchFamily="34" charset="-122"/>
+                <a:cs typeface="Arial" pitchFamily="34" charset="-120"/>
+              </a:rPr>
+              <a:t>«Хавчик»</a:t>
+            </a:r>
+            <a:endParaRPr lang="en-US" sz="1900" dirty="0"/>
+          </a:p>
+        </p:txBody>
+      </p:sp>
+      <p:sp>
+        <p:nvSpPr>
+          <p:cNvPr id="7" name="Text 5"/>
+          <p:cNvSpPr txBox="1"/>
+          <p:nvPr/>
+        </p:nvSpPr>
+        <p:spPr>
+          <a:xfrm>
+            <a:off x="822960" y="3063240"/>
+            <a:ext cx="1920240" cy="548640"/>
+          </a:xfrm>
+          <a:prstGeom prst="rect">
+            <a:avLst/>
+          </a:prstGeom>
+          <a:noFill/>
+          <a:ln/>
+        </p:spPr>
+        <p:txBody>
+          <a:bodyPr wrap="square" lIns="0" tIns="0" rIns="0" bIns="0" rtlCol="0" anchor="t"/>
+          <a:lstStyle/>
+          <a:p>
+            <a:pPr indent="0" marL="0">
+              <a:buNone/>
+            </a:pPr>
+            <a:r>
+              <a:rPr lang="en-US" sz="1200" dirty="0">
+                <a:solidFill>
+                  <a:srgbClr val="8E8E9C"/>
+                </a:solidFill>
+                <a:latin typeface="Arial" pitchFamily="34" charset="0"/>
+                <a:ea typeface="Arial" pitchFamily="34" charset="-122"/>
+                <a:cs typeface="Arial" pitchFamily="34" charset="-120"/>
+              </a:rPr>
+              <a:t>С Тимати и Даней Милохиным</a:t>
+            </a:r>
+            <a:endParaRPr lang="en-US" sz="1200" dirty="0"/>
+          </a:p>
+        </p:txBody>
+      </p:sp>
+      <p:sp>
+        <p:nvSpPr>
+          <p:cNvPr id="8" name="Shape 6"/>
+          <p:cNvSpPr/>
+          <p:nvPr/>
+        </p:nvSpPr>
+        <p:spPr>
+          <a:xfrm>
+            <a:off x="3337560" y="1783080"/>
+            <a:ext cx="2468880" cy="2011680"/>
+          </a:xfrm>
+          <a:prstGeom prst="roundRect">
+            <a:avLst>
+              <a:gd name="adj" fmla="val 3636"/>
+            </a:avLst>
+          </a:prstGeom>
+          <a:solidFill>
+            <a:srgbClr val="15151D"/>
+          </a:solidFill>
+          <a:ln w="9525">
+            <a:solidFill>
+              <a:srgbClr val="2A2A36"/>
+            </a:solidFill>
+            <a:prstDash val="solid"/>
+          </a:ln>
+        </p:spPr>
+      </p:sp>
+      <p:sp>
+        <p:nvSpPr>
+          <p:cNvPr id="9" name="Text 7"/>
+          <p:cNvSpPr txBox="1"/>
+          <p:nvPr/>
+        </p:nvSpPr>
+        <p:spPr>
+          <a:xfrm>
+            <a:off x="3611880" y="2011680"/>
+            <a:ext cx="914400" cy="365760"/>
+          </a:xfrm>
+          <a:prstGeom prst="rect">
+            <a:avLst/>
+          </a:prstGeom>
+          <a:noFill/>
+          <a:ln/>
+        </p:spPr>
+        <p:txBody>
+          <a:bodyPr wrap="square" lIns="0" tIns="0" rIns="0" bIns="0" rtlCol="0" anchor="ctr"/>
+          <a:lstStyle/>
+          <a:p>
+            <a:pPr indent="0" marL="0">
+              <a:buNone/>
+            </a:pPr>
+            <a:r>
+              <a:rPr lang="en-US" sz="2000" b="1" dirty="0">
+                <a:solidFill>
+                  <a:srgbClr val="8B7CF6"/>
+                </a:solidFill>
+                <a:latin typeface="Arial" pitchFamily="34" charset="0"/>
+                <a:ea typeface="Arial" pitchFamily="34" charset="-122"/>
+                <a:cs typeface="Arial" pitchFamily="34" charset="-120"/>
+              </a:rPr>
+              <a:t>02</a:t>
+            </a:r>
+            <a:endParaRPr lang="en-US" sz="2000" dirty="0"/>
+          </a:p>
+        </p:txBody>
+      </p:sp>
+      <p:sp>
+        <p:nvSpPr>
+          <p:cNvPr id="10" name="Text 8"/>
+          <p:cNvSpPr txBox="1"/>
+          <p:nvPr/>
+        </p:nvSpPr>
+        <p:spPr>
+          <a:xfrm>
+            <a:off x="3611880" y="2651760"/>
+            <a:ext cx="1920240" cy="365760"/>
+          </a:xfrm>
+          <a:prstGeom prst="rect">
+            <a:avLst/>
+          </a:prstGeom>
+          <a:noFill/>
+          <a:ln/>
+        </p:spPr>
+        <p:txBody>
+          <a:bodyPr wrap="square" lIns="0" tIns="0" rIns="0" bIns="0" rtlCol="0" anchor="ctr"/>
+          <a:lstStyle/>
+          <a:p>
+            <a:pPr indent="0" marL="0">
+              <a:buNone/>
+            </a:pPr>
+            <a:r>
+              <a:rPr lang="en-US" sz="1900" b="1" dirty="0">
+                <a:solidFill>
+                  <a:srgbClr val="F4F4F6"/>
+                </a:solidFill>
+                <a:latin typeface="Arial" pitchFamily="34" charset="0"/>
+                <a:ea typeface="Arial" pitchFamily="34" charset="-122"/>
+                <a:cs typeface="Arial" pitchFamily="34" charset="-120"/>
+              </a:rPr>
+              <a:t>«На чиле»</a:t>
+            </a:r>
+            <a:endParaRPr lang="en-US" sz="1900" dirty="0"/>
+          </a:p>
+        </p:txBody>
+      </p:sp>
+      <p:sp>
+        <p:nvSpPr>
+          <p:cNvPr id="11" name="Text 9"/>
+          <p:cNvSpPr txBox="1"/>
+          <p:nvPr/>
+        </p:nvSpPr>
+        <p:spPr>
+          <a:xfrm>
+            <a:off x="3611880" y="3063240"/>
+            <a:ext cx="1920240" cy="548640"/>
+          </a:xfrm>
+          <a:prstGeom prst="rect">
+            <a:avLst/>
+          </a:prstGeom>
+          <a:noFill/>
+          <a:ln/>
+        </p:spPr>
+        <p:txBody>
+          <a:bodyPr wrap="square" lIns="0" tIns="0" rIns="0" bIns="0" rtlCol="0" anchor="t"/>
+          <a:lstStyle/>
+          <a:p>
+            <a:pPr indent="0" marL="0">
+              <a:buNone/>
+            </a:pPr>
+            <a:r>
+              <a:rPr lang="en-US" sz="1200" dirty="0">
+                <a:solidFill>
+                  <a:srgbClr val="8E8E9C"/>
+                </a:solidFill>
+                <a:latin typeface="Arial" pitchFamily="34" charset="0"/>
+                <a:ea typeface="Arial" pitchFamily="34" charset="-122"/>
+                <a:cs typeface="Arial" pitchFamily="34" charset="-120"/>
+              </a:rPr>
+              <a:t>Сайфер с половиной рэп-тусовки</a:t>
+            </a:r>
+            <a:endParaRPr lang="en-US" sz="1200" dirty="0"/>
+          </a:p>
+        </p:txBody>
+      </p:sp>
+      <p:sp>
+        <p:nvSpPr>
+          <p:cNvPr id="12" name="Shape 10"/>
+          <p:cNvSpPr/>
+          <p:nvPr/>
+        </p:nvSpPr>
+        <p:spPr>
+          <a:xfrm>
+            <a:off x="6126480" y="1783080"/>
+            <a:ext cx="2468880" cy="2011680"/>
+          </a:xfrm>
+          <a:prstGeom prst="roundRect">
+            <a:avLst>
+              <a:gd name="adj" fmla="val 3636"/>
+            </a:avLst>
+          </a:prstGeom>
+          <a:solidFill>
+            <a:srgbClr val="15151D"/>
+          </a:solidFill>
+          <a:ln w="9525">
+            <a:solidFill>
+              <a:srgbClr val="2A2A36"/>
+            </a:solidFill>
+            <a:prstDash val="solid"/>
+          </a:ln>
+        </p:spPr>
+      </p:sp>
+      <p:sp>
+        <p:nvSpPr>
+          <p:cNvPr id="13" name="Text 11"/>
+          <p:cNvSpPr txBox="1"/>
+          <p:nvPr/>
+        </p:nvSpPr>
+        <p:spPr>
+          <a:xfrm>
+            <a:off x="6400800" y="2011680"/>
+            <a:ext cx="914400" cy="365760"/>
+          </a:xfrm>
+          <a:prstGeom prst="rect">
+            <a:avLst/>
+          </a:prstGeom>
+          <a:noFill/>
+          <a:ln/>
+        </p:spPr>
+        <p:txBody>
+          <a:bodyPr wrap="square" lIns="0" tIns="0" rIns="0" bIns="0" rtlCol="0" anchor="ctr"/>
+          <a:lstStyle/>
+          <a:p>
+            <a:pPr indent="0" marL="0">
+              <a:buNone/>
+            </a:pPr>
+            <a:r>
+              <a:rPr lang="en-US" sz="2000" b="1" dirty="0">
+                <a:solidFill>
+                  <a:srgbClr val="8B7CF6"/>
+                </a:solidFill>
+                <a:latin typeface="Arial" pitchFamily="34" charset="0"/>
+                <a:ea typeface="Arial" pitchFamily="34" charset="-122"/>
+                <a:cs typeface="Arial" pitchFamily="34" charset="-120"/>
+              </a:rPr>
+              <a:t>03</a:t>
+            </a:r>
+            <a:endParaRPr lang="en-US" sz="2000" dirty="0"/>
+          </a:p>
+        </p:txBody>
+      </p:sp>
+      <p:sp>
+        <p:nvSpPr>
+          <p:cNvPr id="14" name="Text 12"/>
+          <p:cNvSpPr txBox="1"/>
+          <p:nvPr/>
+        </p:nvSpPr>
+        <p:spPr>
+          <a:xfrm>
+            <a:off x="6400800" y="2651760"/>
+            <a:ext cx="1920240" cy="365760"/>
+          </a:xfrm>
+          <a:prstGeom prst="rect">
+            <a:avLst/>
+          </a:prstGeom>
+          <a:noFill/>
+          <a:ln/>
+        </p:spPr>
+        <p:txBody>
+          <a:bodyPr wrap="square" lIns="0" tIns="0" rIns="0" bIns="0" rtlCol="0" anchor="ctr"/>
+          <a:lstStyle/>
+          <a:p>
+            <a:pPr indent="0" marL="0">
+              <a:buNone/>
+            </a:pPr>
+            <a:r>
+              <a:rPr lang="en-US" sz="1900" b="1" dirty="0">
+                <a:solidFill>
+                  <a:srgbClr val="F4F4F6"/>
+                </a:solidFill>
+                <a:latin typeface="Arial" pitchFamily="34" charset="0"/>
+                <a:ea typeface="Arial" pitchFamily="34" charset="-122"/>
+                <a:cs typeface="Arial" pitchFamily="34" charset="-120"/>
+              </a:rPr>
+              <a:t>«Bang»</a:t>
+            </a:r>
+            <a:endParaRPr lang="en-US" sz="1900" dirty="0"/>
+          </a:p>
+        </p:txBody>
+      </p:sp>
+      <p:sp>
+        <p:nvSpPr>
+          <p:cNvPr id="15" name="Text 13"/>
+          <p:cNvSpPr txBox="1"/>
+          <p:nvPr/>
+        </p:nvSpPr>
+        <p:spPr>
+          <a:xfrm>
+            <a:off x="6400800" y="3063240"/>
+            <a:ext cx="1920240" cy="548640"/>
+          </a:xfrm>
+          <a:prstGeom prst="rect">
+            <a:avLst/>
+          </a:prstGeom>
+          <a:noFill/>
+          <a:ln/>
+        </p:spPr>
+        <p:txBody>
+          <a:bodyPr wrap="square" lIns="0" tIns="0" rIns="0" bIns="0" rtlCol="0" anchor="t"/>
+          <a:lstStyle/>
+          <a:p>
+            <a:pPr indent="0" marL="0">
+              <a:buNone/>
+            </a:pPr>
+            <a:r>
+              <a:rPr lang="en-US" sz="1200" dirty="0">
+                <a:solidFill>
+                  <a:srgbClr val="8E8E9C"/>
+                </a:solidFill>
+                <a:latin typeface="Arial" pitchFamily="34" charset="0"/>
+                <a:ea typeface="Arial" pitchFamily="34" charset="-122"/>
+                <a:cs typeface="Arial" pitchFamily="34" charset="-120"/>
+              </a:rPr>
+              <a:t>Альбом с автотюновым трэпом</a:t>
+            </a:r>
+            <a:endParaRPr lang="en-US" sz="1200" dirty="0"/>
+          </a:p>
+        </p:txBody>
+      </p:sp>
+      <p:sp>
+        <p:nvSpPr>
+          <p:cNvPr id="16" name="Text 14"/>
           <p:cNvSpPr txBox="1"/>
           <p:nvPr/>
         </p:nvSpPr>
         <p:spPr>
           <a:xfrm>
             <a:off x="548640" y="4114800"/>
-            <a:ext cx="6858000" cy="320040"/>
-          </a:xfrm>
-          <a:prstGeom prst="rect">
-            <a:avLst/>
-          </a:prstGeom>
-          <a:noFill/>
-          <a:ln/>
-        </p:spPr>
-        <p:txBody>
-          <a:bodyPr wrap="square" lIns="0" tIns="0" rIns="0" bIns="0" rtlCol="0" anchor="ctr"/>
-          <a:lstStyle/>
-          <a:p>
-            <a:pPr indent="0" marL="0">
-              <a:buNone/>
-            </a:pPr>
-            <a:r>
-              <a:rPr lang="en-US" sz="1400" b="1" dirty="0">
+            <a:ext cx="5486400" cy="274320"/>
+          </a:xfrm>
+          <a:prstGeom prst="rect">
+            <a:avLst/>
+          </a:prstGeom>
+          <a:noFill/>
+          <a:ln/>
+        </p:spPr>
+        <p:txBody>
+          <a:bodyPr wrap="square" lIns="0" tIns="0" rIns="0" bIns="0" rtlCol="0" anchor="ctr"/>
+          <a:lstStyle/>
+          <a:p>
+            <a:pPr indent="0" marL="0">
+              <a:buNone/>
+            </a:pPr>
+            <a:r>
+              <a:rPr lang="en-US" sz="1300" b="1" dirty="0">
                 <a:solidFill>
                   <a:srgbClr val="8B7CF6"/>
                 </a:solidFill>
@@ -6045,68 +6793,15 @@
                 <a:ea typeface="Arial" pitchFamily="34" charset="-122"/>
                 <a:cs typeface="Arial" pitchFamily="34" charset="-120"/>
               </a:rPr>
-              <a:t>Мем → трек:  </a:t>
-            </a:r>
-            <a:pPr indent="0" marL="0">
-              <a:buNone/>
-            </a:pPr>
-            <a:r>
-              <a:rPr lang="en-US" sz="1400" b="1" dirty="0">
-                <a:solidFill>
-                  <a:srgbClr val="F4F4F6"/>
-                </a:solidFill>
-                <a:latin typeface="Arial" pitchFamily="34" charset="0"/>
-                <a:ea typeface="Arial" pitchFamily="34" charset="-122"/>
-                <a:cs typeface="Arial" pitchFamily="34" charset="-120"/>
-              </a:rPr>
-              <a:t>«Хавчик» · «На чиле» · альбом «Bang»</a:t>
-            </a:r>
-            <a:endParaRPr lang="en-US" sz="1400" dirty="0"/>
-          </a:p>
-        </p:txBody>
-      </p:sp>
-      <p:sp>
-        <p:nvSpPr>
-          <p:cNvPr id="7" name="Text 3"/>
-          <p:cNvSpPr txBox="1"/>
-          <p:nvPr/>
-        </p:nvSpPr>
-        <p:spPr>
-          <a:xfrm>
-            <a:off x="548640" y="4480560"/>
-            <a:ext cx="5486400" cy="228600"/>
-          </a:xfrm>
-          <a:prstGeom prst="rect">
-            <a:avLst/>
-          </a:prstGeom>
-          <a:noFill/>
-          <a:ln/>
-        </p:spPr>
-        <p:txBody>
-          <a:bodyPr wrap="square" lIns="0" tIns="0" rIns="0" bIns="0" rtlCol="0" anchor="ctr"/>
-          <a:lstStyle/>
-          <a:p>
-            <a:pPr indent="0" marL="0">
-              <a:buNone/>
-            </a:pPr>
-            <a:r>
-              <a:rPr lang="en-US" sz="800" dirty="0">
-                <a:solidFill>
-                  <a:srgbClr val="8E8E9C"/>
-                </a:solidFill>
-                <a:latin typeface="Arial" pitchFamily="34" charset="0"/>
-                <a:ea typeface="Arial" pitchFamily="34" charset="-122"/>
-                <a:cs typeface="Arial" pitchFamily="34" charset="-120"/>
-              </a:rPr>
-              <a:t>Мемы: пользователи соцсетей</a:t>
-            </a:r>
-            <a:endParaRPr lang="en-US" sz="800" dirty="0"/>
-          </a:p>
-        </p:txBody>
-      </p:sp>
-      <p:sp>
-        <p:nvSpPr>
-          <p:cNvPr id="8" name="Text 4"/>
+              <a:t>Вирусная фраза → трек → охваты</a:t>
+            </a:r>
+            <a:endParaRPr lang="en-US" sz="1300" dirty="0"/>
+          </a:p>
+        </p:txBody>
+      </p:sp>
+      <p:sp>
+        <p:nvSpPr>
+          <p:cNvPr id="17" name="Text 15"/>
           <p:cNvSpPr txBox="1"/>
           <p:nvPr/>
         </p:nvSpPr>
@@ -6137,7 +6832,7 @@
                 <a:ea typeface="Arial" pitchFamily="34" charset="-122"/>
                 <a:cs typeface="Arial" pitchFamily="34" charset="-120"/>
               </a:rPr>
-              <a:t>07 / 10</a:t>
+              <a:t>07 / 11</a:t>
             </a:r>
             <a:endParaRPr lang="en-US" sz="900" dirty="0"/>
           </a:p>
@@ -6754,7 +7449,7 @@
                 <a:ea typeface="Arial" pitchFamily="34" charset="-122"/>
                 <a:cs typeface="Arial" pitchFamily="34" charset="-120"/>
               </a:rPr>
-              <a:t>08 / 10</a:t>
+              <a:t>08 / 11</a:t>
             </a:r>
             <a:endParaRPr lang="en-US" sz="900" dirty="0"/>
           </a:p>
@@ -7367,7 +8062,7 @@
                 <a:ea typeface="Arial" pitchFamily="34" charset="-122"/>
                 <a:cs typeface="Arial" pitchFamily="34" charset="-120"/>
               </a:rPr>
-              <a:t>09 / 10</a:t>
+              <a:t>09 / 11</a:t>
             </a:r>
             <a:endParaRPr lang="en-US" sz="900" dirty="0"/>
           </a:p>

</xml_diff>